<commit_message>
Add Zotero connection checks and update setup guide
</commit_message>
<xml_diff>
--- a/instructor/slides/setup-guide.pptx
+++ b/instructor/slides/setup-guide.pptx
@@ -2,18 +2,20 @@
 <file path=ppt/presentation.xml><?xml version="1.0" encoding="utf-8"?>
 <p:presentation xmlns:p="http://schemas.openxmlformats.org/presentationml/2006/main">
   <p:sldMasterIdLst>
-    <p:sldMasterId xmlns:r="http://schemas.openxmlformats.org/officeDocument/2006/relationships" id="2147483648" r:id="Rd92f88dd4f554740"/>
+    <p:sldMasterId xmlns:r="http://schemas.openxmlformats.org/officeDocument/2006/relationships" id="2147483648" r:id="R67ea7e9663744c25"/>
   </p:sldMasterIdLst>
   <p:notesMasterIdLst>
-    <p:notesMasterId xmlns:r="http://schemas.openxmlformats.org/officeDocument/2006/relationships" r:id="R5accfbe3120b4a77"/>
+    <p:notesMasterId xmlns:r="http://schemas.openxmlformats.org/officeDocument/2006/relationships" r:id="Rc393efa7404046be"/>
   </p:notesMasterIdLst>
   <p:sldIdLst>
-    <p:sldId xmlns:r="http://schemas.openxmlformats.org/officeDocument/2006/relationships" id="256" r:id="R7b998f11f5d242c4"/>
-    <p:sldId xmlns:r="http://schemas.openxmlformats.org/officeDocument/2006/relationships" id="257" r:id="R508e3a23086749ea"/>
-    <p:sldId xmlns:r="http://schemas.openxmlformats.org/officeDocument/2006/relationships" id="258" r:id="Rea8a9a38604e406f"/>
-    <p:sldId xmlns:r="http://schemas.openxmlformats.org/officeDocument/2006/relationships" id="259" r:id="Rc92bdf28fdfa4a1f"/>
-    <p:sldId xmlns:r="http://schemas.openxmlformats.org/officeDocument/2006/relationships" id="260" r:id="Raf2a127f20624809"/>
-    <p:sldId xmlns:r="http://schemas.openxmlformats.org/officeDocument/2006/relationships" id="261" r:id="R1c8b6adeec8e4ea3"/>
+    <p:sldId xmlns:r="http://schemas.openxmlformats.org/officeDocument/2006/relationships" id="256" r:id="Re75a54cff5b146ec"/>
+    <p:sldId xmlns:r="http://schemas.openxmlformats.org/officeDocument/2006/relationships" id="257" r:id="R0473a9edafba4b99"/>
+    <p:sldId xmlns:r="http://schemas.openxmlformats.org/officeDocument/2006/relationships" id="258" r:id="R8ca9eada82d041f1"/>
+    <p:sldId xmlns:r="http://schemas.openxmlformats.org/officeDocument/2006/relationships" id="259" r:id="Re05ba07ed5f441b7"/>
+    <p:sldId xmlns:r="http://schemas.openxmlformats.org/officeDocument/2006/relationships" id="260" r:id="R72054d61978e4e9c"/>
+    <p:sldId xmlns:r="http://schemas.openxmlformats.org/officeDocument/2006/relationships" id="261" r:id="R6996b0afb4754c6d"/>
+    <p:sldId xmlns:r="http://schemas.openxmlformats.org/officeDocument/2006/relationships" id="262" r:id="Rcc2d807de4c64ad1"/>
+    <p:sldId xmlns:r="http://schemas.openxmlformats.org/officeDocument/2006/relationships" id="263" r:id="R700d676d0a624860"/>
   </p:sldIdLst>
   <p:sldSz cx="12192000" cy="6858000"/>
   <p:notesSz cx="6858000" cy="9144000"/>
@@ -797,7 +799,147 @@
           <a:lstStyle xmlns:a="http://schemas.openxmlformats.org/drawingml/2006/main"/>
           <a:p xmlns:a="http://schemas.openxmlformats.org/drawingml/2006/main">
             <a:r>
+              <a:t>Screenshot supplied by the instructor: Screenshot 2026-09-28 at 18.00.10.png. Source: https://www.zotero.org/support/dev/web_api/v3/local_api. The original screenshot is preserved; the SVG adds red outlines and crops unrelated settings.</a:t>
+            </a:r>
+          </a:p>
+        </p:txBody>
+      </p:sp>
+      <p:sp>
+        <p:nvSpPr>
+          <p:cNvPr id="4" name="Slide Number Placeholder 3"/>
+          <p:cNvSpPr>
+            <a:spLocks xmlns:a="http://schemas.openxmlformats.org/drawingml/2006/main" noGrp="1"/>
+          </p:cNvSpPr>
+          <p:nvPr>
+            <p:ph type="sldNum" idx="5"/>
+          </p:nvPr>
+        </p:nvSpPr>
+        <p:spPr/>
+        <p:txBody>
+          <a:bodyPr xmlns:a="http://schemas.openxmlformats.org/drawingml/2006/main"/>
+          <a:lstStyle xmlns:a="http://schemas.openxmlformats.org/drawingml/2006/main"/>
+          <a:p xmlns:a="http://schemas.openxmlformats.org/drawingml/2006/main"/>
+        </p:txBody>
+      </p:sp>
+    </p:spTree>
+  </p:cSld>
+  <p:clrMapOvr>
+    <a:masterClrMapping xmlns:a="http://schemas.openxmlformats.org/drawingml/2006/main"/>
+  </p:clrMapOvr>
+</p:notes>
+</file>
+
+<file path=ppt/notesSlides/notesSlide7.xml><?xml version="1.0" encoding="utf-8"?>
+<p:notes xmlns:p="http://schemas.openxmlformats.org/presentationml/2006/main">
+  <p:cSld>
+    <p:spTree>
+      <p:nvGrpSpPr>
+        <p:cNvPr id="1" name=""/>
+        <p:cNvGrpSpPr/>
+        <p:nvPr/>
+      </p:nvGrpSpPr>
+      <p:grpSpPr>
+        <a:xfrm xmlns:a="http://schemas.openxmlformats.org/drawingml/2006/main"/>
+      </p:grpSpPr>
+      <p:sp>
+        <p:nvSpPr>
+          <p:cNvPr id="2" name="Slide Image Placeholder 1"/>
+          <p:cNvSpPr>
+            <a:spLocks xmlns:a="http://schemas.openxmlformats.org/drawingml/2006/main" noGrp="1"/>
+          </p:cNvSpPr>
+          <p:nvPr>
+            <p:ph type="sldImg" idx="0"/>
+          </p:nvPr>
+        </p:nvSpPr>
+        <p:spPr/>
+      </p:sp>
+      <p:sp>
+        <p:nvSpPr>
+          <p:cNvPr id="3" name="Notes Placeholder 2"/>
+          <p:cNvSpPr>
+            <a:spLocks xmlns:a="http://schemas.openxmlformats.org/drawingml/2006/main" noGrp="1"/>
+          </p:cNvSpPr>
+          <p:nvPr>
+            <p:ph type="body" idx="1"/>
+          </p:nvPr>
+        </p:nvSpPr>
+        <p:spPr/>
+        <p:txBody>
+          <a:bodyPr xmlns:a="http://schemas.openxmlformats.org/drawingml/2006/main"/>
+          <a:lstStyle xmlns:a="http://schemas.openxmlformats.org/drawingml/2006/main"/>
+          <a:p xmlns:a="http://schemas.openxmlformats.org/drawingml/2006/main">
+            <a:r>
               <a:t>Source: workshop/00-start-here.md. Repository: https://github.com/Alias-z/agentic-researcher-psc</a:t>
+            </a:r>
+          </a:p>
+        </p:txBody>
+      </p:sp>
+      <p:sp>
+        <p:nvSpPr>
+          <p:cNvPr id="4" name="Slide Number Placeholder 3"/>
+          <p:cNvSpPr>
+            <a:spLocks xmlns:a="http://schemas.openxmlformats.org/drawingml/2006/main" noGrp="1"/>
+          </p:cNvSpPr>
+          <p:nvPr>
+            <p:ph type="sldNum" idx="5"/>
+          </p:nvPr>
+        </p:nvSpPr>
+        <p:spPr/>
+        <p:txBody>
+          <a:bodyPr xmlns:a="http://schemas.openxmlformats.org/drawingml/2006/main"/>
+          <a:lstStyle xmlns:a="http://schemas.openxmlformats.org/drawingml/2006/main"/>
+          <a:p xmlns:a="http://schemas.openxmlformats.org/drawingml/2006/main"/>
+        </p:txBody>
+      </p:sp>
+    </p:spTree>
+  </p:cSld>
+  <p:clrMapOvr>
+    <a:masterClrMapping xmlns:a="http://schemas.openxmlformats.org/drawingml/2006/main"/>
+  </p:clrMapOvr>
+</p:notes>
+</file>
+
+<file path=ppt/notesSlides/notesSlide8.xml><?xml version="1.0" encoding="utf-8"?>
+<p:notes xmlns:p="http://schemas.openxmlformats.org/presentationml/2006/main">
+  <p:cSld>
+    <p:spTree>
+      <p:nvGrpSpPr>
+        <p:cNvPr id="1" name=""/>
+        <p:cNvGrpSpPr/>
+        <p:nvPr/>
+      </p:nvGrpSpPr>
+      <p:grpSpPr>
+        <a:xfrm xmlns:a="http://schemas.openxmlformats.org/drawingml/2006/main"/>
+      </p:grpSpPr>
+      <p:sp>
+        <p:nvSpPr>
+          <p:cNvPr id="2" name="Slide Image Placeholder 1"/>
+          <p:cNvSpPr>
+            <a:spLocks xmlns:a="http://schemas.openxmlformats.org/drawingml/2006/main" noGrp="1"/>
+          </p:cNvSpPr>
+          <p:nvPr>
+            <p:ph type="sldImg" idx="0"/>
+          </p:nvPr>
+        </p:nvSpPr>
+        <p:spPr/>
+      </p:sp>
+      <p:sp>
+        <p:nvSpPr>
+          <p:cNvPr id="3" name="Notes Placeholder 2"/>
+          <p:cNvSpPr>
+            <a:spLocks xmlns:a="http://schemas.openxmlformats.org/drawingml/2006/main" noGrp="1"/>
+          </p:cNvSpPr>
+          <p:nvPr>
+            <p:ph type="body" idx="1"/>
+          </p:nvPr>
+        </p:nvSpPr>
+        <p:spPr/>
+        <p:txBody>
+          <a:bodyPr xmlns:a="http://schemas.openxmlformats.org/drawingml/2006/main"/>
+          <a:lstStyle xmlns:a="http://schemas.openxmlformats.org/drawingml/2006/main"/>
+          <a:p xmlns:a="http://schemas.openxmlformats.org/drawingml/2006/main">
+            <a:r>
+              <a:t>Screenshot supplied by the instructor: Screenshot 2026-09-28 at 19.08.39.png. Plugin installation: https://learn.chatgpt.com/docs/plugins. Reading and citation capabilities were checked against the installed Zotero 0.1.2 skill and helper. The plugin reads indexed attachment text; it does not replace our publisher Connector/PDF save workflow. The original screenshot is preserved; the SVG adds red outlines and crops the recent chat list.</a:t>
             </a:r>
           </a:p>
         </p:txBody>
@@ -830,6 +972,1716 @@
 <file path=ppt/slideLayouts/slideLayout1.xml><?xml version="1.0" encoding="utf-8"?>
 <p:sldLayout xmlns:p="http://schemas.openxmlformats.org/presentationml/2006/main" type="title">
   <p:cSld name="Title Slide">
+    <p:spTree>
+      <p:nvGrpSpPr>
+        <p:cNvPr id="1" name=""/>
+        <p:cNvGrpSpPr/>
+        <p:nvPr/>
+      </p:nvGrpSpPr>
+      <p:grpSpPr>
+        <a:xfrm xmlns:a="http://schemas.openxmlformats.org/drawingml/2006/main"/>
+      </p:grpSpPr>
+      <p:sp>
+        <p:nvSpPr>
+          <p:cNvPr id="4" name="Accent rule">
+            <a:extLst xmlns:a="http://schemas.openxmlformats.org/drawingml/2006/main">
+              <a:ext uri="{FF2B5EF4-FFF2-40B4-BE49-F238E27FC236}">
+                <a16:creationId xmlns:a16="http://schemas.microsoft.com/office/drawing/2014/main" id="{B82C36B7-AF5C-4A9B-9C3A-6DEEFD765C32}"/>
+              </a:ext>
+            </a:extLst>
+          </p:cNvPr>
+          <p:cNvSpPr>
+            <a:spLocks xmlns:a="http://schemas.openxmlformats.org/drawingml/2006/main" noGrp="1"/>
+          </p:cNvSpPr>
+          <p:nvPr/>
+        </p:nvSpPr>
+        <p:spPr>
+          <a:xfrm xmlns:a="http://schemas.openxmlformats.org/drawingml/2006/main">
+            <a:off x="5791200" y="2209800"/>
+            <a:ext cx="609600" cy="38100"/>
+          </a:xfrm>
+          <a:prstGeom xmlns:a="http://schemas.openxmlformats.org/drawingml/2006/main" prst="rect">
+            <a:avLst/>
+          </a:prstGeom>
+          <a:solidFill xmlns:a="http://schemas.openxmlformats.org/drawingml/2006/main">
+            <a:schemeClr val="accent1"/>
+          </a:solidFill>
+          <a:ln xmlns:a="http://schemas.openxmlformats.org/drawingml/2006/main">
+            <a:noFill/>
+            <a:prstDash val="solid"/>
+          </a:ln>
+        </p:spPr>
+      </p:sp>
+      <p:sp>
+        <p:nvSpPr>
+          <p:cNvPr id="2" name="Title">
+            <a:extLst xmlns:a="http://schemas.openxmlformats.org/drawingml/2006/main">
+              <a:ext uri="{FF2B5EF4-FFF2-40B4-BE49-F238E27FC236}">
+                <a16:creationId xmlns:a16="http://schemas.microsoft.com/office/drawing/2014/main" id="{2B7D8A81-8970-43C4-A0A9-85F335AB6370}"/>
+              </a:ext>
+            </a:extLst>
+          </p:cNvPr>
+          <p:cNvSpPr>
+            <a:spLocks xmlns:a="http://schemas.openxmlformats.org/drawingml/2006/main" noGrp="1"/>
+          </p:cNvSpPr>
+          <p:nvPr>
+            <p:ph type="title" idx="0"/>
+          </p:nvPr>
+        </p:nvSpPr>
+        <p:spPr>
+          <a:xfrm xmlns:a="http://schemas.openxmlformats.org/drawingml/2006/main">
+            <a:off x="1219200" y="2590800"/>
+            <a:ext cx="9753600" cy="990600"/>
+          </a:xfrm>
+          <a:prstGeom xmlns:a="http://schemas.openxmlformats.org/drawingml/2006/main" prst="rect">
+            <a:avLst/>
+          </a:prstGeom>
+          <a:noFill xmlns:a="http://schemas.openxmlformats.org/drawingml/2006/main"/>
+          <a:ln xmlns:a="http://schemas.openxmlformats.org/drawingml/2006/main">
+            <a:noFill/>
+            <a:prstDash val="solid"/>
+          </a:ln>
+        </p:spPr>
+        <p:txBody>
+          <a:bodyPr xmlns:a="http://schemas.openxmlformats.org/drawingml/2006/main" wrap="square" lIns="0" tIns="0" rIns="0" bIns="0" anchor="ctr">
+            <a:normAutofit/>
+          </a:bodyPr>
+          <a:lstStyle xmlns:a="http://schemas.openxmlformats.org/drawingml/2006/main">
+            <a:lvl1pPr marL="0" indent="0">
+              <a:lnSpc>
+                <a:spcPct val="110000"/>
+              </a:lnSpc>
+              <a:spcBef>
+                <a:spcPts val="0"/>
+              </a:spcBef>
+              <a:spcAft>
+                <a:spcPts val="0"/>
+              </a:spcAft>
+              <a:buNone/>
+            </a:lvl1pPr>
+            <a:lvl2pPr marL="0" indent="0">
+              <a:lnSpc>
+                <a:spcPct val="110000"/>
+              </a:lnSpc>
+              <a:spcBef>
+                <a:spcPts val="0"/>
+              </a:spcBef>
+              <a:spcAft>
+                <a:spcPts val="0"/>
+              </a:spcAft>
+              <a:buNone/>
+            </a:lvl2pPr>
+            <a:lvl3pPr marL="0" indent="0">
+              <a:lnSpc>
+                <a:spcPct val="110000"/>
+              </a:lnSpc>
+              <a:spcBef>
+                <a:spcPts val="0"/>
+              </a:spcBef>
+              <a:spcAft>
+                <a:spcPts val="0"/>
+              </a:spcAft>
+              <a:buNone/>
+            </a:lvl3pPr>
+            <a:lvl4pPr marL="0" indent="0">
+              <a:lnSpc>
+                <a:spcPct val="110000"/>
+              </a:lnSpc>
+              <a:spcBef>
+                <a:spcPts val="0"/>
+              </a:spcBef>
+              <a:spcAft>
+                <a:spcPts val="0"/>
+              </a:spcAft>
+              <a:buNone/>
+            </a:lvl4pPr>
+            <a:lvl5pPr marL="0" indent="0">
+              <a:lnSpc>
+                <a:spcPct val="110000"/>
+              </a:lnSpc>
+              <a:spcBef>
+                <a:spcPts val="0"/>
+              </a:spcBef>
+              <a:spcAft>
+                <a:spcPts val="0"/>
+              </a:spcAft>
+              <a:buNone/>
+            </a:lvl5pPr>
+            <a:lvl6pPr marL="0" indent="0">
+              <a:lnSpc>
+                <a:spcPct val="110000"/>
+              </a:lnSpc>
+              <a:spcBef>
+                <a:spcPts val="0"/>
+              </a:spcBef>
+              <a:spcAft>
+                <a:spcPts val="0"/>
+              </a:spcAft>
+              <a:buNone/>
+            </a:lvl6pPr>
+            <a:lvl7pPr marL="0" indent="0">
+              <a:lnSpc>
+                <a:spcPct val="110000"/>
+              </a:lnSpc>
+              <a:spcBef>
+                <a:spcPts val="0"/>
+              </a:spcBef>
+              <a:spcAft>
+                <a:spcPts val="0"/>
+              </a:spcAft>
+              <a:buNone/>
+            </a:lvl7pPr>
+            <a:lvl8pPr marL="0" indent="0">
+              <a:lnSpc>
+                <a:spcPct val="110000"/>
+              </a:lnSpc>
+              <a:spcBef>
+                <a:spcPts val="0"/>
+              </a:spcBef>
+              <a:spcAft>
+                <a:spcPts val="0"/>
+              </a:spcAft>
+              <a:buNone/>
+            </a:lvl8pPr>
+            <a:lvl9pPr marL="0" indent="0">
+              <a:lnSpc>
+                <a:spcPct val="110000"/>
+              </a:lnSpc>
+              <a:spcBef>
+                <a:spcPts val="0"/>
+              </a:spcBef>
+              <a:spcAft>
+                <a:spcPts val="0"/>
+              </a:spcAft>
+              <a:buNone/>
+            </a:lvl9pPr>
+          </a:lstStyle>
+          <a:p xmlns:a="http://schemas.openxmlformats.org/drawingml/2006/main"/>
+        </p:txBody>
+      </p:sp>
+      <p:sp>
+        <p:nvSpPr>
+          <p:cNvPr id="3" name="Subtitle">
+            <a:extLst xmlns:a="http://schemas.openxmlformats.org/drawingml/2006/main">
+              <a:ext uri="{FF2B5EF4-FFF2-40B4-BE49-F238E27FC236}">
+                <a16:creationId xmlns:a16="http://schemas.microsoft.com/office/drawing/2014/main" id="{03FC80FC-D146-4EF2-A33B-547AF8148035}"/>
+              </a:ext>
+            </a:extLst>
+          </p:cNvPr>
+          <p:cNvSpPr>
+            <a:spLocks xmlns:a="http://schemas.openxmlformats.org/drawingml/2006/main" noGrp="1"/>
+          </p:cNvSpPr>
+          <p:nvPr>
+            <p:ph type="subTitle" idx="1"/>
+          </p:nvPr>
+        </p:nvSpPr>
+        <p:spPr>
+          <a:xfrm xmlns:a="http://schemas.openxmlformats.org/drawingml/2006/main">
+            <a:off x="1828800" y="3771900"/>
+            <a:ext cx="8534400" cy="762000"/>
+          </a:xfrm>
+          <a:prstGeom xmlns:a="http://schemas.openxmlformats.org/drawingml/2006/main" prst="rect">
+            <a:avLst/>
+          </a:prstGeom>
+          <a:noFill xmlns:a="http://schemas.openxmlformats.org/drawingml/2006/main"/>
+          <a:ln xmlns:a="http://schemas.openxmlformats.org/drawingml/2006/main">
+            <a:noFill/>
+            <a:prstDash val="solid"/>
+          </a:ln>
+        </p:spPr>
+        <p:txBody>
+          <a:bodyPr xmlns:a="http://schemas.openxmlformats.org/drawingml/2006/main" wrap="square" lIns="0" tIns="0" rIns="0" bIns="0" anchor="ctr">
+            <a:normAutofit/>
+          </a:bodyPr>
+          <a:lstStyle xmlns:a="http://schemas.openxmlformats.org/drawingml/2006/main">
+            <a:lvl1pPr marL="0" indent="0">
+              <a:lnSpc>
+                <a:spcPct val="110000"/>
+              </a:lnSpc>
+              <a:spcBef>
+                <a:spcPts val="0"/>
+              </a:spcBef>
+              <a:spcAft>
+                <a:spcPts val="0"/>
+              </a:spcAft>
+              <a:buNone/>
+            </a:lvl1pPr>
+            <a:lvl2pPr marL="0" indent="0">
+              <a:lnSpc>
+                <a:spcPct val="110000"/>
+              </a:lnSpc>
+              <a:spcBef>
+                <a:spcPts val="0"/>
+              </a:spcBef>
+              <a:spcAft>
+                <a:spcPts val="0"/>
+              </a:spcAft>
+              <a:buNone/>
+            </a:lvl2pPr>
+            <a:lvl3pPr marL="0" indent="0">
+              <a:lnSpc>
+                <a:spcPct val="110000"/>
+              </a:lnSpc>
+              <a:spcBef>
+                <a:spcPts val="0"/>
+              </a:spcBef>
+              <a:spcAft>
+                <a:spcPts val="0"/>
+              </a:spcAft>
+              <a:buNone/>
+            </a:lvl3pPr>
+            <a:lvl4pPr marL="0" indent="0">
+              <a:lnSpc>
+                <a:spcPct val="110000"/>
+              </a:lnSpc>
+              <a:spcBef>
+                <a:spcPts val="0"/>
+              </a:spcBef>
+              <a:spcAft>
+                <a:spcPts val="0"/>
+              </a:spcAft>
+              <a:buNone/>
+            </a:lvl4pPr>
+            <a:lvl5pPr marL="0" indent="0">
+              <a:lnSpc>
+                <a:spcPct val="110000"/>
+              </a:lnSpc>
+              <a:spcBef>
+                <a:spcPts val="0"/>
+              </a:spcBef>
+              <a:spcAft>
+                <a:spcPts val="0"/>
+              </a:spcAft>
+              <a:buNone/>
+            </a:lvl5pPr>
+            <a:lvl6pPr marL="0" indent="0">
+              <a:lnSpc>
+                <a:spcPct val="110000"/>
+              </a:lnSpc>
+              <a:spcBef>
+                <a:spcPts val="0"/>
+              </a:spcBef>
+              <a:spcAft>
+                <a:spcPts val="0"/>
+              </a:spcAft>
+              <a:buNone/>
+            </a:lvl6pPr>
+            <a:lvl7pPr marL="0" indent="0">
+              <a:lnSpc>
+                <a:spcPct val="110000"/>
+              </a:lnSpc>
+              <a:spcBef>
+                <a:spcPts val="0"/>
+              </a:spcBef>
+              <a:spcAft>
+                <a:spcPts val="0"/>
+              </a:spcAft>
+              <a:buNone/>
+            </a:lvl7pPr>
+            <a:lvl8pPr marL="0" indent="0">
+              <a:lnSpc>
+                <a:spcPct val="110000"/>
+              </a:lnSpc>
+              <a:spcBef>
+                <a:spcPts val="0"/>
+              </a:spcBef>
+              <a:spcAft>
+                <a:spcPts val="0"/>
+              </a:spcAft>
+              <a:buNone/>
+            </a:lvl8pPr>
+            <a:lvl9pPr marL="0" indent="0">
+              <a:lnSpc>
+                <a:spcPct val="110000"/>
+              </a:lnSpc>
+              <a:spcBef>
+                <a:spcPts val="0"/>
+              </a:spcBef>
+              <a:spcAft>
+                <a:spcPts val="0"/>
+              </a:spcAft>
+              <a:buNone/>
+            </a:lvl9pPr>
+          </a:lstStyle>
+          <a:p xmlns:a="http://schemas.openxmlformats.org/drawingml/2006/main"/>
+        </p:txBody>
+      </p:sp>
+    </p:spTree>
+  </p:cSld>
+</p:sldLayout>
+</file>
+
+<file path=ppt/slideLayouts/slideLayout2.xml><?xml version="1.0" encoding="utf-8"?>
+<p:sldLayout xmlns:p="http://schemas.openxmlformats.org/presentationml/2006/main">
+  <p:cSld name="Section Header">
+    <p:spTree>
+      <p:nvGrpSpPr>
+        <p:cNvPr id="1" name=""/>
+        <p:cNvGrpSpPr/>
+        <p:nvPr/>
+      </p:nvGrpSpPr>
+      <p:grpSpPr>
+        <a:xfrm xmlns:a="http://schemas.openxmlformats.org/drawingml/2006/main"/>
+      </p:grpSpPr>
+      <p:sp>
+        <p:nvSpPr>
+          <p:cNvPr id="3" name="Accent rule">
+            <a:extLst xmlns:a="http://schemas.openxmlformats.org/drawingml/2006/main">
+              <a:ext uri="{FF2B5EF4-FFF2-40B4-BE49-F238E27FC236}">
+                <a16:creationId xmlns:a16="http://schemas.microsoft.com/office/drawing/2014/main" id="{168B1544-AA7C-4EA0-A9D9-978C8EC910C1}"/>
+              </a:ext>
+            </a:extLst>
+          </p:cNvPr>
+          <p:cNvSpPr>
+            <a:spLocks xmlns:a="http://schemas.openxmlformats.org/drawingml/2006/main" noGrp="1"/>
+          </p:cNvSpPr>
+          <p:nvPr/>
+        </p:nvSpPr>
+        <p:spPr>
+          <a:xfrm xmlns:a="http://schemas.openxmlformats.org/drawingml/2006/main">
+            <a:off x="5791200" y="2476500"/>
+            <a:ext cx="609600" cy="38100"/>
+          </a:xfrm>
+          <a:prstGeom xmlns:a="http://schemas.openxmlformats.org/drawingml/2006/main" prst="rect">
+            <a:avLst/>
+          </a:prstGeom>
+          <a:solidFill xmlns:a="http://schemas.openxmlformats.org/drawingml/2006/main">
+            <a:schemeClr val="accent1"/>
+          </a:solidFill>
+          <a:ln xmlns:a="http://schemas.openxmlformats.org/drawingml/2006/main">
+            <a:noFill/>
+            <a:prstDash val="solid"/>
+          </a:ln>
+        </p:spPr>
+      </p:sp>
+      <p:sp>
+        <p:nvSpPr>
+          <p:cNvPr id="2" name="Section title">
+            <a:extLst xmlns:a="http://schemas.openxmlformats.org/drawingml/2006/main">
+              <a:ext uri="{FF2B5EF4-FFF2-40B4-BE49-F238E27FC236}">
+                <a16:creationId xmlns:a16="http://schemas.microsoft.com/office/drawing/2014/main" id="{321E2848-676D-4DF0-88F1-2446A341735D}"/>
+              </a:ext>
+            </a:extLst>
+          </p:cNvPr>
+          <p:cNvSpPr>
+            <a:spLocks xmlns:a="http://schemas.openxmlformats.org/drawingml/2006/main" noGrp="1"/>
+          </p:cNvSpPr>
+          <p:nvPr>
+            <p:ph type="title" idx="0"/>
+          </p:nvPr>
+        </p:nvSpPr>
+        <p:spPr>
+          <a:xfrm xmlns:a="http://schemas.openxmlformats.org/drawingml/2006/main">
+            <a:off x="1219200" y="2857500"/>
+            <a:ext cx="9753600" cy="1143000"/>
+          </a:xfrm>
+          <a:prstGeom xmlns:a="http://schemas.openxmlformats.org/drawingml/2006/main" prst="rect">
+            <a:avLst/>
+          </a:prstGeom>
+          <a:noFill xmlns:a="http://schemas.openxmlformats.org/drawingml/2006/main"/>
+          <a:ln xmlns:a="http://schemas.openxmlformats.org/drawingml/2006/main">
+            <a:noFill/>
+            <a:prstDash val="solid"/>
+          </a:ln>
+        </p:spPr>
+        <p:txBody>
+          <a:bodyPr xmlns:a="http://schemas.openxmlformats.org/drawingml/2006/main" wrap="square" lIns="0" tIns="0" rIns="0" bIns="0" anchor="ctr">
+            <a:normAutofit/>
+          </a:bodyPr>
+          <a:lstStyle xmlns:a="http://schemas.openxmlformats.org/drawingml/2006/main">
+            <a:lvl1pPr marL="0" indent="0">
+              <a:lnSpc>
+                <a:spcPct val="110000"/>
+              </a:lnSpc>
+              <a:spcBef>
+                <a:spcPts val="0"/>
+              </a:spcBef>
+              <a:spcAft>
+                <a:spcPts val="0"/>
+              </a:spcAft>
+              <a:buNone/>
+            </a:lvl1pPr>
+            <a:lvl2pPr marL="0" indent="0">
+              <a:lnSpc>
+                <a:spcPct val="110000"/>
+              </a:lnSpc>
+              <a:spcBef>
+                <a:spcPts val="0"/>
+              </a:spcBef>
+              <a:spcAft>
+                <a:spcPts val="0"/>
+              </a:spcAft>
+              <a:buNone/>
+            </a:lvl2pPr>
+            <a:lvl3pPr marL="0" indent="0">
+              <a:lnSpc>
+                <a:spcPct val="110000"/>
+              </a:lnSpc>
+              <a:spcBef>
+                <a:spcPts val="0"/>
+              </a:spcBef>
+              <a:spcAft>
+                <a:spcPts val="0"/>
+              </a:spcAft>
+              <a:buNone/>
+            </a:lvl3pPr>
+            <a:lvl4pPr marL="0" indent="0">
+              <a:lnSpc>
+                <a:spcPct val="110000"/>
+              </a:lnSpc>
+              <a:spcBef>
+                <a:spcPts val="0"/>
+              </a:spcBef>
+              <a:spcAft>
+                <a:spcPts val="0"/>
+              </a:spcAft>
+              <a:buNone/>
+            </a:lvl4pPr>
+            <a:lvl5pPr marL="0" indent="0">
+              <a:lnSpc>
+                <a:spcPct val="110000"/>
+              </a:lnSpc>
+              <a:spcBef>
+                <a:spcPts val="0"/>
+              </a:spcBef>
+              <a:spcAft>
+                <a:spcPts val="0"/>
+              </a:spcAft>
+              <a:buNone/>
+            </a:lvl5pPr>
+            <a:lvl6pPr marL="0" indent="0">
+              <a:lnSpc>
+                <a:spcPct val="110000"/>
+              </a:lnSpc>
+              <a:spcBef>
+                <a:spcPts val="0"/>
+              </a:spcBef>
+              <a:spcAft>
+                <a:spcPts val="0"/>
+              </a:spcAft>
+              <a:buNone/>
+            </a:lvl6pPr>
+            <a:lvl7pPr marL="0" indent="0">
+              <a:lnSpc>
+                <a:spcPct val="110000"/>
+              </a:lnSpc>
+              <a:spcBef>
+                <a:spcPts val="0"/>
+              </a:spcBef>
+              <a:spcAft>
+                <a:spcPts val="0"/>
+              </a:spcAft>
+              <a:buNone/>
+            </a:lvl7pPr>
+            <a:lvl8pPr marL="0" indent="0">
+              <a:lnSpc>
+                <a:spcPct val="110000"/>
+              </a:lnSpc>
+              <a:spcBef>
+                <a:spcPts val="0"/>
+              </a:spcBef>
+              <a:spcAft>
+                <a:spcPts val="0"/>
+              </a:spcAft>
+              <a:buNone/>
+            </a:lvl8pPr>
+            <a:lvl9pPr marL="0" indent="0">
+              <a:lnSpc>
+                <a:spcPct val="110000"/>
+              </a:lnSpc>
+              <a:spcBef>
+                <a:spcPts val="0"/>
+              </a:spcBef>
+              <a:spcAft>
+                <a:spcPts val="0"/>
+              </a:spcAft>
+              <a:buNone/>
+            </a:lvl9pPr>
+          </a:lstStyle>
+          <a:p xmlns:a="http://schemas.openxmlformats.org/drawingml/2006/main"/>
+        </p:txBody>
+      </p:sp>
+    </p:spTree>
+  </p:cSld>
+</p:sldLayout>
+</file>
+
+<file path=ppt/slideLayouts/slideLayout3.xml><?xml version="1.0" encoding="utf-8"?>
+<p:sldLayout xmlns:p="http://schemas.openxmlformats.org/presentationml/2006/main">
+  <p:cSld name="Title and Body">
+    <p:spTree>
+      <p:nvGrpSpPr>
+        <p:cNvPr id="1" name=""/>
+        <p:cNvGrpSpPr/>
+        <p:nvPr/>
+      </p:nvGrpSpPr>
+      <p:grpSpPr>
+        <a:xfrm xmlns:a="http://schemas.openxmlformats.org/drawingml/2006/main"/>
+      </p:grpSpPr>
+      <p:sp>
+        <p:nvSpPr>
+          <p:cNvPr id="4" name="Accent rule">
+            <a:extLst xmlns:a="http://schemas.openxmlformats.org/drawingml/2006/main">
+              <a:ext uri="{FF2B5EF4-FFF2-40B4-BE49-F238E27FC236}">
+                <a16:creationId xmlns:a16="http://schemas.microsoft.com/office/drawing/2014/main" id="{F23C18A9-19A0-4D7F-8DC5-A520FE3172B0}"/>
+              </a:ext>
+            </a:extLst>
+          </p:cNvPr>
+          <p:cNvSpPr>
+            <a:spLocks xmlns:a="http://schemas.openxmlformats.org/drawingml/2006/main" noGrp="1"/>
+          </p:cNvSpPr>
+          <p:nvPr/>
+        </p:nvSpPr>
+        <p:spPr>
+          <a:xfrm xmlns:a="http://schemas.openxmlformats.org/drawingml/2006/main">
+            <a:off x="685800" y="1524000"/>
+            <a:ext cx="609600" cy="38100"/>
+          </a:xfrm>
+          <a:prstGeom xmlns:a="http://schemas.openxmlformats.org/drawingml/2006/main" prst="rect">
+            <a:avLst/>
+          </a:prstGeom>
+          <a:solidFill xmlns:a="http://schemas.openxmlformats.org/drawingml/2006/main">
+            <a:schemeClr val="accent1"/>
+          </a:solidFill>
+          <a:ln xmlns:a="http://schemas.openxmlformats.org/drawingml/2006/main">
+            <a:noFill/>
+            <a:prstDash val="solid"/>
+          </a:ln>
+        </p:spPr>
+      </p:sp>
+      <p:sp>
+        <p:nvSpPr>
+          <p:cNvPr id="2" name="Title">
+            <a:extLst xmlns:a="http://schemas.openxmlformats.org/drawingml/2006/main">
+              <a:ext uri="{FF2B5EF4-FFF2-40B4-BE49-F238E27FC236}">
+                <a16:creationId xmlns:a16="http://schemas.microsoft.com/office/drawing/2014/main" id="{AF0DFA36-855B-49FD-9900-2279CB258097}"/>
+              </a:ext>
+            </a:extLst>
+          </p:cNvPr>
+          <p:cNvSpPr>
+            <a:spLocks xmlns:a="http://schemas.openxmlformats.org/drawingml/2006/main" noGrp="1"/>
+          </p:cNvSpPr>
+          <p:nvPr>
+            <p:ph type="title" idx="0"/>
+          </p:nvPr>
+        </p:nvSpPr>
+        <p:spPr>
+          <a:xfrm xmlns:a="http://schemas.openxmlformats.org/drawingml/2006/main">
+            <a:off x="685800" y="533400"/>
+            <a:ext cx="10820400" cy="838200"/>
+          </a:xfrm>
+          <a:prstGeom xmlns:a="http://schemas.openxmlformats.org/drawingml/2006/main" prst="rect">
+            <a:avLst/>
+          </a:prstGeom>
+          <a:noFill xmlns:a="http://schemas.openxmlformats.org/drawingml/2006/main"/>
+          <a:ln xmlns:a="http://schemas.openxmlformats.org/drawingml/2006/main">
+            <a:noFill/>
+            <a:prstDash val="solid"/>
+          </a:ln>
+        </p:spPr>
+        <p:txBody>
+          <a:bodyPr xmlns:a="http://schemas.openxmlformats.org/drawingml/2006/main" wrap="square" lIns="0" tIns="0" rIns="0" bIns="0" anchor="t">
+            <a:normAutofit/>
+          </a:bodyPr>
+          <a:lstStyle xmlns:a="http://schemas.openxmlformats.org/drawingml/2006/main">
+            <a:lvl1pPr marL="0" indent="0">
+              <a:lnSpc>
+                <a:spcPct val="110000"/>
+              </a:lnSpc>
+              <a:spcBef>
+                <a:spcPts val="0"/>
+              </a:spcBef>
+              <a:spcAft>
+                <a:spcPts val="0"/>
+              </a:spcAft>
+              <a:buNone/>
+            </a:lvl1pPr>
+            <a:lvl2pPr marL="0" indent="0">
+              <a:lnSpc>
+                <a:spcPct val="110000"/>
+              </a:lnSpc>
+              <a:spcBef>
+                <a:spcPts val="0"/>
+              </a:spcBef>
+              <a:spcAft>
+                <a:spcPts val="0"/>
+              </a:spcAft>
+              <a:buNone/>
+            </a:lvl2pPr>
+            <a:lvl3pPr marL="0" indent="0">
+              <a:lnSpc>
+                <a:spcPct val="110000"/>
+              </a:lnSpc>
+              <a:spcBef>
+                <a:spcPts val="0"/>
+              </a:spcBef>
+              <a:spcAft>
+                <a:spcPts val="0"/>
+              </a:spcAft>
+              <a:buNone/>
+            </a:lvl3pPr>
+            <a:lvl4pPr marL="0" indent="0">
+              <a:lnSpc>
+                <a:spcPct val="110000"/>
+              </a:lnSpc>
+              <a:spcBef>
+                <a:spcPts val="0"/>
+              </a:spcBef>
+              <a:spcAft>
+                <a:spcPts val="0"/>
+              </a:spcAft>
+              <a:buNone/>
+            </a:lvl4pPr>
+            <a:lvl5pPr marL="0" indent="0">
+              <a:lnSpc>
+                <a:spcPct val="110000"/>
+              </a:lnSpc>
+              <a:spcBef>
+                <a:spcPts val="0"/>
+              </a:spcBef>
+              <a:spcAft>
+                <a:spcPts val="0"/>
+              </a:spcAft>
+              <a:buNone/>
+            </a:lvl5pPr>
+            <a:lvl6pPr marL="0" indent="0">
+              <a:lnSpc>
+                <a:spcPct val="110000"/>
+              </a:lnSpc>
+              <a:spcBef>
+                <a:spcPts val="0"/>
+              </a:spcBef>
+              <a:spcAft>
+                <a:spcPts val="0"/>
+              </a:spcAft>
+              <a:buNone/>
+            </a:lvl6pPr>
+            <a:lvl7pPr marL="0" indent="0">
+              <a:lnSpc>
+                <a:spcPct val="110000"/>
+              </a:lnSpc>
+              <a:spcBef>
+                <a:spcPts val="0"/>
+              </a:spcBef>
+              <a:spcAft>
+                <a:spcPts val="0"/>
+              </a:spcAft>
+              <a:buNone/>
+            </a:lvl7pPr>
+            <a:lvl8pPr marL="0" indent="0">
+              <a:lnSpc>
+                <a:spcPct val="110000"/>
+              </a:lnSpc>
+              <a:spcBef>
+                <a:spcPts val="0"/>
+              </a:spcBef>
+              <a:spcAft>
+                <a:spcPts val="0"/>
+              </a:spcAft>
+              <a:buNone/>
+            </a:lvl8pPr>
+            <a:lvl9pPr marL="0" indent="0">
+              <a:lnSpc>
+                <a:spcPct val="110000"/>
+              </a:lnSpc>
+              <a:spcBef>
+                <a:spcPts val="0"/>
+              </a:spcBef>
+              <a:spcAft>
+                <a:spcPts val="0"/>
+              </a:spcAft>
+              <a:buNone/>
+            </a:lvl9pPr>
+          </a:lstStyle>
+          <a:p xmlns:a="http://schemas.openxmlformats.org/drawingml/2006/main"/>
+        </p:txBody>
+      </p:sp>
+      <p:sp>
+        <p:nvSpPr>
+          <p:cNvPr id="3" name="Body">
+            <a:extLst xmlns:a="http://schemas.openxmlformats.org/drawingml/2006/main">
+              <a:ext uri="{FF2B5EF4-FFF2-40B4-BE49-F238E27FC236}">
+                <a16:creationId xmlns:a16="http://schemas.microsoft.com/office/drawing/2014/main" id="{FC987463-31CA-48D1-9615-E71CC5AFC63F}"/>
+              </a:ext>
+            </a:extLst>
+          </p:cNvPr>
+          <p:cNvSpPr>
+            <a:spLocks xmlns:a="http://schemas.openxmlformats.org/drawingml/2006/main" noGrp="1"/>
+          </p:cNvSpPr>
+          <p:nvPr>
+            <p:ph type="body" idx="1"/>
+          </p:nvPr>
+        </p:nvSpPr>
+        <p:spPr>
+          <a:xfrm xmlns:a="http://schemas.openxmlformats.org/drawingml/2006/main">
+            <a:off x="685800" y="1905000"/>
+            <a:ext cx="10820400" cy="4267200"/>
+          </a:xfrm>
+          <a:prstGeom xmlns:a="http://schemas.openxmlformats.org/drawingml/2006/main" prst="rect">
+            <a:avLst/>
+          </a:prstGeom>
+          <a:noFill xmlns:a="http://schemas.openxmlformats.org/drawingml/2006/main"/>
+          <a:ln xmlns:a="http://schemas.openxmlformats.org/drawingml/2006/main">
+            <a:noFill/>
+            <a:prstDash val="solid"/>
+          </a:ln>
+        </p:spPr>
+        <p:txBody>
+          <a:bodyPr xmlns:a="http://schemas.openxmlformats.org/drawingml/2006/main" wrap="square" lIns="0" tIns="0" rIns="0" bIns="0" anchor="t">
+            <a:normAutofit/>
+          </a:bodyPr>
+          <a:lstStyle xmlns:a="http://schemas.openxmlformats.org/drawingml/2006/main">
+            <a:lvl1pPr marL="228600" indent="-228600">
+              <a:lnSpc>
+                <a:spcPct val="110000"/>
+              </a:lnSpc>
+              <a:spcBef>
+                <a:spcPts val="0"/>
+              </a:spcBef>
+              <a:spcAft>
+                <a:spcPts val="1200"/>
+              </a:spcAft>
+              <a:buChar char="•"/>
+            </a:lvl1pPr>
+            <a:lvl2pPr marL="533400" indent="-228600">
+              <a:lnSpc>
+                <a:spcPct val="110000"/>
+              </a:lnSpc>
+              <a:spcBef>
+                <a:spcPts val="0"/>
+              </a:spcBef>
+              <a:spcAft>
+                <a:spcPts val="1200"/>
+              </a:spcAft>
+              <a:buChar char="•"/>
+            </a:lvl2pPr>
+            <a:lvl3pPr marL="838200" indent="-228600">
+              <a:lnSpc>
+                <a:spcPct val="110000"/>
+              </a:lnSpc>
+              <a:spcBef>
+                <a:spcPts val="0"/>
+              </a:spcBef>
+              <a:spcAft>
+                <a:spcPts val="1200"/>
+              </a:spcAft>
+              <a:buChar char="•"/>
+            </a:lvl3pPr>
+            <a:lvl4pPr marL="1143000" indent="-228600">
+              <a:lnSpc>
+                <a:spcPct val="110000"/>
+              </a:lnSpc>
+              <a:spcBef>
+                <a:spcPts val="0"/>
+              </a:spcBef>
+              <a:spcAft>
+                <a:spcPts val="1200"/>
+              </a:spcAft>
+              <a:buChar char="•"/>
+            </a:lvl4pPr>
+            <a:lvl5pPr marL="1447800" indent="-228600">
+              <a:lnSpc>
+                <a:spcPct val="110000"/>
+              </a:lnSpc>
+              <a:spcBef>
+                <a:spcPts val="0"/>
+              </a:spcBef>
+              <a:spcAft>
+                <a:spcPts val="1200"/>
+              </a:spcAft>
+              <a:buChar char="•"/>
+            </a:lvl5pPr>
+            <a:lvl6pPr marL="1752600" indent="-228600">
+              <a:lnSpc>
+                <a:spcPct val="110000"/>
+              </a:lnSpc>
+              <a:spcBef>
+                <a:spcPts val="0"/>
+              </a:spcBef>
+              <a:spcAft>
+                <a:spcPts val="1200"/>
+              </a:spcAft>
+              <a:buChar char="•"/>
+            </a:lvl6pPr>
+            <a:lvl7pPr marL="2057400" indent="-228600">
+              <a:lnSpc>
+                <a:spcPct val="110000"/>
+              </a:lnSpc>
+              <a:spcBef>
+                <a:spcPts val="0"/>
+              </a:spcBef>
+              <a:spcAft>
+                <a:spcPts val="1200"/>
+              </a:spcAft>
+              <a:buChar char="•"/>
+            </a:lvl7pPr>
+            <a:lvl8pPr marL="2362200" indent="-228600">
+              <a:lnSpc>
+                <a:spcPct val="110000"/>
+              </a:lnSpc>
+              <a:spcBef>
+                <a:spcPts val="0"/>
+              </a:spcBef>
+              <a:spcAft>
+                <a:spcPts val="1200"/>
+              </a:spcAft>
+              <a:buChar char="•"/>
+            </a:lvl8pPr>
+            <a:lvl9pPr marL="2667000" indent="-228600">
+              <a:lnSpc>
+                <a:spcPct val="110000"/>
+              </a:lnSpc>
+              <a:spcBef>
+                <a:spcPts val="0"/>
+              </a:spcBef>
+              <a:spcAft>
+                <a:spcPts val="1200"/>
+              </a:spcAft>
+              <a:buChar char="•"/>
+            </a:lvl9pPr>
+          </a:lstStyle>
+          <a:p xmlns:a="http://schemas.openxmlformats.org/drawingml/2006/main"/>
+        </p:txBody>
+      </p:sp>
+    </p:spTree>
+  </p:cSld>
+</p:sldLayout>
+</file>
+
+<file path=ppt/slideLayouts/slideLayout4.xml><?xml version="1.0" encoding="utf-8"?>
+<p:sldLayout xmlns:p="http://schemas.openxmlformats.org/presentationml/2006/main">
+  <p:cSld name="Title and Two Column">
+    <p:spTree>
+      <p:nvGrpSpPr>
+        <p:cNvPr id="1" name=""/>
+        <p:cNvGrpSpPr/>
+        <p:nvPr/>
+      </p:nvGrpSpPr>
+      <p:grpSpPr>
+        <a:xfrm xmlns:a="http://schemas.openxmlformats.org/drawingml/2006/main"/>
+      </p:grpSpPr>
+      <p:sp>
+        <p:nvSpPr>
+          <p:cNvPr id="5" name="Accent rule">
+            <a:extLst xmlns:a="http://schemas.openxmlformats.org/drawingml/2006/main">
+              <a:ext uri="{FF2B5EF4-FFF2-40B4-BE49-F238E27FC236}">
+                <a16:creationId xmlns:a16="http://schemas.microsoft.com/office/drawing/2014/main" id="{1A1887C7-6AB2-4DBC-B422-00412D0E95C0}"/>
+              </a:ext>
+            </a:extLst>
+          </p:cNvPr>
+          <p:cNvSpPr>
+            <a:spLocks xmlns:a="http://schemas.openxmlformats.org/drawingml/2006/main" noGrp="1"/>
+          </p:cNvSpPr>
+          <p:nvPr/>
+        </p:nvSpPr>
+        <p:spPr>
+          <a:xfrm xmlns:a="http://schemas.openxmlformats.org/drawingml/2006/main">
+            <a:off x="685800" y="1524000"/>
+            <a:ext cx="609600" cy="38100"/>
+          </a:xfrm>
+          <a:prstGeom xmlns:a="http://schemas.openxmlformats.org/drawingml/2006/main" prst="rect">
+            <a:avLst/>
+          </a:prstGeom>
+          <a:solidFill xmlns:a="http://schemas.openxmlformats.org/drawingml/2006/main">
+            <a:schemeClr val="accent1"/>
+          </a:solidFill>
+          <a:ln xmlns:a="http://schemas.openxmlformats.org/drawingml/2006/main">
+            <a:noFill/>
+            <a:prstDash val="solid"/>
+          </a:ln>
+        </p:spPr>
+      </p:sp>
+      <p:sp>
+        <p:nvSpPr>
+          <p:cNvPr id="2" name="Title">
+            <a:extLst xmlns:a="http://schemas.openxmlformats.org/drawingml/2006/main">
+              <a:ext uri="{FF2B5EF4-FFF2-40B4-BE49-F238E27FC236}">
+                <a16:creationId xmlns:a16="http://schemas.microsoft.com/office/drawing/2014/main" id="{7C2F7817-2D04-48CE-B005-AB8D637C1C10}"/>
+              </a:ext>
+            </a:extLst>
+          </p:cNvPr>
+          <p:cNvSpPr>
+            <a:spLocks xmlns:a="http://schemas.openxmlformats.org/drawingml/2006/main" noGrp="1"/>
+          </p:cNvSpPr>
+          <p:nvPr>
+            <p:ph type="title" idx="0"/>
+          </p:nvPr>
+        </p:nvSpPr>
+        <p:spPr>
+          <a:xfrm xmlns:a="http://schemas.openxmlformats.org/drawingml/2006/main">
+            <a:off x="685800" y="533400"/>
+            <a:ext cx="10820400" cy="838200"/>
+          </a:xfrm>
+          <a:prstGeom xmlns:a="http://schemas.openxmlformats.org/drawingml/2006/main" prst="rect">
+            <a:avLst/>
+          </a:prstGeom>
+          <a:noFill xmlns:a="http://schemas.openxmlformats.org/drawingml/2006/main"/>
+          <a:ln xmlns:a="http://schemas.openxmlformats.org/drawingml/2006/main">
+            <a:noFill/>
+            <a:prstDash val="solid"/>
+          </a:ln>
+        </p:spPr>
+        <p:txBody>
+          <a:bodyPr xmlns:a="http://schemas.openxmlformats.org/drawingml/2006/main" wrap="square" lIns="0" tIns="0" rIns="0" bIns="0" anchor="t">
+            <a:normAutofit/>
+          </a:bodyPr>
+          <a:lstStyle xmlns:a="http://schemas.openxmlformats.org/drawingml/2006/main">
+            <a:lvl1pPr marL="0" indent="0">
+              <a:lnSpc>
+                <a:spcPct val="110000"/>
+              </a:lnSpc>
+              <a:spcBef>
+                <a:spcPts val="0"/>
+              </a:spcBef>
+              <a:spcAft>
+                <a:spcPts val="0"/>
+              </a:spcAft>
+              <a:buNone/>
+            </a:lvl1pPr>
+            <a:lvl2pPr marL="0" indent="0">
+              <a:lnSpc>
+                <a:spcPct val="110000"/>
+              </a:lnSpc>
+              <a:spcBef>
+                <a:spcPts val="0"/>
+              </a:spcBef>
+              <a:spcAft>
+                <a:spcPts val="0"/>
+              </a:spcAft>
+              <a:buNone/>
+            </a:lvl2pPr>
+            <a:lvl3pPr marL="0" indent="0">
+              <a:lnSpc>
+                <a:spcPct val="110000"/>
+              </a:lnSpc>
+              <a:spcBef>
+                <a:spcPts val="0"/>
+              </a:spcBef>
+              <a:spcAft>
+                <a:spcPts val="0"/>
+              </a:spcAft>
+              <a:buNone/>
+            </a:lvl3pPr>
+            <a:lvl4pPr marL="0" indent="0">
+              <a:lnSpc>
+                <a:spcPct val="110000"/>
+              </a:lnSpc>
+              <a:spcBef>
+                <a:spcPts val="0"/>
+              </a:spcBef>
+              <a:spcAft>
+                <a:spcPts val="0"/>
+              </a:spcAft>
+              <a:buNone/>
+            </a:lvl4pPr>
+            <a:lvl5pPr marL="0" indent="0">
+              <a:lnSpc>
+                <a:spcPct val="110000"/>
+              </a:lnSpc>
+              <a:spcBef>
+                <a:spcPts val="0"/>
+              </a:spcBef>
+              <a:spcAft>
+                <a:spcPts val="0"/>
+              </a:spcAft>
+              <a:buNone/>
+            </a:lvl5pPr>
+            <a:lvl6pPr marL="0" indent="0">
+              <a:lnSpc>
+                <a:spcPct val="110000"/>
+              </a:lnSpc>
+              <a:spcBef>
+                <a:spcPts val="0"/>
+              </a:spcBef>
+              <a:spcAft>
+                <a:spcPts val="0"/>
+              </a:spcAft>
+              <a:buNone/>
+            </a:lvl6pPr>
+            <a:lvl7pPr marL="0" indent="0">
+              <a:lnSpc>
+                <a:spcPct val="110000"/>
+              </a:lnSpc>
+              <a:spcBef>
+                <a:spcPts val="0"/>
+              </a:spcBef>
+              <a:spcAft>
+                <a:spcPts val="0"/>
+              </a:spcAft>
+              <a:buNone/>
+            </a:lvl7pPr>
+            <a:lvl8pPr marL="0" indent="0">
+              <a:lnSpc>
+                <a:spcPct val="110000"/>
+              </a:lnSpc>
+              <a:spcBef>
+                <a:spcPts val="0"/>
+              </a:spcBef>
+              <a:spcAft>
+                <a:spcPts val="0"/>
+              </a:spcAft>
+              <a:buNone/>
+            </a:lvl8pPr>
+            <a:lvl9pPr marL="0" indent="0">
+              <a:lnSpc>
+                <a:spcPct val="110000"/>
+              </a:lnSpc>
+              <a:spcBef>
+                <a:spcPts val="0"/>
+              </a:spcBef>
+              <a:spcAft>
+                <a:spcPts val="0"/>
+              </a:spcAft>
+              <a:buNone/>
+            </a:lvl9pPr>
+          </a:lstStyle>
+          <a:p xmlns:a="http://schemas.openxmlformats.org/drawingml/2006/main"/>
+        </p:txBody>
+      </p:sp>
+      <p:sp>
+        <p:nvSpPr>
+          <p:cNvPr id="3" name="Left column">
+            <a:extLst xmlns:a="http://schemas.openxmlformats.org/drawingml/2006/main">
+              <a:ext uri="{FF2B5EF4-FFF2-40B4-BE49-F238E27FC236}">
+                <a16:creationId xmlns:a16="http://schemas.microsoft.com/office/drawing/2014/main" id="{40AF1AA6-A3B2-4735-B76C-27B4154C248D}"/>
+              </a:ext>
+            </a:extLst>
+          </p:cNvPr>
+          <p:cNvSpPr>
+            <a:spLocks xmlns:a="http://schemas.openxmlformats.org/drawingml/2006/main" noGrp="1"/>
+          </p:cNvSpPr>
+          <p:nvPr>
+            <p:ph type="body" idx="1"/>
+          </p:nvPr>
+        </p:nvSpPr>
+        <p:spPr>
+          <a:xfrm xmlns:a="http://schemas.openxmlformats.org/drawingml/2006/main">
+            <a:off x="685800" y="1905000"/>
+            <a:ext cx="5029200" cy="4267200"/>
+          </a:xfrm>
+          <a:prstGeom xmlns:a="http://schemas.openxmlformats.org/drawingml/2006/main" prst="rect">
+            <a:avLst/>
+          </a:prstGeom>
+          <a:noFill xmlns:a="http://schemas.openxmlformats.org/drawingml/2006/main"/>
+          <a:ln xmlns:a="http://schemas.openxmlformats.org/drawingml/2006/main">
+            <a:noFill/>
+            <a:prstDash val="solid"/>
+          </a:ln>
+        </p:spPr>
+        <p:txBody>
+          <a:bodyPr xmlns:a="http://schemas.openxmlformats.org/drawingml/2006/main" wrap="square" lIns="0" tIns="0" rIns="0" bIns="0" anchor="t">
+            <a:normAutofit/>
+          </a:bodyPr>
+          <a:lstStyle xmlns:a="http://schemas.openxmlformats.org/drawingml/2006/main">
+            <a:lvl1pPr marL="228600" indent="-228600">
+              <a:lnSpc>
+                <a:spcPct val="110000"/>
+              </a:lnSpc>
+              <a:spcBef>
+                <a:spcPts val="0"/>
+              </a:spcBef>
+              <a:spcAft>
+                <a:spcPts val="1200"/>
+              </a:spcAft>
+              <a:buChar char="•"/>
+            </a:lvl1pPr>
+            <a:lvl2pPr marL="533400" indent="-228600">
+              <a:lnSpc>
+                <a:spcPct val="110000"/>
+              </a:lnSpc>
+              <a:spcBef>
+                <a:spcPts val="0"/>
+              </a:spcBef>
+              <a:spcAft>
+                <a:spcPts val="1200"/>
+              </a:spcAft>
+              <a:buChar char="•"/>
+            </a:lvl2pPr>
+            <a:lvl3pPr marL="838200" indent="-228600">
+              <a:lnSpc>
+                <a:spcPct val="110000"/>
+              </a:lnSpc>
+              <a:spcBef>
+                <a:spcPts val="0"/>
+              </a:spcBef>
+              <a:spcAft>
+                <a:spcPts val="1200"/>
+              </a:spcAft>
+              <a:buChar char="•"/>
+            </a:lvl3pPr>
+            <a:lvl4pPr marL="1143000" indent="-228600">
+              <a:lnSpc>
+                <a:spcPct val="110000"/>
+              </a:lnSpc>
+              <a:spcBef>
+                <a:spcPts val="0"/>
+              </a:spcBef>
+              <a:spcAft>
+                <a:spcPts val="1200"/>
+              </a:spcAft>
+              <a:buChar char="•"/>
+            </a:lvl4pPr>
+            <a:lvl5pPr marL="1447800" indent="-228600">
+              <a:lnSpc>
+                <a:spcPct val="110000"/>
+              </a:lnSpc>
+              <a:spcBef>
+                <a:spcPts val="0"/>
+              </a:spcBef>
+              <a:spcAft>
+                <a:spcPts val="1200"/>
+              </a:spcAft>
+              <a:buChar char="•"/>
+            </a:lvl5pPr>
+            <a:lvl6pPr marL="1752600" indent="-228600">
+              <a:lnSpc>
+                <a:spcPct val="110000"/>
+              </a:lnSpc>
+              <a:spcBef>
+                <a:spcPts val="0"/>
+              </a:spcBef>
+              <a:spcAft>
+                <a:spcPts val="1200"/>
+              </a:spcAft>
+              <a:buChar char="•"/>
+            </a:lvl6pPr>
+            <a:lvl7pPr marL="2057400" indent="-228600">
+              <a:lnSpc>
+                <a:spcPct val="110000"/>
+              </a:lnSpc>
+              <a:spcBef>
+                <a:spcPts val="0"/>
+              </a:spcBef>
+              <a:spcAft>
+                <a:spcPts val="1200"/>
+              </a:spcAft>
+              <a:buChar char="•"/>
+            </a:lvl7pPr>
+            <a:lvl8pPr marL="2362200" indent="-228600">
+              <a:lnSpc>
+                <a:spcPct val="110000"/>
+              </a:lnSpc>
+              <a:spcBef>
+                <a:spcPts val="0"/>
+              </a:spcBef>
+              <a:spcAft>
+                <a:spcPts val="1200"/>
+              </a:spcAft>
+              <a:buChar char="•"/>
+            </a:lvl8pPr>
+            <a:lvl9pPr marL="2667000" indent="-228600">
+              <a:lnSpc>
+                <a:spcPct val="110000"/>
+              </a:lnSpc>
+              <a:spcBef>
+                <a:spcPts val="0"/>
+              </a:spcBef>
+              <a:spcAft>
+                <a:spcPts val="1200"/>
+              </a:spcAft>
+              <a:buChar char="•"/>
+            </a:lvl9pPr>
+          </a:lstStyle>
+          <a:p xmlns:a="http://schemas.openxmlformats.org/drawingml/2006/main"/>
+        </p:txBody>
+      </p:sp>
+      <p:sp>
+        <p:nvSpPr>
+          <p:cNvPr id="4" name="Right column">
+            <a:extLst xmlns:a="http://schemas.openxmlformats.org/drawingml/2006/main">
+              <a:ext uri="{FF2B5EF4-FFF2-40B4-BE49-F238E27FC236}">
+                <a16:creationId xmlns:a16="http://schemas.microsoft.com/office/drawing/2014/main" id="{6F0F9D44-7415-48D4-87AA-14132E5ADD9F}"/>
+              </a:ext>
+            </a:extLst>
+          </p:cNvPr>
+          <p:cNvSpPr>
+            <a:spLocks xmlns:a="http://schemas.openxmlformats.org/drawingml/2006/main" noGrp="1"/>
+          </p:cNvSpPr>
+          <p:nvPr>
+            <p:ph type="body" idx="2"/>
+          </p:nvPr>
+        </p:nvSpPr>
+        <p:spPr>
+          <a:xfrm xmlns:a="http://schemas.openxmlformats.org/drawingml/2006/main">
+            <a:off x="6477000" y="1905000"/>
+            <a:ext cx="5029200" cy="4267200"/>
+          </a:xfrm>
+          <a:prstGeom xmlns:a="http://schemas.openxmlformats.org/drawingml/2006/main" prst="rect">
+            <a:avLst/>
+          </a:prstGeom>
+          <a:noFill xmlns:a="http://schemas.openxmlformats.org/drawingml/2006/main"/>
+          <a:ln xmlns:a="http://schemas.openxmlformats.org/drawingml/2006/main">
+            <a:noFill/>
+            <a:prstDash val="solid"/>
+          </a:ln>
+        </p:spPr>
+        <p:txBody>
+          <a:bodyPr xmlns:a="http://schemas.openxmlformats.org/drawingml/2006/main" wrap="square" lIns="0" tIns="0" rIns="0" bIns="0" anchor="t">
+            <a:normAutofit/>
+          </a:bodyPr>
+          <a:lstStyle xmlns:a="http://schemas.openxmlformats.org/drawingml/2006/main">
+            <a:lvl1pPr marL="228600" indent="-228600">
+              <a:lnSpc>
+                <a:spcPct val="110000"/>
+              </a:lnSpc>
+              <a:spcBef>
+                <a:spcPts val="0"/>
+              </a:spcBef>
+              <a:spcAft>
+                <a:spcPts val="1200"/>
+              </a:spcAft>
+              <a:buChar char="•"/>
+            </a:lvl1pPr>
+            <a:lvl2pPr marL="533400" indent="-228600">
+              <a:lnSpc>
+                <a:spcPct val="110000"/>
+              </a:lnSpc>
+              <a:spcBef>
+                <a:spcPts val="0"/>
+              </a:spcBef>
+              <a:spcAft>
+                <a:spcPts val="1200"/>
+              </a:spcAft>
+              <a:buChar char="•"/>
+            </a:lvl2pPr>
+            <a:lvl3pPr marL="838200" indent="-228600">
+              <a:lnSpc>
+                <a:spcPct val="110000"/>
+              </a:lnSpc>
+              <a:spcBef>
+                <a:spcPts val="0"/>
+              </a:spcBef>
+              <a:spcAft>
+                <a:spcPts val="1200"/>
+              </a:spcAft>
+              <a:buChar char="•"/>
+            </a:lvl3pPr>
+            <a:lvl4pPr marL="1143000" indent="-228600">
+              <a:lnSpc>
+                <a:spcPct val="110000"/>
+              </a:lnSpc>
+              <a:spcBef>
+                <a:spcPts val="0"/>
+              </a:spcBef>
+              <a:spcAft>
+                <a:spcPts val="1200"/>
+              </a:spcAft>
+              <a:buChar char="•"/>
+            </a:lvl4pPr>
+            <a:lvl5pPr marL="1447800" indent="-228600">
+              <a:lnSpc>
+                <a:spcPct val="110000"/>
+              </a:lnSpc>
+              <a:spcBef>
+                <a:spcPts val="0"/>
+              </a:spcBef>
+              <a:spcAft>
+                <a:spcPts val="1200"/>
+              </a:spcAft>
+              <a:buChar char="•"/>
+            </a:lvl5pPr>
+            <a:lvl6pPr marL="1752600" indent="-228600">
+              <a:lnSpc>
+                <a:spcPct val="110000"/>
+              </a:lnSpc>
+              <a:spcBef>
+                <a:spcPts val="0"/>
+              </a:spcBef>
+              <a:spcAft>
+                <a:spcPts val="1200"/>
+              </a:spcAft>
+              <a:buChar char="•"/>
+            </a:lvl6pPr>
+            <a:lvl7pPr marL="2057400" indent="-228600">
+              <a:lnSpc>
+                <a:spcPct val="110000"/>
+              </a:lnSpc>
+              <a:spcBef>
+                <a:spcPts val="0"/>
+              </a:spcBef>
+              <a:spcAft>
+                <a:spcPts val="1200"/>
+              </a:spcAft>
+              <a:buChar char="•"/>
+            </a:lvl7pPr>
+            <a:lvl8pPr marL="2362200" indent="-228600">
+              <a:lnSpc>
+                <a:spcPct val="110000"/>
+              </a:lnSpc>
+              <a:spcBef>
+                <a:spcPts val="0"/>
+              </a:spcBef>
+              <a:spcAft>
+                <a:spcPts val="1200"/>
+              </a:spcAft>
+              <a:buChar char="•"/>
+            </a:lvl8pPr>
+            <a:lvl9pPr marL="2667000" indent="-228600">
+              <a:lnSpc>
+                <a:spcPct val="110000"/>
+              </a:lnSpc>
+              <a:spcBef>
+                <a:spcPts val="0"/>
+              </a:spcBef>
+              <a:spcAft>
+                <a:spcPts val="1200"/>
+              </a:spcAft>
+              <a:buChar char="•"/>
+            </a:lvl9pPr>
+          </a:lstStyle>
+          <a:p xmlns:a="http://schemas.openxmlformats.org/drawingml/2006/main"/>
+        </p:txBody>
+      </p:sp>
+    </p:spTree>
+  </p:cSld>
+</p:sldLayout>
+</file>
+
+<file path=ppt/slideLayouts/slideLayout5.xml><?xml version="1.0" encoding="utf-8"?>
+<p:sldLayout xmlns:p="http://schemas.openxmlformats.org/presentationml/2006/main">
+  <p:cSld name="Title and One Column">
+    <p:spTree>
+      <p:nvGrpSpPr>
+        <p:cNvPr id="1" name=""/>
+        <p:cNvGrpSpPr/>
+        <p:nvPr/>
+      </p:nvGrpSpPr>
+      <p:grpSpPr>
+        <a:xfrm xmlns:a="http://schemas.openxmlformats.org/drawingml/2006/main"/>
+      </p:grpSpPr>
+      <p:sp>
+        <p:nvSpPr>
+          <p:cNvPr id="4" name="Accent rule">
+            <a:extLst xmlns:a="http://schemas.openxmlformats.org/drawingml/2006/main">
+              <a:ext uri="{FF2B5EF4-FFF2-40B4-BE49-F238E27FC236}">
+                <a16:creationId xmlns:a16="http://schemas.microsoft.com/office/drawing/2014/main" id="{08651FAA-1B59-4F92-A742-91D1238B1A3D}"/>
+              </a:ext>
+            </a:extLst>
+          </p:cNvPr>
+          <p:cNvSpPr>
+            <a:spLocks xmlns:a="http://schemas.openxmlformats.org/drawingml/2006/main" noGrp="1"/>
+          </p:cNvSpPr>
+          <p:nvPr/>
+        </p:nvSpPr>
+        <p:spPr>
+          <a:xfrm xmlns:a="http://schemas.openxmlformats.org/drawingml/2006/main">
+            <a:off x="685800" y="1524000"/>
+            <a:ext cx="609600" cy="38100"/>
+          </a:xfrm>
+          <a:prstGeom xmlns:a="http://schemas.openxmlformats.org/drawingml/2006/main" prst="rect">
+            <a:avLst/>
+          </a:prstGeom>
+          <a:solidFill xmlns:a="http://schemas.openxmlformats.org/drawingml/2006/main">
+            <a:schemeClr val="accent1"/>
+          </a:solidFill>
+          <a:ln xmlns:a="http://schemas.openxmlformats.org/drawingml/2006/main">
+            <a:noFill/>
+            <a:prstDash val="solid"/>
+          </a:ln>
+        </p:spPr>
+      </p:sp>
+      <p:sp>
+        <p:nvSpPr>
+          <p:cNvPr id="2" name="Title">
+            <a:extLst xmlns:a="http://schemas.openxmlformats.org/drawingml/2006/main">
+              <a:ext uri="{FF2B5EF4-FFF2-40B4-BE49-F238E27FC236}">
+                <a16:creationId xmlns:a16="http://schemas.microsoft.com/office/drawing/2014/main" id="{22188AAA-157D-4F55-9345-68738F20D5ED}"/>
+              </a:ext>
+            </a:extLst>
+          </p:cNvPr>
+          <p:cNvSpPr>
+            <a:spLocks xmlns:a="http://schemas.openxmlformats.org/drawingml/2006/main" noGrp="1"/>
+          </p:cNvSpPr>
+          <p:nvPr>
+            <p:ph type="title" idx="0"/>
+          </p:nvPr>
+        </p:nvSpPr>
+        <p:spPr>
+          <a:xfrm xmlns:a="http://schemas.openxmlformats.org/drawingml/2006/main">
+            <a:off x="685800" y="533400"/>
+            <a:ext cx="10820400" cy="838200"/>
+          </a:xfrm>
+          <a:prstGeom xmlns:a="http://schemas.openxmlformats.org/drawingml/2006/main" prst="rect">
+            <a:avLst/>
+          </a:prstGeom>
+          <a:noFill xmlns:a="http://schemas.openxmlformats.org/drawingml/2006/main"/>
+          <a:ln xmlns:a="http://schemas.openxmlformats.org/drawingml/2006/main">
+            <a:noFill/>
+            <a:prstDash val="solid"/>
+          </a:ln>
+        </p:spPr>
+        <p:txBody>
+          <a:bodyPr xmlns:a="http://schemas.openxmlformats.org/drawingml/2006/main" wrap="square" lIns="0" tIns="0" rIns="0" bIns="0" anchor="t">
+            <a:normAutofit/>
+          </a:bodyPr>
+          <a:lstStyle xmlns:a="http://schemas.openxmlformats.org/drawingml/2006/main">
+            <a:lvl1pPr marL="0" indent="0">
+              <a:lnSpc>
+                <a:spcPct val="110000"/>
+              </a:lnSpc>
+              <a:spcBef>
+                <a:spcPts val="0"/>
+              </a:spcBef>
+              <a:spcAft>
+                <a:spcPts val="0"/>
+              </a:spcAft>
+              <a:buNone/>
+            </a:lvl1pPr>
+            <a:lvl2pPr marL="0" indent="0">
+              <a:lnSpc>
+                <a:spcPct val="110000"/>
+              </a:lnSpc>
+              <a:spcBef>
+                <a:spcPts val="0"/>
+              </a:spcBef>
+              <a:spcAft>
+                <a:spcPts val="0"/>
+              </a:spcAft>
+              <a:buNone/>
+            </a:lvl2pPr>
+            <a:lvl3pPr marL="0" indent="0">
+              <a:lnSpc>
+                <a:spcPct val="110000"/>
+              </a:lnSpc>
+              <a:spcBef>
+                <a:spcPts val="0"/>
+              </a:spcBef>
+              <a:spcAft>
+                <a:spcPts val="0"/>
+              </a:spcAft>
+              <a:buNone/>
+            </a:lvl3pPr>
+            <a:lvl4pPr marL="0" indent="0">
+              <a:lnSpc>
+                <a:spcPct val="110000"/>
+              </a:lnSpc>
+              <a:spcBef>
+                <a:spcPts val="0"/>
+              </a:spcBef>
+              <a:spcAft>
+                <a:spcPts val="0"/>
+              </a:spcAft>
+              <a:buNone/>
+            </a:lvl4pPr>
+            <a:lvl5pPr marL="0" indent="0">
+              <a:lnSpc>
+                <a:spcPct val="110000"/>
+              </a:lnSpc>
+              <a:spcBef>
+                <a:spcPts val="0"/>
+              </a:spcBef>
+              <a:spcAft>
+                <a:spcPts val="0"/>
+              </a:spcAft>
+              <a:buNone/>
+            </a:lvl5pPr>
+            <a:lvl6pPr marL="0" indent="0">
+              <a:lnSpc>
+                <a:spcPct val="110000"/>
+              </a:lnSpc>
+              <a:spcBef>
+                <a:spcPts val="0"/>
+              </a:spcBef>
+              <a:spcAft>
+                <a:spcPts val="0"/>
+              </a:spcAft>
+              <a:buNone/>
+            </a:lvl6pPr>
+            <a:lvl7pPr marL="0" indent="0">
+              <a:lnSpc>
+                <a:spcPct val="110000"/>
+              </a:lnSpc>
+              <a:spcBef>
+                <a:spcPts val="0"/>
+              </a:spcBef>
+              <a:spcAft>
+                <a:spcPts val="0"/>
+              </a:spcAft>
+              <a:buNone/>
+            </a:lvl7pPr>
+            <a:lvl8pPr marL="0" indent="0">
+              <a:lnSpc>
+                <a:spcPct val="110000"/>
+              </a:lnSpc>
+              <a:spcBef>
+                <a:spcPts val="0"/>
+              </a:spcBef>
+              <a:spcAft>
+                <a:spcPts val="0"/>
+              </a:spcAft>
+              <a:buNone/>
+            </a:lvl8pPr>
+            <a:lvl9pPr marL="0" indent="0">
+              <a:lnSpc>
+                <a:spcPct val="110000"/>
+              </a:lnSpc>
+              <a:spcBef>
+                <a:spcPts val="0"/>
+              </a:spcBef>
+              <a:spcAft>
+                <a:spcPts val="0"/>
+              </a:spcAft>
+              <a:buNone/>
+            </a:lvl9pPr>
+          </a:lstStyle>
+          <a:p xmlns:a="http://schemas.openxmlformats.org/drawingml/2006/main"/>
+        </p:txBody>
+      </p:sp>
+      <p:sp>
+        <p:nvSpPr>
+          <p:cNvPr id="3" name="Left column">
+            <a:extLst xmlns:a="http://schemas.openxmlformats.org/drawingml/2006/main">
+              <a:ext uri="{FF2B5EF4-FFF2-40B4-BE49-F238E27FC236}">
+                <a16:creationId xmlns:a16="http://schemas.microsoft.com/office/drawing/2014/main" id="{8E3B5FA3-ADDA-4CAD-98F1-331D5CEAC4A5}"/>
+              </a:ext>
+            </a:extLst>
+          </p:cNvPr>
+          <p:cNvSpPr>
+            <a:spLocks xmlns:a="http://schemas.openxmlformats.org/drawingml/2006/main" noGrp="1"/>
+          </p:cNvSpPr>
+          <p:nvPr>
+            <p:ph type="body" idx="1"/>
+          </p:nvPr>
+        </p:nvSpPr>
+        <p:spPr>
+          <a:xfrm xmlns:a="http://schemas.openxmlformats.org/drawingml/2006/main">
+            <a:off x="685800" y="1905000"/>
+            <a:ext cx="5029200" cy="4267200"/>
+          </a:xfrm>
+          <a:prstGeom xmlns:a="http://schemas.openxmlformats.org/drawingml/2006/main" prst="rect">
+            <a:avLst/>
+          </a:prstGeom>
+          <a:noFill xmlns:a="http://schemas.openxmlformats.org/drawingml/2006/main"/>
+          <a:ln xmlns:a="http://schemas.openxmlformats.org/drawingml/2006/main">
+            <a:noFill/>
+            <a:prstDash val="solid"/>
+          </a:ln>
+        </p:spPr>
+        <p:txBody>
+          <a:bodyPr xmlns:a="http://schemas.openxmlformats.org/drawingml/2006/main" wrap="square" lIns="0" tIns="0" rIns="0" bIns="0" anchor="t">
+            <a:normAutofit/>
+          </a:bodyPr>
+          <a:lstStyle xmlns:a="http://schemas.openxmlformats.org/drawingml/2006/main">
+            <a:lvl1pPr marL="228600" indent="-228600">
+              <a:lnSpc>
+                <a:spcPct val="110000"/>
+              </a:lnSpc>
+              <a:spcBef>
+                <a:spcPts val="0"/>
+              </a:spcBef>
+              <a:spcAft>
+                <a:spcPts val="1200"/>
+              </a:spcAft>
+              <a:buChar char="•"/>
+            </a:lvl1pPr>
+            <a:lvl2pPr marL="533400" indent="-228600">
+              <a:lnSpc>
+                <a:spcPct val="110000"/>
+              </a:lnSpc>
+              <a:spcBef>
+                <a:spcPts val="0"/>
+              </a:spcBef>
+              <a:spcAft>
+                <a:spcPts val="1200"/>
+              </a:spcAft>
+              <a:buChar char="•"/>
+            </a:lvl2pPr>
+            <a:lvl3pPr marL="838200" indent="-228600">
+              <a:lnSpc>
+                <a:spcPct val="110000"/>
+              </a:lnSpc>
+              <a:spcBef>
+                <a:spcPts val="0"/>
+              </a:spcBef>
+              <a:spcAft>
+                <a:spcPts val="1200"/>
+              </a:spcAft>
+              <a:buChar char="•"/>
+            </a:lvl3pPr>
+            <a:lvl4pPr marL="1143000" indent="-228600">
+              <a:lnSpc>
+                <a:spcPct val="110000"/>
+              </a:lnSpc>
+              <a:spcBef>
+                <a:spcPts val="0"/>
+              </a:spcBef>
+              <a:spcAft>
+                <a:spcPts val="1200"/>
+              </a:spcAft>
+              <a:buChar char="•"/>
+            </a:lvl4pPr>
+            <a:lvl5pPr marL="1447800" indent="-228600">
+              <a:lnSpc>
+                <a:spcPct val="110000"/>
+              </a:lnSpc>
+              <a:spcBef>
+                <a:spcPts val="0"/>
+              </a:spcBef>
+              <a:spcAft>
+                <a:spcPts val="1200"/>
+              </a:spcAft>
+              <a:buChar char="•"/>
+            </a:lvl5pPr>
+            <a:lvl6pPr marL="1752600" indent="-228600">
+              <a:lnSpc>
+                <a:spcPct val="110000"/>
+              </a:lnSpc>
+              <a:spcBef>
+                <a:spcPts val="0"/>
+              </a:spcBef>
+              <a:spcAft>
+                <a:spcPts val="1200"/>
+              </a:spcAft>
+              <a:buChar char="•"/>
+            </a:lvl6pPr>
+            <a:lvl7pPr marL="2057400" indent="-228600">
+              <a:lnSpc>
+                <a:spcPct val="110000"/>
+              </a:lnSpc>
+              <a:spcBef>
+                <a:spcPts val="0"/>
+              </a:spcBef>
+              <a:spcAft>
+                <a:spcPts val="1200"/>
+              </a:spcAft>
+              <a:buChar char="•"/>
+            </a:lvl7pPr>
+            <a:lvl8pPr marL="2362200" indent="-228600">
+              <a:lnSpc>
+                <a:spcPct val="110000"/>
+              </a:lnSpc>
+              <a:spcBef>
+                <a:spcPts val="0"/>
+              </a:spcBef>
+              <a:spcAft>
+                <a:spcPts val="1200"/>
+              </a:spcAft>
+              <a:buChar char="•"/>
+            </a:lvl8pPr>
+            <a:lvl9pPr marL="2667000" indent="-228600">
+              <a:lnSpc>
+                <a:spcPct val="110000"/>
+              </a:lnSpc>
+              <a:spcBef>
+                <a:spcPts val="0"/>
+              </a:spcBef>
+              <a:spcAft>
+                <a:spcPts val="1200"/>
+              </a:spcAft>
+              <a:buChar char="•"/>
+            </a:lvl9pPr>
+          </a:lstStyle>
+          <a:p xmlns:a="http://schemas.openxmlformats.org/drawingml/2006/main"/>
+        </p:txBody>
+      </p:sp>
+    </p:spTree>
+  </p:cSld>
+</p:sldLayout>
+</file>
+
+<file path=ppt/slideLayouts/slideLayout6.xml><?xml version="1.0" encoding="utf-8"?>
+<p:sldLayout xmlns:p="http://schemas.openxmlformats.org/presentationml/2006/main" type="blank">
+  <p:cSld name="Blank">
     <p:spTree>
       <p:nvGrpSpPr>
         <p:cNvPr id="1" name=""/>
@@ -865,7 +2717,12 @@
   </p:cSld>
   <p:clrMap bg1="lt1" tx1="dk1" bg2="lt2" tx2="dk2" accent1="accent1" accent2="accent2" accent3="accent3" accent4="accent4" accent5="accent5" accent6="accent6" hlink="hlink" folHlink="folHlink"/>
   <p:sldLayoutIdLst>
-    <p:sldLayoutId xmlns:r="http://schemas.openxmlformats.org/officeDocument/2006/relationships" id="2147483649" r:id="R13261d22889d400d"/>
+    <p:sldLayoutId xmlns:r="http://schemas.openxmlformats.org/officeDocument/2006/relationships" id="2147483649" r:id="Rae4e7b42a3144ce3"/>
+    <p:sldLayoutId xmlns:r="http://schemas.openxmlformats.org/officeDocument/2006/relationships" id="2147483650" r:id="R9d7c8b58021b4b3d"/>
+    <p:sldLayoutId xmlns:r="http://schemas.openxmlformats.org/officeDocument/2006/relationships" id="2147483651" r:id="Rb82fbcc02f744429"/>
+    <p:sldLayoutId xmlns:r="http://schemas.openxmlformats.org/officeDocument/2006/relationships" id="2147483652" r:id="Rd7324638c22a404b"/>
+    <p:sldLayoutId xmlns:r="http://schemas.openxmlformats.org/officeDocument/2006/relationships" id="2147483653" r:id="R2e7fbcecd1114b18"/>
+    <p:sldLayoutId xmlns:r="http://schemas.openxmlformats.org/officeDocument/2006/relationships" id="2147483654" r:id="R5b7967cc86784807"/>
   </p:sldLayoutIdLst>
   <p:txStyles>
     <p:titleStyle>
@@ -1416,7 +3273,7 @@
           <p:cNvPr id="13" name="">
             <a:extLst xmlns:a="http://schemas.openxmlformats.org/drawingml/2006/main">
               <a:ext uri="{FF2B5EF4-FFF2-40B4-BE49-F238E27FC236}">
-                <a16:creationId xmlns:a16="http://schemas.microsoft.com/office/drawing/2014/main" id="{A8E6A7DD-3184-41BE-86FD-713A5DAEB47D}"/>
+                <a16:creationId xmlns:a16="http://schemas.microsoft.com/office/drawing/2014/main" id="{854BAC86-D50F-4CA4-86FF-A35534DCDD37}"/>
               </a:ext>
             </a:extLst>
           </p:cNvPr>
@@ -1473,7 +3330,7 @@
           <p:cNvPr id="2" name="">
             <a:extLst xmlns:a="http://schemas.openxmlformats.org/drawingml/2006/main">
               <a:ext uri="{FF2B5EF4-FFF2-40B4-BE49-F238E27FC236}">
-                <a16:creationId xmlns:a16="http://schemas.microsoft.com/office/drawing/2014/main" id="{653E470D-8926-4CD7-92A2-C3978BBF01CE}"/>
+                <a16:creationId xmlns:a16="http://schemas.microsoft.com/office/drawing/2014/main" id="{FCD5273E-DA74-4253-9895-5D3707BDEBB8}"/>
               </a:ext>
             </a:extLst>
           </p:cNvPr>
@@ -1530,7 +3387,7 @@
           <p:cNvPr id="3" name="">
             <a:extLst xmlns:a="http://schemas.openxmlformats.org/drawingml/2006/main">
               <a:ext uri="{FF2B5EF4-FFF2-40B4-BE49-F238E27FC236}">
-                <a16:creationId xmlns:a16="http://schemas.microsoft.com/office/drawing/2014/main" id="{9A70E407-FD63-4D01-959A-80409A6E1CE4}"/>
+                <a16:creationId xmlns:a16="http://schemas.microsoft.com/office/drawing/2014/main" id="{A2A73BE1-8D65-4986-A58A-C3835DE9E516}"/>
               </a:ext>
             </a:extLst>
           </p:cNvPr>
@@ -1587,7 +3444,7 @@
           <p:cNvPr id="4" name="">
             <a:extLst xmlns:a="http://schemas.openxmlformats.org/drawingml/2006/main">
               <a:ext uri="{FF2B5EF4-FFF2-40B4-BE49-F238E27FC236}">
-                <a16:creationId xmlns:a16="http://schemas.microsoft.com/office/drawing/2014/main" id="{A5DEFA0A-AECF-434A-B1DF-401C562199BD}"/>
+                <a16:creationId xmlns:a16="http://schemas.microsoft.com/office/drawing/2014/main" id="{CDC8D267-6AF2-4712-8058-172AE094B826}"/>
               </a:ext>
             </a:extLst>
           </p:cNvPr>
@@ -1644,7 +3501,7 @@
           <p:cNvPr id="5" name="">
             <a:extLst xmlns:a="http://schemas.openxmlformats.org/drawingml/2006/main">
               <a:ext uri="{FF2B5EF4-FFF2-40B4-BE49-F238E27FC236}">
-                <a16:creationId xmlns:a16="http://schemas.microsoft.com/office/drawing/2014/main" id="{987B06EA-26BB-488F-BE22-1ADC91207C45}"/>
+                <a16:creationId xmlns:a16="http://schemas.microsoft.com/office/drawing/2014/main" id="{046FF2F1-A88F-4266-B354-F7179D344B22}"/>
               </a:ext>
             </a:extLst>
           </p:cNvPr>
@@ -1690,7 +3547,7 @@
                 <a:latin typeface="Arial"/>
                 <a:ea typeface="Arial"/>
                 <a:cs typeface="Arial"/>
-                <a:hlinkClick xmlns:r="http://schemas.openxmlformats.org/officeDocument/2006/relationships" r:id="R325c2c606aff43e3"/>
+                <a:hlinkClick xmlns:r="http://schemas.openxmlformats.org/officeDocument/2006/relationships" r:id="Rcb3b22bee98d4a68"/>
               </a:rPr>
               <a:t>chatgpt.com/download</a:t>
             </a:r>
@@ -1702,7 +3559,7 @@
           <p:cNvPr id="6" name="">
             <a:extLst xmlns:a="http://schemas.openxmlformats.org/drawingml/2006/main">
               <a:ext uri="{FF2B5EF4-FFF2-40B4-BE49-F238E27FC236}">
-                <a16:creationId xmlns:a16="http://schemas.microsoft.com/office/drawing/2014/main" id="{00296831-75F9-4FAA-924A-1AA6FE42A997}"/>
+                <a16:creationId xmlns:a16="http://schemas.microsoft.com/office/drawing/2014/main" id="{2B7DBE92-9AA3-4493-9BF5-81359BBB7320}"/>
               </a:ext>
             </a:extLst>
           </p:cNvPr>
@@ -1759,7 +3616,7 @@
           <p:cNvPr id="7" name="">
             <a:extLst xmlns:a="http://schemas.openxmlformats.org/drawingml/2006/main">
               <a:ext uri="{FF2B5EF4-FFF2-40B4-BE49-F238E27FC236}">
-                <a16:creationId xmlns:a16="http://schemas.microsoft.com/office/drawing/2014/main" id="{6793F30B-7720-4644-B065-CC1224F9CD02}"/>
+                <a16:creationId xmlns:a16="http://schemas.microsoft.com/office/drawing/2014/main" id="{634F2B0B-614C-4737-90B9-430FD69EC7FF}"/>
               </a:ext>
             </a:extLst>
           </p:cNvPr>
@@ -1816,7 +3673,7 @@
           <p:cNvPr id="8" name="">
             <a:extLst xmlns:a="http://schemas.openxmlformats.org/drawingml/2006/main">
               <a:ext uri="{FF2B5EF4-FFF2-40B4-BE49-F238E27FC236}">
-                <a16:creationId xmlns:a16="http://schemas.microsoft.com/office/drawing/2014/main" id="{944A88E1-FA1A-4489-B6D2-F900DBA0B267}"/>
+                <a16:creationId xmlns:a16="http://schemas.microsoft.com/office/drawing/2014/main" id="{E0AB1BF5-100E-417D-8370-F07C894FA245}"/>
               </a:ext>
             </a:extLst>
           </p:cNvPr>
@@ -1862,7 +3719,7 @@
                 <a:latin typeface="Arial"/>
                 <a:ea typeface="Arial"/>
                 <a:cs typeface="Arial"/>
-                <a:hlinkClick xmlns:r="http://schemas.openxmlformats.org/officeDocument/2006/relationships" r:id="R6a1c6ddcc1e3437a"/>
+                <a:hlinkClick xmlns:r="http://schemas.openxmlformats.org/officeDocument/2006/relationships" r:id="R961b7b4b2e0b450d"/>
               </a:rPr>
               <a:t>google.com/chrome</a:t>
             </a:r>
@@ -1874,7 +3731,7 @@
           <p:cNvPr id="9" name="">
             <a:extLst xmlns:a="http://schemas.openxmlformats.org/drawingml/2006/main">
               <a:ext uri="{FF2B5EF4-FFF2-40B4-BE49-F238E27FC236}">
-                <a16:creationId xmlns:a16="http://schemas.microsoft.com/office/drawing/2014/main" id="{E5E0BC49-A8E1-4B99-A592-799FF0391993}"/>
+                <a16:creationId xmlns:a16="http://schemas.microsoft.com/office/drawing/2014/main" id="{9E268C47-59CC-4B12-8438-B158D9AC2901}"/>
               </a:ext>
             </a:extLst>
           </p:cNvPr>
@@ -1931,7 +3788,7 @@
           <p:cNvPr id="10" name="">
             <a:extLst xmlns:a="http://schemas.openxmlformats.org/drawingml/2006/main">
               <a:ext uri="{FF2B5EF4-FFF2-40B4-BE49-F238E27FC236}">
-                <a16:creationId xmlns:a16="http://schemas.microsoft.com/office/drawing/2014/main" id="{84A6A032-01DA-4809-BF00-388DE2AB9448}"/>
+                <a16:creationId xmlns:a16="http://schemas.microsoft.com/office/drawing/2014/main" id="{4B79ED39-55E2-467B-A748-C3707C7C3DFC}"/>
               </a:ext>
             </a:extLst>
           </p:cNvPr>
@@ -1988,7 +3845,7 @@
           <p:cNvPr id="11" name="">
             <a:extLst xmlns:a="http://schemas.openxmlformats.org/drawingml/2006/main">
               <a:ext uri="{FF2B5EF4-FFF2-40B4-BE49-F238E27FC236}">
-                <a16:creationId xmlns:a16="http://schemas.microsoft.com/office/drawing/2014/main" id="{C8A0B043-0E0C-4A43-9204-B36B2D6960E6}"/>
+                <a16:creationId xmlns:a16="http://schemas.microsoft.com/office/drawing/2014/main" id="{4166D91E-A8D5-408F-9D50-1E1A534A4A57}"/>
               </a:ext>
             </a:extLst>
           </p:cNvPr>
@@ -2034,7 +3891,7 @@
                 <a:latin typeface="Arial"/>
                 <a:ea typeface="Arial"/>
                 <a:cs typeface="Arial"/>
-                <a:hlinkClick xmlns:r="http://schemas.openxmlformats.org/officeDocument/2006/relationships" r:id="R94c8fd4a267844df"/>
+                <a:hlinkClick xmlns:r="http://schemas.openxmlformats.org/officeDocument/2006/relationships" r:id="R6e15a089dc0c40b5"/>
               </a:rPr>
               <a:t>zotero.org/download</a:t>
             </a:r>
@@ -2046,7 +3903,7 @@
           <p:cNvPr id="12" name="">
             <a:extLst xmlns:a="http://schemas.openxmlformats.org/drawingml/2006/main">
               <a:ext uri="{FF2B5EF4-FFF2-40B4-BE49-F238E27FC236}">
-                <a16:creationId xmlns:a16="http://schemas.microsoft.com/office/drawing/2014/main" id="{55444B05-4C97-490F-8D8C-7446B3FFE60A}"/>
+                <a16:creationId xmlns:a16="http://schemas.microsoft.com/office/drawing/2014/main" id="{A0165864-BF8A-4D3C-ABC9-A307DACB1EB8}"/>
               </a:ext>
             </a:extLst>
           </p:cNvPr>
@@ -2101,7 +3958,7 @@
     </p:spTree>
     <p:extLst>
       <p:ext uri="{BB962C8B-B14F-4D97-AF65-F5344CB8AC3E}">
-        <p14:creationId xmlns:p14="http://schemas.microsoft.com/office/powerpoint/2010/main" val="1819670526"/>
+        <p14:creationId xmlns:p14="http://schemas.microsoft.com/office/powerpoint/2010/main" val="938461103"/>
       </p:ext>
     </p:extLst>
   </p:cSld>
@@ -2132,7 +3989,7 @@
           <p:cNvPr id="9" name="">
             <a:extLst xmlns:a="http://schemas.openxmlformats.org/drawingml/2006/main">
               <a:ext uri="{FF2B5EF4-FFF2-40B4-BE49-F238E27FC236}">
-                <a16:creationId xmlns:a16="http://schemas.microsoft.com/office/drawing/2014/main" id="{C2C9065C-CB27-4A81-9391-D2851C84B32D}"/>
+                <a16:creationId xmlns:a16="http://schemas.microsoft.com/office/drawing/2014/main" id="{84C04EAA-88DE-432B-A050-1DD5AC1B81E5}"/>
               </a:ext>
             </a:extLst>
           </p:cNvPr>
@@ -2212,7 +4069,7 @@
           <p:cNvPr id="2" name="">
             <a:extLst xmlns:a="http://schemas.openxmlformats.org/drawingml/2006/main">
               <a:ext uri="{FF2B5EF4-FFF2-40B4-BE49-F238E27FC236}">
-                <a16:creationId xmlns:a16="http://schemas.microsoft.com/office/drawing/2014/main" id="{8F90A9D7-F378-496D-919E-EFE247BA867E}"/>
+                <a16:creationId xmlns:a16="http://schemas.microsoft.com/office/drawing/2014/main" id="{C965E284-534D-4B05-A65E-9DCCC39A2884}"/>
               </a:ext>
             </a:extLst>
           </p:cNvPr>
@@ -2269,7 +4126,7 @@
           <p:cNvPr id="3" name="">
             <a:extLst xmlns:a="http://schemas.openxmlformats.org/drawingml/2006/main">
               <a:ext uri="{FF2B5EF4-FFF2-40B4-BE49-F238E27FC236}">
-                <a16:creationId xmlns:a16="http://schemas.microsoft.com/office/drawing/2014/main" id="{8C3F464D-5943-4DE7-B6C2-639816DCE260}"/>
+                <a16:creationId xmlns:a16="http://schemas.microsoft.com/office/drawing/2014/main" id="{B57B0948-BB2E-429B-A299-B67EF4AB654E}"/>
               </a:ext>
             </a:extLst>
           </p:cNvPr>
@@ -2349,7 +4206,7 @@
           <p:cNvPr id="4" name="">
             <a:extLst xmlns:a="http://schemas.openxmlformats.org/drawingml/2006/main">
               <a:ext uri="{FF2B5EF4-FFF2-40B4-BE49-F238E27FC236}">
-                <a16:creationId xmlns:a16="http://schemas.microsoft.com/office/drawing/2014/main" id="{CF2C83BB-1E93-475F-BE5C-B517532FB647}"/>
+                <a16:creationId xmlns:a16="http://schemas.microsoft.com/office/drawing/2014/main" id="{193181D8-05A4-4B16-B641-9E56C5032232}"/>
               </a:ext>
             </a:extLst>
           </p:cNvPr>
@@ -2406,7 +4263,7 @@
           <p:cNvPr id="5" name="">
             <a:extLst xmlns:a="http://schemas.openxmlformats.org/drawingml/2006/main">
               <a:ext uri="{FF2B5EF4-FFF2-40B4-BE49-F238E27FC236}">
-                <a16:creationId xmlns:a16="http://schemas.microsoft.com/office/drawing/2014/main" id="{47743E95-E337-4916-AF63-24EFAB719ECF}"/>
+                <a16:creationId xmlns:a16="http://schemas.microsoft.com/office/drawing/2014/main" id="{912CC068-1B39-46CE-885B-2A239CB19992}"/>
               </a:ext>
             </a:extLst>
           </p:cNvPr>
@@ -2486,7 +4343,7 @@
           <p:cNvPr id="6" name="">
             <a:extLst xmlns:a="http://schemas.openxmlformats.org/drawingml/2006/main">
               <a:ext uri="{FF2B5EF4-FFF2-40B4-BE49-F238E27FC236}">
-                <a16:creationId xmlns:a16="http://schemas.microsoft.com/office/drawing/2014/main" id="{AD89A0BF-0DCE-45F8-BBA6-AFB11E40ECE9}"/>
+                <a16:creationId xmlns:a16="http://schemas.microsoft.com/office/drawing/2014/main" id="{25B867AA-BD81-4712-9871-62DFD6A5CD3C}"/>
               </a:ext>
             </a:extLst>
           </p:cNvPr>
@@ -2570,10 +4427,10 @@
           <p:nvPr/>
         </p:nvPicPr>
         <p:blipFill>
-          <a:blip xmlns:r="http://schemas.openxmlformats.org/officeDocument/2006/relationships" xmlns:a="http://schemas.openxmlformats.org/drawingml/2006/main" r:embed="R8fe2ab6fc9fc4d72">
+          <a:blip xmlns:r="http://schemas.openxmlformats.org/officeDocument/2006/relationships" xmlns:a="http://schemas.openxmlformats.org/drawingml/2006/main" r:embed="R8eb2626d575348c3">
             <a:extLst>
               <a:ext uri="{96DAC541-7B7A-43D3-8B79-37D633B846F1}">
-                <asvg:svgBlip xmlns:asvg="http://schemas.microsoft.com/office/drawing/2016/SVG/main" r:embed="R821d668af42c4cbf"/>
+                <asvg:svgBlip xmlns:asvg="http://schemas.microsoft.com/office/drawing/2016/SVG/main" r:embed="R9a3162ee57314f5e"/>
               </a:ext>
             </a:extLst>
           </a:blip>
@@ -2598,7 +4455,7 @@
           <p:nvPr/>
         </p:nvPicPr>
         <p:blipFill>
-          <a:blip xmlns:r="http://schemas.openxmlformats.org/officeDocument/2006/relationships" xmlns:a="http://schemas.openxmlformats.org/drawingml/2006/main" r:embed="Rf0853b5aa210475d"/>
+          <a:blip xmlns:r="http://schemas.openxmlformats.org/officeDocument/2006/relationships" xmlns:a="http://schemas.openxmlformats.org/drawingml/2006/main" r:embed="R38c2f7f61b7e4292"/>
           <a:srcRect xmlns:a="http://schemas.openxmlformats.org/drawingml/2006/main" l="0" t="6081" r="0" b="28604"/>
           <a:stretch xmlns:a="http://schemas.openxmlformats.org/drawingml/2006/main"/>
         </p:blipFill>
@@ -2615,7 +4472,7 @@
     </p:spTree>
     <p:extLst>
       <p:ext uri="{BB962C8B-B14F-4D97-AF65-F5344CB8AC3E}">
-        <p14:creationId xmlns:p14="http://schemas.microsoft.com/office/powerpoint/2010/main" val="19142228"/>
+        <p14:creationId xmlns:p14="http://schemas.microsoft.com/office/powerpoint/2010/main" val="1778222932"/>
       </p:ext>
     </p:extLst>
   </p:cSld>
@@ -2646,7 +4503,7 @@
           <p:cNvPr id="5" name="">
             <a:extLst xmlns:a="http://schemas.openxmlformats.org/drawingml/2006/main">
               <a:ext uri="{FF2B5EF4-FFF2-40B4-BE49-F238E27FC236}">
-                <a16:creationId xmlns:a16="http://schemas.microsoft.com/office/drawing/2014/main" id="{61FDA347-7F0E-45AB-9FC3-A6934C9809BA}"/>
+                <a16:creationId xmlns:a16="http://schemas.microsoft.com/office/drawing/2014/main" id="{05BED945-9C34-4B20-AF46-87406FABA4B1}"/>
               </a:ext>
             </a:extLst>
           </p:cNvPr>
@@ -2703,7 +4560,7 @@
           <p:cNvPr id="2" name="">
             <a:extLst xmlns:a="http://schemas.openxmlformats.org/drawingml/2006/main">
               <a:ext uri="{FF2B5EF4-FFF2-40B4-BE49-F238E27FC236}">
-                <a16:creationId xmlns:a16="http://schemas.microsoft.com/office/drawing/2014/main" id="{45AFE86C-0021-459B-ABF5-269CAABFFF76}"/>
+                <a16:creationId xmlns:a16="http://schemas.microsoft.com/office/drawing/2014/main" id="{4979EBCE-0ADA-47F5-B6C6-2C08EFCA86C9}"/>
               </a:ext>
             </a:extLst>
           </p:cNvPr>
@@ -2760,7 +4617,7 @@
           <p:cNvPr id="3" name="">
             <a:extLst xmlns:a="http://schemas.openxmlformats.org/drawingml/2006/main">
               <a:ext uri="{FF2B5EF4-FFF2-40B4-BE49-F238E27FC236}">
-                <a16:creationId xmlns:a16="http://schemas.microsoft.com/office/drawing/2014/main" id="{601CF620-D7D4-4FF0-8758-98D9F95668E1}"/>
+                <a16:creationId xmlns:a16="http://schemas.microsoft.com/office/drawing/2014/main" id="{FFF29971-CE25-4B64-A104-C46EED6697E0}"/>
               </a:ext>
             </a:extLst>
           </p:cNvPr>
@@ -2821,7 +4678,7 @@
           <p:nvPr/>
         </p:nvPicPr>
         <p:blipFill>
-          <a:blip xmlns:r="http://schemas.openxmlformats.org/officeDocument/2006/relationships" xmlns:a="http://schemas.openxmlformats.org/drawingml/2006/main" r:embed="Re2f8081d9cd84db4"/>
+          <a:blip xmlns:r="http://schemas.openxmlformats.org/officeDocument/2006/relationships" xmlns:a="http://schemas.openxmlformats.org/drawingml/2006/main" r:embed="R5223b735eafc46e7"/>
           <a:stretch xmlns:a="http://schemas.openxmlformats.org/drawingml/2006/main"/>
         </p:blipFill>
         <p:spPr>
@@ -2837,7 +4694,7 @@
     </p:spTree>
     <p:extLst>
       <p:ext uri="{BB962C8B-B14F-4D97-AF65-F5344CB8AC3E}">
-        <p14:creationId xmlns:p14="http://schemas.microsoft.com/office/powerpoint/2010/main" val="371335670"/>
+        <p14:creationId xmlns:p14="http://schemas.microsoft.com/office/powerpoint/2010/main" val="1328665889"/>
       </p:ext>
     </p:extLst>
   </p:cSld>
@@ -2868,7 +4725,7 @@
           <p:cNvPr id="5" name="">
             <a:extLst xmlns:a="http://schemas.openxmlformats.org/drawingml/2006/main">
               <a:ext uri="{FF2B5EF4-FFF2-40B4-BE49-F238E27FC236}">
-                <a16:creationId xmlns:a16="http://schemas.microsoft.com/office/drawing/2014/main" id="{EE8DF113-6AB8-4D7B-B831-2A0632A0F49A}"/>
+                <a16:creationId xmlns:a16="http://schemas.microsoft.com/office/drawing/2014/main" id="{6556DDF9-2CB3-4BAE-BC8C-81BA5485DFB7}"/>
               </a:ext>
             </a:extLst>
           </p:cNvPr>
@@ -2925,7 +4782,7 @@
           <p:cNvPr id="2" name="">
             <a:extLst xmlns:a="http://schemas.openxmlformats.org/drawingml/2006/main">
               <a:ext uri="{FF2B5EF4-FFF2-40B4-BE49-F238E27FC236}">
-                <a16:creationId xmlns:a16="http://schemas.microsoft.com/office/drawing/2014/main" id="{570B64DF-F1E2-45C8-A011-F792195F4299}"/>
+                <a16:creationId xmlns:a16="http://schemas.microsoft.com/office/drawing/2014/main" id="{89779615-EB02-4FAD-9698-B8FDA0F52640}"/>
               </a:ext>
             </a:extLst>
           </p:cNvPr>
@@ -2982,7 +4839,7 @@
           <p:cNvPr id="3" name="">
             <a:extLst xmlns:a="http://schemas.openxmlformats.org/drawingml/2006/main">
               <a:ext uri="{FF2B5EF4-FFF2-40B4-BE49-F238E27FC236}">
-                <a16:creationId xmlns:a16="http://schemas.microsoft.com/office/drawing/2014/main" id="{191933D4-6CE2-40ED-895D-29C34C37660F}"/>
+                <a16:creationId xmlns:a16="http://schemas.microsoft.com/office/drawing/2014/main" id="{6ABAC7D9-32D1-425B-B0FD-E735E35A0B4D}"/>
               </a:ext>
             </a:extLst>
           </p:cNvPr>
@@ -3043,7 +4900,7 @@
           <p:nvPr/>
         </p:nvPicPr>
         <p:blipFill>
-          <a:blip xmlns:r="http://schemas.openxmlformats.org/officeDocument/2006/relationships" xmlns:a="http://schemas.openxmlformats.org/drawingml/2006/main" r:embed="R66cfca1af6c749f8"/>
+          <a:blip xmlns:r="http://schemas.openxmlformats.org/officeDocument/2006/relationships" xmlns:a="http://schemas.openxmlformats.org/drawingml/2006/main" r:embed="R91c0bba1dc944622"/>
           <a:stretch xmlns:a="http://schemas.openxmlformats.org/drawingml/2006/main"/>
         </p:blipFill>
         <p:spPr>
@@ -3059,7 +4916,7 @@
     </p:spTree>
     <p:extLst>
       <p:ext uri="{BB962C8B-B14F-4D97-AF65-F5344CB8AC3E}">
-        <p14:creationId xmlns:p14="http://schemas.microsoft.com/office/powerpoint/2010/main" val="735280249"/>
+        <p14:creationId xmlns:p14="http://schemas.microsoft.com/office/powerpoint/2010/main" val="1935320746"/>
       </p:ext>
     </p:extLst>
   </p:cSld>
@@ -3090,7 +4947,7 @@
           <p:cNvPr id="5" name="">
             <a:extLst xmlns:a="http://schemas.openxmlformats.org/drawingml/2006/main">
               <a:ext uri="{FF2B5EF4-FFF2-40B4-BE49-F238E27FC236}">
-                <a16:creationId xmlns:a16="http://schemas.microsoft.com/office/drawing/2014/main" id="{D724C525-E87A-4F4B-81C9-252F4F23E028}"/>
+                <a16:creationId xmlns:a16="http://schemas.microsoft.com/office/drawing/2014/main" id="{202BCDDD-091A-4185-86F5-1364FAA98755}"/>
               </a:ext>
             </a:extLst>
           </p:cNvPr>
@@ -3147,7 +5004,7 @@
           <p:cNvPr id="2" name="">
             <a:extLst xmlns:a="http://schemas.openxmlformats.org/drawingml/2006/main">
               <a:ext uri="{FF2B5EF4-FFF2-40B4-BE49-F238E27FC236}">
-                <a16:creationId xmlns:a16="http://schemas.microsoft.com/office/drawing/2014/main" id="{930A7441-2E21-46F7-ADB0-F9832D21047C}"/>
+                <a16:creationId xmlns:a16="http://schemas.microsoft.com/office/drawing/2014/main" id="{173618C2-8B01-4C42-AF50-34CA2CC311D3}"/>
               </a:ext>
             </a:extLst>
           </p:cNvPr>
@@ -3204,7 +5061,7 @@
           <p:cNvPr id="3" name="">
             <a:extLst xmlns:a="http://schemas.openxmlformats.org/drawingml/2006/main">
               <a:ext uri="{FF2B5EF4-FFF2-40B4-BE49-F238E27FC236}">
-                <a16:creationId xmlns:a16="http://schemas.microsoft.com/office/drawing/2014/main" id="{EC8724E5-94D0-4D13-B00B-B6D100A53DC6}"/>
+                <a16:creationId xmlns:a16="http://schemas.microsoft.com/office/drawing/2014/main" id="{ED097DC3-C13C-454C-8C64-EA8E86DC683C}"/>
               </a:ext>
             </a:extLst>
           </p:cNvPr>
@@ -3265,7 +5122,7 @@
           <p:nvPr/>
         </p:nvPicPr>
         <p:blipFill>
-          <a:blip xmlns:r="http://schemas.openxmlformats.org/officeDocument/2006/relationships" xmlns:a="http://schemas.openxmlformats.org/drawingml/2006/main" r:embed="R34fc4a70244844af"/>
+          <a:blip xmlns:r="http://schemas.openxmlformats.org/officeDocument/2006/relationships" xmlns:a="http://schemas.openxmlformats.org/drawingml/2006/main" r:embed="Rf57f637aaec94605"/>
           <a:stretch xmlns:a="http://schemas.openxmlformats.org/drawingml/2006/main"/>
         </p:blipFill>
         <p:spPr>
@@ -3281,7 +5138,7 @@
     </p:spTree>
     <p:extLst>
       <p:ext uri="{BB962C8B-B14F-4D97-AF65-F5344CB8AC3E}">
-        <p14:creationId xmlns:p14="http://schemas.microsoft.com/office/powerpoint/2010/main" val="867337500"/>
+        <p14:creationId xmlns:p14="http://schemas.microsoft.com/office/powerpoint/2010/main" val="917130261"/>
       </p:ext>
     </p:extLst>
   </p:cSld>
@@ -3309,10 +5166,10 @@
       </p:grpSpPr>
       <p:sp>
         <p:nvSpPr>
-          <p:cNvPr id="10" name="">
+          <p:cNvPr id="6" name="">
             <a:extLst xmlns:a="http://schemas.openxmlformats.org/drawingml/2006/main">
               <a:ext uri="{FF2B5EF4-FFF2-40B4-BE49-F238E27FC236}">
-                <a16:creationId xmlns:a16="http://schemas.microsoft.com/office/drawing/2014/main" id="{2D8D6BA7-FE0E-445F-B721-5A053144F21E}"/>
+                <a16:creationId xmlns:a16="http://schemas.microsoft.com/office/drawing/2014/main" id="{1ACAB929-8FBC-4124-B5DB-557EF3B64141}"/>
               </a:ext>
             </a:extLst>
           </p:cNvPr>
@@ -3359,7 +5216,7 @@
                 <a:ea typeface="Arial"/>
                 <a:cs typeface="Arial"/>
               </a:rPr>
-              <a:t>Skill installation</a:t>
+              <a:t>Zotero access</a:t>
             </a:r>
           </a:p>
         </p:txBody>
@@ -3369,7 +5226,7 @@
           <p:cNvPr id="2" name="">
             <a:extLst xmlns:a="http://schemas.openxmlformats.org/drawingml/2006/main">
               <a:ext uri="{FF2B5EF4-FFF2-40B4-BE49-F238E27FC236}">
-                <a16:creationId xmlns:a16="http://schemas.microsoft.com/office/drawing/2014/main" id="{F0E5919E-08B7-470D-9D01-96E069E64F7A}"/>
+                <a16:creationId xmlns:a16="http://schemas.microsoft.com/office/drawing/2014/main" id="{DC1FF6B6-7032-44CC-8906-8238FA7D55F1}"/>
               </a:ext>
             </a:extLst>
           </p:cNvPr>
@@ -3426,7 +5283,292 @@
           <p:cNvPr id="3" name="">
             <a:extLst xmlns:a="http://schemas.openxmlformats.org/drawingml/2006/main">
               <a:ext uri="{FF2B5EF4-FFF2-40B4-BE49-F238E27FC236}">
-                <a16:creationId xmlns:a16="http://schemas.microsoft.com/office/drawing/2014/main" id="{4DED6F1D-2C2E-4C42-BECF-37225952C8FC}"/>
+                <a16:creationId xmlns:a16="http://schemas.microsoft.com/office/drawing/2014/main" id="{7971DF77-AC87-4F69-920D-2AF95A4FE5B6}"/>
+              </a:ext>
+            </a:extLst>
+          </p:cNvPr>
+          <p:cNvSpPr>
+            <a:spLocks xmlns:a="http://schemas.openxmlformats.org/drawingml/2006/main" noGrp="1"/>
+          </p:cNvSpPr>
+          <p:nvPr/>
+        </p:nvSpPr>
+        <p:spPr>
+          <a:xfrm xmlns:a="http://schemas.openxmlformats.org/drawingml/2006/main">
+            <a:off x="609600" y="1028700"/>
+            <a:ext cx="10972800" cy="342900"/>
+          </a:xfrm>
+          <a:prstGeom xmlns:a="http://schemas.openxmlformats.org/drawingml/2006/main" prst="rect">
+            <a:avLst/>
+          </a:prstGeom>
+          <a:noFill xmlns:a="http://schemas.openxmlformats.org/drawingml/2006/main"/>
+          <a:ln xmlns:a="http://schemas.openxmlformats.org/drawingml/2006/main" w="0">
+            <a:noFill/>
+          </a:ln>
+        </p:spPr>
+        <p:txBody>
+          <a:bodyPr xmlns:a="http://schemas.openxmlformats.org/drawingml/2006/main" wrap="none" lIns="0" tIns="0" rIns="0" bIns="0" anchor="t">
+            <a:noAutofit/>
+          </a:bodyPr>
+          <a:lstStyle xmlns:a="http://schemas.openxmlformats.org/drawingml/2006/main"/>
+          <a:p xmlns:a="http://schemas.openxmlformats.org/drawingml/2006/main">
+            <a:pPr algn="l">
+              <a:defRPr sz="1875" b="0">
+                <a:solidFill>
+                  <a:srgbClr val="172C31"/>
+                </a:solidFill>
+                <a:latin typeface="Arial"/>
+                <a:ea typeface="Arial"/>
+                <a:cs typeface="Arial"/>
+              </a:defRPr>
+            </a:pPr>
+            <a:r>
+              <a:rPr sz="1875" b="0">
+                <a:solidFill>
+                  <a:srgbClr val="172C31"/>
+                </a:solidFill>
+                <a:latin typeface="Arial"/>
+                <a:ea typeface="Arial"/>
+                <a:cs typeface="Arial"/>
+              </a:rPr>
+              <a:t>In Zotero Settings → Advanced, enable the highlighted option.</a:t>
+            </a:r>
+          </a:p>
+        </p:txBody>
+      </p:sp>
+      <p:pic>
+        <p:nvPicPr>
+          <p:cNvPr id="9" name=""/>
+          <p:cNvPicPr>
+            <a:picLocks xmlns:a="http://schemas.openxmlformats.org/drawingml/2006/main" noChangeAspect="1"/>
+          </p:cNvPicPr>
+          <p:nvPr/>
+        </p:nvPicPr>
+        <p:blipFill>
+          <a:blip xmlns:r="http://schemas.openxmlformats.org/officeDocument/2006/relationships" xmlns:a="http://schemas.openxmlformats.org/drawingml/2006/main" r:embed="R99d92f1f63194144">
+            <a:extLst>
+              <a:ext uri="{96DAC541-7B7A-43D3-8B79-37D633B846F1}">
+                <asvg:svgBlip xmlns:asvg="http://schemas.microsoft.com/office/drawing/2016/SVG/main" r:embed="R8c557e7085164916"/>
+              </a:ext>
+            </a:extLst>
+          </a:blip>
+          <a:stretch xmlns:a="http://schemas.openxmlformats.org/drawingml/2006/main"/>
+        </p:blipFill>
+        <p:spPr>
+          <a:xfrm xmlns:a="http://schemas.openxmlformats.org/drawingml/2006/main">
+            <a:off x="609600" y="1668292"/>
+            <a:ext cx="10972800" cy="3921467"/>
+          </a:xfrm>
+          <a:prstGeom xmlns:a="http://schemas.openxmlformats.org/drawingml/2006/main" prst="rect">
+            <a:avLst/>
+          </a:prstGeom>
+        </p:spPr>
+      </p:pic>
+      <p:sp>
+        <p:nvSpPr>
+          <p:cNvPr id="5" name="">
+            <a:extLst xmlns:a="http://schemas.openxmlformats.org/drawingml/2006/main">
+              <a:ext uri="{FF2B5EF4-FFF2-40B4-BE49-F238E27FC236}">
+                <a16:creationId xmlns:a16="http://schemas.microsoft.com/office/drawing/2014/main" id="{49972772-17B7-4491-B947-78D32E1BD5C9}"/>
+              </a:ext>
+            </a:extLst>
+          </p:cNvPr>
+          <p:cNvSpPr>
+            <a:spLocks xmlns:a="http://schemas.openxmlformats.org/drawingml/2006/main" noGrp="1"/>
+          </p:cNvSpPr>
+          <p:nvPr/>
+        </p:nvSpPr>
+        <p:spPr>
+          <a:xfrm xmlns:a="http://schemas.openxmlformats.org/drawingml/2006/main">
+            <a:off x="609600" y="5924550"/>
+            <a:ext cx="10972800" cy="342900"/>
+          </a:xfrm>
+          <a:prstGeom xmlns:a="http://schemas.openxmlformats.org/drawingml/2006/main" prst="rect">
+            <a:avLst/>
+          </a:prstGeom>
+          <a:noFill xmlns:a="http://schemas.openxmlformats.org/drawingml/2006/main"/>
+          <a:ln xmlns:a="http://schemas.openxmlformats.org/drawingml/2006/main" w="0">
+            <a:noFill/>
+          </a:ln>
+        </p:spPr>
+        <p:txBody>
+          <a:bodyPr xmlns:a="http://schemas.openxmlformats.org/drawingml/2006/main" wrap="none" lIns="0" tIns="0" rIns="0" bIns="0" anchor="t">
+            <a:noAutofit/>
+          </a:bodyPr>
+          <a:lstStyle xmlns:a="http://schemas.openxmlformats.org/drawingml/2006/main"/>
+          <a:p xmlns:a="http://schemas.openxmlformats.org/drawingml/2006/main">
+            <a:pPr algn="l">
+              <a:defRPr sz="1875" b="0">
+                <a:solidFill>
+                  <a:srgbClr val="536166"/>
+                </a:solidFill>
+                <a:latin typeface="Arial"/>
+                <a:ea typeface="Arial"/>
+                <a:cs typeface="Arial"/>
+              </a:defRPr>
+            </a:pPr>
+            <a:r>
+              <a:rPr sz="1875" b="0">
+                <a:solidFill>
+                  <a:srgbClr val="536166"/>
+                </a:solidFill>
+                <a:latin typeface="Arial"/>
+                <a:ea typeface="Arial"/>
+                <a:cs typeface="Arial"/>
+              </a:rPr>
+              <a:t>Keep Zotero desktop open so Codex can check your library and read saved text.</a:t>
+            </a:r>
+          </a:p>
+        </p:txBody>
+      </p:sp>
+    </p:spTree>
+    <p:extLst>
+      <p:ext uri="{BB962C8B-B14F-4D97-AF65-F5344CB8AC3E}">
+        <p14:creationId xmlns:p14="http://schemas.microsoft.com/office/powerpoint/2010/main" val="1125414157"/>
+      </p:ext>
+    </p:extLst>
+  </p:cSld>
+</p:sld>
+</file>
+
+<file path=ppt/slides/slide7.xml><?xml version="1.0" encoding="utf-8"?>
+<p:sld xmlns:p="http://schemas.openxmlformats.org/presentationml/2006/main">
+  <p:cSld>
+    <p:bg>
+      <p:bgPr>
+        <a:solidFill xmlns:a="http://schemas.openxmlformats.org/drawingml/2006/main">
+          <a:srgbClr val="FFFFFF"/>
+        </a:solidFill>
+      </p:bgPr>
+    </p:bg>
+    <p:spTree>
+      <p:nvGrpSpPr>
+        <p:cNvPr id="1" name=""/>
+        <p:cNvGrpSpPr/>
+        <p:nvPr/>
+      </p:nvGrpSpPr>
+      <p:grpSpPr>
+        <a:xfrm xmlns:a="http://schemas.openxmlformats.org/drawingml/2006/main"/>
+      </p:grpSpPr>
+      <p:sp>
+        <p:nvSpPr>
+          <p:cNvPr id="10" name="">
+            <a:extLst xmlns:a="http://schemas.openxmlformats.org/drawingml/2006/main">
+              <a:ext uri="{FF2B5EF4-FFF2-40B4-BE49-F238E27FC236}">
+                <a16:creationId xmlns:a16="http://schemas.microsoft.com/office/drawing/2014/main" id="{C991F367-3184-4418-9F75-11C633A9902C}"/>
+              </a:ext>
+            </a:extLst>
+          </p:cNvPr>
+          <p:cNvSpPr>
+            <a:spLocks xmlns:a="http://schemas.openxmlformats.org/drawingml/2006/main" noGrp="1"/>
+          </p:cNvSpPr>
+          <p:nvPr/>
+        </p:nvSpPr>
+        <p:spPr>
+          <a:xfrm xmlns:a="http://schemas.openxmlformats.org/drawingml/2006/main">
+            <a:off x="609600" y="361950"/>
+            <a:ext cx="10972800" cy="571500"/>
+          </a:xfrm>
+          <a:prstGeom xmlns:a="http://schemas.openxmlformats.org/drawingml/2006/main" prst="rect">
+            <a:avLst/>
+          </a:prstGeom>
+          <a:noFill xmlns:a="http://schemas.openxmlformats.org/drawingml/2006/main"/>
+          <a:ln xmlns:a="http://schemas.openxmlformats.org/drawingml/2006/main" w="0">
+            <a:noFill/>
+          </a:ln>
+        </p:spPr>
+        <p:txBody>
+          <a:bodyPr xmlns:a="http://schemas.openxmlformats.org/drawingml/2006/main" wrap="none" lIns="0" tIns="0" rIns="0" bIns="0" anchor="t">
+            <a:noAutofit/>
+          </a:bodyPr>
+          <a:lstStyle xmlns:a="http://schemas.openxmlformats.org/drawingml/2006/main"/>
+          <a:p xmlns:a="http://schemas.openxmlformats.org/drawingml/2006/main">
+            <a:pPr algn="l">
+              <a:defRPr sz="3300" b="1">
+                <a:solidFill>
+                  <a:srgbClr val="147477"/>
+                </a:solidFill>
+                <a:latin typeface="Arial"/>
+                <a:ea typeface="Arial"/>
+                <a:cs typeface="Arial"/>
+              </a:defRPr>
+            </a:pPr>
+            <a:r>
+              <a:rPr sz="3300" b="1">
+                <a:solidFill>
+                  <a:srgbClr val="147477"/>
+                </a:solidFill>
+                <a:latin typeface="Arial"/>
+                <a:ea typeface="Arial"/>
+                <a:cs typeface="Arial"/>
+              </a:rPr>
+              <a:t>Skill installation</a:t>
+            </a:r>
+          </a:p>
+        </p:txBody>
+      </p:sp>
+      <p:sp>
+        <p:nvSpPr>
+          <p:cNvPr id="2" name="">
+            <a:extLst xmlns:a="http://schemas.openxmlformats.org/drawingml/2006/main">
+              <a:ext uri="{FF2B5EF4-FFF2-40B4-BE49-F238E27FC236}">
+                <a16:creationId xmlns:a16="http://schemas.microsoft.com/office/drawing/2014/main" id="{678A159B-3CA1-47F9-9C4A-43213354E795}"/>
+              </a:ext>
+            </a:extLst>
+          </p:cNvPr>
+          <p:cNvSpPr>
+            <a:spLocks xmlns:a="http://schemas.openxmlformats.org/drawingml/2006/main" noGrp="1"/>
+          </p:cNvSpPr>
+          <p:nvPr/>
+        </p:nvSpPr>
+        <p:spPr>
+          <a:xfrm xmlns:a="http://schemas.openxmlformats.org/drawingml/2006/main">
+            <a:off x="11125200" y="6448425"/>
+            <a:ext cx="457200" cy="228600"/>
+          </a:xfrm>
+          <a:prstGeom xmlns:a="http://schemas.openxmlformats.org/drawingml/2006/main" prst="rect">
+            <a:avLst/>
+          </a:prstGeom>
+          <a:noFill xmlns:a="http://schemas.openxmlformats.org/drawingml/2006/main"/>
+          <a:ln xmlns:a="http://schemas.openxmlformats.org/drawingml/2006/main" w="0">
+            <a:noFill/>
+          </a:ln>
+        </p:spPr>
+        <p:txBody>
+          <a:bodyPr xmlns:a="http://schemas.openxmlformats.org/drawingml/2006/main" wrap="none" lIns="0" tIns="0" rIns="0" bIns="0" anchor="t">
+            <a:noAutofit/>
+          </a:bodyPr>
+          <a:lstStyle xmlns:a="http://schemas.openxmlformats.org/drawingml/2006/main"/>
+          <a:p xmlns:a="http://schemas.openxmlformats.org/drawingml/2006/main">
+            <a:pPr algn="r">
+              <a:defRPr sz="1275" b="0">
+                <a:solidFill>
+                  <a:srgbClr val="536166"/>
+                </a:solidFill>
+                <a:latin typeface="Arial"/>
+                <a:ea typeface="Arial"/>
+                <a:cs typeface="Arial"/>
+              </a:defRPr>
+            </a:pPr>
+            <a:r>
+              <a:rPr sz="1275" b="0">
+                <a:solidFill>
+                  <a:srgbClr val="536166"/>
+                </a:solidFill>
+                <a:latin typeface="Arial"/>
+                <a:ea typeface="Arial"/>
+                <a:cs typeface="Arial"/>
+              </a:rPr>
+              <a:t>7</a:t>
+            </a:r>
+          </a:p>
+        </p:txBody>
+      </p:sp>
+      <p:sp>
+        <p:nvSpPr>
+          <p:cNvPr id="3" name="">
+            <a:extLst xmlns:a="http://schemas.openxmlformats.org/drawingml/2006/main">
+              <a:ext uri="{FF2B5EF4-FFF2-40B4-BE49-F238E27FC236}">
+                <a16:creationId xmlns:a16="http://schemas.microsoft.com/office/drawing/2014/main" id="{147ACC5C-4D93-4448-B1DE-A9C37EC6C140}"/>
               </a:ext>
             </a:extLst>
           </p:cNvPr>
@@ -3483,7 +5625,7 @@
           <p:cNvPr id="4" name="">
             <a:extLst xmlns:a="http://schemas.openxmlformats.org/drawingml/2006/main">
               <a:ext uri="{FF2B5EF4-FFF2-40B4-BE49-F238E27FC236}">
-                <a16:creationId xmlns:a16="http://schemas.microsoft.com/office/drawing/2014/main" id="{FC1E24D2-28C0-4D6A-B932-7C57553F03A5}"/>
+                <a16:creationId xmlns:a16="http://schemas.microsoft.com/office/drawing/2014/main" id="{2D665317-4307-4CCF-9F8A-D4527E677C57}"/>
               </a:ext>
             </a:extLst>
           </p:cNvPr>
@@ -3513,7 +5655,7 @@
           <p:cNvPr id="5" name="">
             <a:extLst xmlns:a="http://schemas.openxmlformats.org/drawingml/2006/main">
               <a:ext uri="{FF2B5EF4-FFF2-40B4-BE49-F238E27FC236}">
-                <a16:creationId xmlns:a16="http://schemas.microsoft.com/office/drawing/2014/main" id="{DC320228-87DD-4C18-BDBC-656C31D6F3E7}"/>
+                <a16:creationId xmlns:a16="http://schemas.microsoft.com/office/drawing/2014/main" id="{F2B9AB8A-7110-4AD0-939A-0A3A78AFD92A}"/>
               </a:ext>
             </a:extLst>
           </p:cNvPr>
@@ -3570,7 +5712,7 @@
           <p:cNvPr id="6" name="">
             <a:extLst xmlns:a="http://schemas.openxmlformats.org/drawingml/2006/main">
               <a:ext uri="{FF2B5EF4-FFF2-40B4-BE49-F238E27FC236}">
-                <a16:creationId xmlns:a16="http://schemas.microsoft.com/office/drawing/2014/main" id="{65DEFC21-1089-4F95-8CFD-456559D89A9B}"/>
+                <a16:creationId xmlns:a16="http://schemas.microsoft.com/office/drawing/2014/main" id="{89DB719E-BB46-4BE5-96B3-0BAE68C179A7}"/>
               </a:ext>
             </a:extLst>
           </p:cNvPr>
@@ -3616,7 +5758,7 @@
                 <a:latin typeface="Courier New"/>
                 <a:ea typeface="Courier New"/>
                 <a:cs typeface="Courier New"/>
-                <a:hlinkClick xmlns:r="http://schemas.openxmlformats.org/officeDocument/2006/relationships" r:id="Rd5fc1ac702664a7b"/>
+                <a:hlinkClick xmlns:r="http://schemas.openxmlformats.org/officeDocument/2006/relationships" r:id="Re49cd519556a4d94"/>
               </a:rPr>
               <a:t>https://github.com/Alias-z/agentic-researcher-psc</a:t>
             </a:r>
@@ -3628,7 +5770,7 @@
           <p:cNvPr id="7" name="">
             <a:extLst xmlns:a="http://schemas.openxmlformats.org/drawingml/2006/main">
               <a:ext uri="{FF2B5EF4-FFF2-40B4-BE49-F238E27FC236}">
-                <a16:creationId xmlns:a16="http://schemas.microsoft.com/office/drawing/2014/main" id="{7E13A7BB-76FC-4A53-8B80-527A2F87F086}"/>
+                <a16:creationId xmlns:a16="http://schemas.microsoft.com/office/drawing/2014/main" id="{1749A9F3-F6F3-4F4A-BFAA-68696978A309}"/>
               </a:ext>
             </a:extLst>
           </p:cNvPr>
@@ -3685,7 +5827,7 @@
           <p:cNvPr id="8" name="">
             <a:extLst xmlns:a="http://schemas.openxmlformats.org/drawingml/2006/main">
               <a:ext uri="{FF2B5EF4-FFF2-40B4-BE49-F238E27FC236}">
-                <a16:creationId xmlns:a16="http://schemas.microsoft.com/office/drawing/2014/main" id="{99D5F6B8-3407-4145-9E74-0E14E9EA1851}"/>
+                <a16:creationId xmlns:a16="http://schemas.microsoft.com/office/drawing/2014/main" id="{2D0ABF89-CB51-40F0-B399-28FB9640E947}"/>
               </a:ext>
             </a:extLst>
           </p:cNvPr>
@@ -3742,7 +5884,7 @@
           <p:cNvPr id="9" name="">
             <a:extLst xmlns:a="http://schemas.openxmlformats.org/drawingml/2006/main">
               <a:ext uri="{FF2B5EF4-FFF2-40B4-BE49-F238E27FC236}">
-                <a16:creationId xmlns:a16="http://schemas.microsoft.com/office/drawing/2014/main" id="{EC4FBA50-7311-4A3B-BAB4-E69E0C8AC4FB}"/>
+                <a16:creationId xmlns:a16="http://schemas.microsoft.com/office/drawing/2014/main" id="{5A178D26-AA45-463C-B2E5-A34B9350E7F1}"/>
               </a:ext>
             </a:extLst>
           </p:cNvPr>
@@ -3789,7 +5931,7 @@
                 <a:ea typeface="Arial"/>
                 <a:cs typeface="Arial"/>
               </a:rPr>
-              <a:t>After installation, type @ to find paper-search and zotero-save.</a:t>
+              <a:t>To use a skill later, type @ and select paper-search or zotero-save.</a:t>
             </a:r>
           </a:p>
         </p:txBody>
@@ -3797,7 +5939,349 @@
     </p:spTree>
     <p:extLst>
       <p:ext uri="{BB962C8B-B14F-4D97-AF65-F5344CB8AC3E}">
-        <p14:creationId xmlns:p14="http://schemas.microsoft.com/office/powerpoint/2010/main" val="1549333895"/>
+        <p14:creationId xmlns:p14="http://schemas.microsoft.com/office/powerpoint/2010/main" val="1187832934"/>
+      </p:ext>
+    </p:extLst>
+  </p:cSld>
+</p:sld>
+</file>
+
+<file path=ppt/slides/slide8.xml><?xml version="1.0" encoding="utf-8"?>
+<p:sld xmlns:p="http://schemas.openxmlformats.org/presentationml/2006/main">
+  <p:cSld>
+    <p:bg>
+      <p:bgPr>
+        <a:solidFill xmlns:a="http://schemas.openxmlformats.org/drawingml/2006/main">
+          <a:srgbClr val="FFFFFF"/>
+        </a:solidFill>
+      </p:bgPr>
+    </p:bg>
+    <p:spTree>
+      <p:nvGrpSpPr>
+        <p:cNvPr id="1" name=""/>
+        <p:cNvGrpSpPr/>
+        <p:nvPr/>
+      </p:nvGrpSpPr>
+      <p:grpSpPr>
+        <a:xfrm xmlns:a="http://schemas.openxmlformats.org/drawingml/2006/main"/>
+      </p:grpSpPr>
+      <p:sp>
+        <p:nvSpPr>
+          <p:cNvPr id="7" name="">
+            <a:extLst xmlns:a="http://schemas.openxmlformats.org/drawingml/2006/main">
+              <a:ext uri="{FF2B5EF4-FFF2-40B4-BE49-F238E27FC236}">
+                <a16:creationId xmlns:a16="http://schemas.microsoft.com/office/drawing/2014/main" id="{21C08B76-601B-474F-807F-A0BE41557D26}"/>
+              </a:ext>
+            </a:extLst>
+          </p:cNvPr>
+          <p:cNvSpPr>
+            <a:spLocks xmlns:a="http://schemas.openxmlformats.org/drawingml/2006/main" noGrp="1"/>
+          </p:cNvSpPr>
+          <p:nvPr/>
+        </p:nvSpPr>
+        <p:spPr>
+          <a:xfrm xmlns:a="http://schemas.openxmlformats.org/drawingml/2006/main">
+            <a:off x="609600" y="361950"/>
+            <a:ext cx="10972800" cy="571500"/>
+          </a:xfrm>
+          <a:prstGeom xmlns:a="http://schemas.openxmlformats.org/drawingml/2006/main" prst="rect">
+            <a:avLst/>
+          </a:prstGeom>
+          <a:noFill xmlns:a="http://schemas.openxmlformats.org/drawingml/2006/main"/>
+          <a:ln xmlns:a="http://schemas.openxmlformats.org/drawingml/2006/main" w="0">
+            <a:noFill/>
+          </a:ln>
+        </p:spPr>
+        <p:txBody>
+          <a:bodyPr xmlns:a="http://schemas.openxmlformats.org/drawingml/2006/main" wrap="none" lIns="0" tIns="0" rIns="0" bIns="0" anchor="t">
+            <a:noAutofit/>
+          </a:bodyPr>
+          <a:lstStyle xmlns:a="http://schemas.openxmlformats.org/drawingml/2006/main"/>
+          <a:p xmlns:a="http://schemas.openxmlformats.org/drawingml/2006/main">
+            <a:pPr algn="l">
+              <a:defRPr sz="3300" b="1">
+                <a:solidFill>
+                  <a:srgbClr val="147477"/>
+                </a:solidFill>
+                <a:latin typeface="Arial"/>
+                <a:ea typeface="Arial"/>
+                <a:cs typeface="Arial"/>
+              </a:defRPr>
+            </a:pPr>
+            <a:r>
+              <a:rPr sz="3300" b="1">
+                <a:solidFill>
+                  <a:srgbClr val="147477"/>
+                </a:solidFill>
+                <a:latin typeface="Arial"/>
+                <a:ea typeface="Arial"/>
+                <a:cs typeface="Arial"/>
+              </a:rPr>
+              <a:t>Zotero plugin</a:t>
+            </a:r>
+          </a:p>
+        </p:txBody>
+      </p:sp>
+      <p:sp>
+        <p:nvSpPr>
+          <p:cNvPr id="2" name="">
+            <a:extLst xmlns:a="http://schemas.openxmlformats.org/drawingml/2006/main">
+              <a:ext uri="{FF2B5EF4-FFF2-40B4-BE49-F238E27FC236}">
+                <a16:creationId xmlns:a16="http://schemas.microsoft.com/office/drawing/2014/main" id="{F1710C09-0B9A-4851-B90A-0D66000FA7B0}"/>
+              </a:ext>
+            </a:extLst>
+          </p:cNvPr>
+          <p:cNvSpPr>
+            <a:spLocks xmlns:a="http://schemas.openxmlformats.org/drawingml/2006/main" noGrp="1"/>
+          </p:cNvSpPr>
+          <p:nvPr/>
+        </p:nvSpPr>
+        <p:spPr>
+          <a:xfrm xmlns:a="http://schemas.openxmlformats.org/drawingml/2006/main">
+            <a:off x="11125200" y="6448425"/>
+            <a:ext cx="457200" cy="228600"/>
+          </a:xfrm>
+          <a:prstGeom xmlns:a="http://schemas.openxmlformats.org/drawingml/2006/main" prst="rect">
+            <a:avLst/>
+          </a:prstGeom>
+          <a:noFill xmlns:a="http://schemas.openxmlformats.org/drawingml/2006/main"/>
+          <a:ln xmlns:a="http://schemas.openxmlformats.org/drawingml/2006/main" w="0">
+            <a:noFill/>
+          </a:ln>
+        </p:spPr>
+        <p:txBody>
+          <a:bodyPr xmlns:a="http://schemas.openxmlformats.org/drawingml/2006/main" wrap="none" lIns="0" tIns="0" rIns="0" bIns="0" anchor="t">
+            <a:noAutofit/>
+          </a:bodyPr>
+          <a:lstStyle xmlns:a="http://schemas.openxmlformats.org/drawingml/2006/main"/>
+          <a:p xmlns:a="http://schemas.openxmlformats.org/drawingml/2006/main">
+            <a:pPr algn="r">
+              <a:defRPr sz="1275" b="0">
+                <a:solidFill>
+                  <a:srgbClr val="536166"/>
+                </a:solidFill>
+                <a:latin typeface="Arial"/>
+                <a:ea typeface="Arial"/>
+                <a:cs typeface="Arial"/>
+              </a:defRPr>
+            </a:pPr>
+            <a:r>
+              <a:rPr sz="1275" b="0">
+                <a:solidFill>
+                  <a:srgbClr val="536166"/>
+                </a:solidFill>
+                <a:latin typeface="Arial"/>
+                <a:ea typeface="Arial"/>
+                <a:cs typeface="Arial"/>
+              </a:rPr>
+              <a:t>8</a:t>
+            </a:r>
+          </a:p>
+        </p:txBody>
+      </p:sp>
+      <p:sp>
+        <p:nvSpPr>
+          <p:cNvPr id="3" name="">
+            <a:extLst xmlns:a="http://schemas.openxmlformats.org/drawingml/2006/main">
+              <a:ext uri="{FF2B5EF4-FFF2-40B4-BE49-F238E27FC236}">
+                <a16:creationId xmlns:a16="http://schemas.microsoft.com/office/drawing/2014/main" id="{DC7E4424-F79A-4E88-94BF-A25EBB074248}"/>
+              </a:ext>
+            </a:extLst>
+          </p:cNvPr>
+          <p:cNvSpPr>
+            <a:spLocks xmlns:a="http://schemas.openxmlformats.org/drawingml/2006/main" noGrp="1"/>
+          </p:cNvSpPr>
+          <p:nvPr/>
+        </p:nvSpPr>
+        <p:spPr>
+          <a:xfrm xmlns:a="http://schemas.openxmlformats.org/drawingml/2006/main">
+            <a:off x="609600" y="1028700"/>
+            <a:ext cx="10972800" cy="342900"/>
+          </a:xfrm>
+          <a:prstGeom xmlns:a="http://schemas.openxmlformats.org/drawingml/2006/main" prst="rect">
+            <a:avLst/>
+          </a:prstGeom>
+          <a:noFill xmlns:a="http://schemas.openxmlformats.org/drawingml/2006/main"/>
+          <a:ln xmlns:a="http://schemas.openxmlformats.org/drawingml/2006/main" w="0">
+            <a:noFill/>
+          </a:ln>
+        </p:spPr>
+        <p:txBody>
+          <a:bodyPr xmlns:a="http://schemas.openxmlformats.org/drawingml/2006/main" wrap="none" lIns="0" tIns="0" rIns="0" bIns="0" anchor="t">
+            <a:noAutofit/>
+          </a:bodyPr>
+          <a:lstStyle xmlns:a="http://schemas.openxmlformats.org/drawingml/2006/main"/>
+          <a:p xmlns:a="http://schemas.openxmlformats.org/drawingml/2006/main">
+            <a:pPr algn="l">
+              <a:defRPr sz="1875" b="0">
+                <a:solidFill>
+                  <a:srgbClr val="172C31"/>
+                </a:solidFill>
+                <a:latin typeface="Arial"/>
+                <a:ea typeface="Arial"/>
+                <a:cs typeface="Arial"/>
+              </a:defRPr>
+            </a:pPr>
+            <a:r>
+              <a:rPr sz="1875" b="0">
+                <a:solidFill>
+                  <a:srgbClr val="172C31"/>
+                </a:solidFill>
+                <a:latin typeface="Arial"/>
+                <a:ea typeface="Arial"/>
+                <a:cs typeface="Arial"/>
+              </a:rPr>
+              <a:t>In Codex Plugins, search "zotero" and install Zotero for use in later chats.</a:t>
+            </a:r>
+          </a:p>
+        </p:txBody>
+      </p:sp>
+      <p:pic>
+        <p:nvPicPr>
+          <p:cNvPr id="10" name=""/>
+          <p:cNvPicPr>
+            <a:picLocks xmlns:a="http://schemas.openxmlformats.org/drawingml/2006/main" noChangeAspect="1"/>
+          </p:cNvPicPr>
+          <p:nvPr/>
+        </p:nvPicPr>
+        <p:blipFill>
+          <a:blip xmlns:r="http://schemas.openxmlformats.org/officeDocument/2006/relationships" xmlns:a="http://schemas.openxmlformats.org/drawingml/2006/main" r:embed="Rea6416b8b9fe4ac9">
+            <a:extLst>
+              <a:ext uri="{96DAC541-7B7A-43D3-8B79-37D633B846F1}">
+                <asvg:svgBlip xmlns:asvg="http://schemas.microsoft.com/office/drawing/2016/SVG/main" r:embed="R179d0d545753495e"/>
+              </a:ext>
+            </a:extLst>
+          </a:blip>
+          <a:stretch xmlns:a="http://schemas.openxmlformats.org/drawingml/2006/main"/>
+        </p:blipFill>
+        <p:spPr>
+          <a:xfrm xmlns:a="http://schemas.openxmlformats.org/drawingml/2006/main">
+            <a:off x="609600" y="1722680"/>
+            <a:ext cx="10972800" cy="3345966"/>
+          </a:xfrm>
+          <a:prstGeom xmlns:a="http://schemas.openxmlformats.org/drawingml/2006/main" prst="rect">
+            <a:avLst/>
+          </a:prstGeom>
+        </p:spPr>
+      </p:pic>
+      <p:sp>
+        <p:nvSpPr>
+          <p:cNvPr id="5" name="">
+            <a:extLst xmlns:a="http://schemas.openxmlformats.org/drawingml/2006/main">
+              <a:ext uri="{FF2B5EF4-FFF2-40B4-BE49-F238E27FC236}">
+                <a16:creationId xmlns:a16="http://schemas.microsoft.com/office/drawing/2014/main" id="{8AA3BC82-9D62-414C-A473-CA98FCCCC9B6}"/>
+              </a:ext>
+            </a:extLst>
+          </p:cNvPr>
+          <p:cNvSpPr>
+            <a:spLocks xmlns:a="http://schemas.openxmlformats.org/drawingml/2006/main" noGrp="1"/>
+          </p:cNvSpPr>
+          <p:nvPr/>
+        </p:nvSpPr>
+        <p:spPr>
+          <a:xfrm xmlns:a="http://schemas.openxmlformats.org/drawingml/2006/main">
+            <a:off x="609600" y="5534025"/>
+            <a:ext cx="10972800" cy="342900"/>
+          </a:xfrm>
+          <a:prstGeom xmlns:a="http://schemas.openxmlformats.org/drawingml/2006/main" prst="rect">
+            <a:avLst/>
+          </a:prstGeom>
+          <a:noFill xmlns:a="http://schemas.openxmlformats.org/drawingml/2006/main"/>
+          <a:ln xmlns:a="http://schemas.openxmlformats.org/drawingml/2006/main" w="0">
+            <a:noFill/>
+          </a:ln>
+        </p:spPr>
+        <p:txBody>
+          <a:bodyPr xmlns:a="http://schemas.openxmlformats.org/drawingml/2006/main" wrap="none" lIns="0" tIns="0" rIns="0" bIns="0" anchor="t">
+            <a:noAutofit/>
+          </a:bodyPr>
+          <a:lstStyle xmlns:a="http://schemas.openxmlformats.org/drawingml/2006/main"/>
+          <a:p xmlns:a="http://schemas.openxmlformats.org/drawingml/2006/main">
+            <a:pPr algn="l">
+              <a:defRPr sz="1875" b="0">
+                <a:solidFill>
+                  <a:srgbClr val="172C31"/>
+                </a:solidFill>
+                <a:latin typeface="Arial"/>
+                <a:ea typeface="Arial"/>
+                <a:cs typeface="Arial"/>
+              </a:defRPr>
+            </a:pPr>
+            <a:r>
+              <a:rPr sz="1875" b="0">
+                <a:solidFill>
+                  <a:srgbClr val="172C31"/>
+                </a:solidFill>
+                <a:latin typeface="Arial"/>
+                <a:ea typeface="Arial"/>
+                <a:cs typeface="Arial"/>
+              </a:rPr>
+              <a:t>paper-search finds papers; zotero-save saves selected papers and available PDFs.</a:t>
+            </a:r>
+          </a:p>
+        </p:txBody>
+      </p:sp>
+      <p:sp>
+        <p:nvSpPr>
+          <p:cNvPr id="6" name="">
+            <a:extLst xmlns:a="http://schemas.openxmlformats.org/drawingml/2006/main">
+              <a:ext uri="{FF2B5EF4-FFF2-40B4-BE49-F238E27FC236}">
+                <a16:creationId xmlns:a16="http://schemas.microsoft.com/office/drawing/2014/main" id="{1C6D4B31-A9DB-4749-91A3-433CA4E0CA6C}"/>
+              </a:ext>
+            </a:extLst>
+          </p:cNvPr>
+          <p:cNvSpPr>
+            <a:spLocks xmlns:a="http://schemas.openxmlformats.org/drawingml/2006/main" noGrp="1"/>
+          </p:cNvSpPr>
+          <p:nvPr/>
+        </p:nvSpPr>
+        <p:spPr>
+          <a:xfrm xmlns:a="http://schemas.openxmlformats.org/drawingml/2006/main">
+            <a:off x="609600" y="5953125"/>
+            <a:ext cx="10972800" cy="342900"/>
+          </a:xfrm>
+          <a:prstGeom xmlns:a="http://schemas.openxmlformats.org/drawingml/2006/main" prst="rect">
+            <a:avLst/>
+          </a:prstGeom>
+          <a:noFill xmlns:a="http://schemas.openxmlformats.org/drawingml/2006/main"/>
+          <a:ln xmlns:a="http://schemas.openxmlformats.org/drawingml/2006/main" w="0">
+            <a:noFill/>
+          </a:ln>
+        </p:spPr>
+        <p:txBody>
+          <a:bodyPr xmlns:a="http://schemas.openxmlformats.org/drawingml/2006/main" wrap="none" lIns="0" tIns="0" rIns="0" bIns="0" anchor="t">
+            <a:noAutofit/>
+          </a:bodyPr>
+          <a:lstStyle xmlns:a="http://schemas.openxmlformats.org/drawingml/2006/main"/>
+          <a:p xmlns:a="http://schemas.openxmlformats.org/drawingml/2006/main">
+            <a:pPr algn="l">
+              <a:defRPr sz="1875" b="0">
+                <a:solidFill>
+                  <a:srgbClr val="172C31"/>
+                </a:solidFill>
+                <a:latin typeface="Arial"/>
+                <a:ea typeface="Arial"/>
+                <a:cs typeface="Arial"/>
+              </a:defRPr>
+            </a:pPr>
+            <a:r>
+              <a:rPr sz="1875" b="0">
+                <a:solidFill>
+                  <a:srgbClr val="172C31"/>
+                </a:solidFill>
+                <a:latin typeface="Arial"/>
+                <a:ea typeface="Arial"/>
+                <a:cs typeface="Arial"/>
+              </a:rPr>
+              <a:t>The Zotero plugin reads their indexed text and helps with citations.</a:t>
+            </a:r>
+          </a:p>
+        </p:txBody>
+      </p:sp>
+    </p:spTree>
+    <p:extLst>
+      <p:ext uri="{BB962C8B-B14F-4D97-AF65-F5344CB8AC3E}">
+        <p14:creationId xmlns:p14="http://schemas.microsoft.com/office/powerpoint/2010/main" val="703869016"/>
       </p:ext>
     </p:extLst>
   </p:cSld>

</xml_diff>

<commit_message>
Update setup guides and slides for paper reading
</commit_message>
<xml_diff>
--- a/instructor/slides/setup-guide.pptx
+++ b/instructor/slides/setup-guide.pptx
@@ -2,20 +2,22 @@
 <file path=ppt/presentation.xml><?xml version="1.0" encoding="utf-8"?>
 <p:presentation xmlns:p="http://schemas.openxmlformats.org/presentationml/2006/main">
   <p:sldMasterIdLst>
-    <p:sldMasterId xmlns:r="http://schemas.openxmlformats.org/officeDocument/2006/relationships" id="2147483648" r:id="R67ea7e9663744c25"/>
+    <p:sldMasterId xmlns:r="http://schemas.openxmlformats.org/officeDocument/2006/relationships" id="2147483648" r:id="Rbf55f5c4a530476a"/>
   </p:sldMasterIdLst>
   <p:notesMasterIdLst>
-    <p:notesMasterId xmlns:r="http://schemas.openxmlformats.org/officeDocument/2006/relationships" r:id="Rc393efa7404046be"/>
+    <p:notesMasterId xmlns:r="http://schemas.openxmlformats.org/officeDocument/2006/relationships" r:id="Ra96c6a4509c74cfb"/>
   </p:notesMasterIdLst>
   <p:sldIdLst>
-    <p:sldId xmlns:r="http://schemas.openxmlformats.org/officeDocument/2006/relationships" id="256" r:id="Re75a54cff5b146ec"/>
-    <p:sldId xmlns:r="http://schemas.openxmlformats.org/officeDocument/2006/relationships" id="257" r:id="R0473a9edafba4b99"/>
-    <p:sldId xmlns:r="http://schemas.openxmlformats.org/officeDocument/2006/relationships" id="258" r:id="R8ca9eada82d041f1"/>
-    <p:sldId xmlns:r="http://schemas.openxmlformats.org/officeDocument/2006/relationships" id="259" r:id="Re05ba07ed5f441b7"/>
-    <p:sldId xmlns:r="http://schemas.openxmlformats.org/officeDocument/2006/relationships" id="260" r:id="R72054d61978e4e9c"/>
-    <p:sldId xmlns:r="http://schemas.openxmlformats.org/officeDocument/2006/relationships" id="261" r:id="R6996b0afb4754c6d"/>
-    <p:sldId xmlns:r="http://schemas.openxmlformats.org/officeDocument/2006/relationships" id="262" r:id="Rcc2d807de4c64ad1"/>
-    <p:sldId xmlns:r="http://schemas.openxmlformats.org/officeDocument/2006/relationships" id="263" r:id="R700d676d0a624860"/>
+    <p:sldId xmlns:r="http://schemas.openxmlformats.org/officeDocument/2006/relationships" id="256" r:id="Rdbacbaa27f1d4ab4"/>
+    <p:sldId xmlns:r="http://schemas.openxmlformats.org/officeDocument/2006/relationships" id="257" r:id="Ra5575241ab6f43e9"/>
+    <p:sldId xmlns:r="http://schemas.openxmlformats.org/officeDocument/2006/relationships" id="258" r:id="Rc7bfc77f671041bb"/>
+    <p:sldId xmlns:r="http://schemas.openxmlformats.org/officeDocument/2006/relationships" id="259" r:id="R1da71a29f4694048"/>
+    <p:sldId xmlns:r="http://schemas.openxmlformats.org/officeDocument/2006/relationships" id="260" r:id="R6b6e696145f042c2"/>
+    <p:sldId xmlns:r="http://schemas.openxmlformats.org/officeDocument/2006/relationships" id="261" r:id="Rdfcbdc2ad78b43b5"/>
+    <p:sldId xmlns:r="http://schemas.openxmlformats.org/officeDocument/2006/relationships" id="262" r:id="R13d99ff35b6c4439"/>
+    <p:sldId xmlns:r="http://schemas.openxmlformats.org/officeDocument/2006/relationships" id="263" r:id="R4a38621e6c754d55"/>
+    <p:sldId xmlns:r="http://schemas.openxmlformats.org/officeDocument/2006/relationships" id="264" r:id="Ra208aeb081f64c27"/>
+    <p:sldId xmlns:r="http://schemas.openxmlformats.org/officeDocument/2006/relationships" id="265" r:id="R06a27245ada74f92"/>
   </p:sldIdLst>
   <p:sldSz cx="12192000" cy="6858000"/>
   <p:notesSz cx="6858000" cy="9144000"/>
@@ -479,6 +481,76 @@
 </p:notes>
 </file>
 
+<file path=ppt/notesSlides/notesSlide10.xml><?xml version="1.0" encoding="utf-8"?>
+<p:notes xmlns:p="http://schemas.openxmlformats.org/presentationml/2006/main">
+  <p:cSld>
+    <p:spTree>
+      <p:nvGrpSpPr>
+        <p:cNvPr id="1" name=""/>
+        <p:cNvGrpSpPr/>
+        <p:nvPr/>
+      </p:nvGrpSpPr>
+      <p:grpSpPr>
+        <a:xfrm xmlns:a="http://schemas.openxmlformats.org/drawingml/2006/main"/>
+      </p:grpSpPr>
+      <p:sp>
+        <p:nvSpPr>
+          <p:cNvPr id="2" name="Slide Image Placeholder 1"/>
+          <p:cNvSpPr>
+            <a:spLocks xmlns:a="http://schemas.openxmlformats.org/drawingml/2006/main" noGrp="1"/>
+          </p:cNvSpPr>
+          <p:nvPr>
+            <p:ph type="sldImg" idx="0"/>
+          </p:nvPr>
+        </p:nvSpPr>
+        <p:spPr/>
+      </p:sp>
+      <p:sp>
+        <p:nvSpPr>
+          <p:cNvPr id="3" name="Notes Placeholder 2"/>
+          <p:cNvSpPr>
+            <a:spLocks xmlns:a="http://schemas.openxmlformats.org/drawingml/2006/main" noGrp="1"/>
+          </p:cNvSpPr>
+          <p:nvPr>
+            <p:ph type="body" idx="1"/>
+          </p:nvPr>
+        </p:nvSpPr>
+        <p:spPr/>
+        <p:txBody>
+          <a:bodyPr xmlns:a="http://schemas.openxmlformats.org/drawingml/2006/main"/>
+          <a:lstStyle xmlns:a="http://schemas.openxmlformats.org/drawingml/2006/main"/>
+          <a:p xmlns:a="http://schemas.openxmlformats.org/drawingml/2006/main">
+            <a:r>
+              <a:t>Source: workshop/01-literature-to-zotero.md, sections 3–5. These are example prompts; replace bracketed text. Read a paper first and inspect its saved note. Only approve content after checking it against the original paper. Unreviewed notes remain usable with their status stated; ask for reviewed-only evidence when desired. Discussion uses keyword retrieval plus original evidence, and newly read findings are saved back to notes.</a:t>
+            </a:r>
+          </a:p>
+        </p:txBody>
+      </p:sp>
+      <p:sp>
+        <p:nvSpPr>
+          <p:cNvPr id="4" name="Slide Number Placeholder 3"/>
+          <p:cNvSpPr>
+            <a:spLocks xmlns:a="http://schemas.openxmlformats.org/drawingml/2006/main" noGrp="1"/>
+          </p:cNvSpPr>
+          <p:nvPr>
+            <p:ph type="sldNum" idx="5"/>
+          </p:nvPr>
+        </p:nvSpPr>
+        <p:spPr/>
+        <p:txBody>
+          <a:bodyPr xmlns:a="http://schemas.openxmlformats.org/drawingml/2006/main"/>
+          <a:lstStyle xmlns:a="http://schemas.openxmlformats.org/drawingml/2006/main"/>
+          <a:p xmlns:a="http://schemas.openxmlformats.org/drawingml/2006/main"/>
+        </p:txBody>
+      </p:sp>
+    </p:spTree>
+  </p:cSld>
+  <p:clrMapOvr>
+    <a:masterClrMapping xmlns:a="http://schemas.openxmlformats.org/drawingml/2006/main"/>
+  </p:clrMapOvr>
+</p:notes>
+</file>
+
 <file path=ppt/notesSlides/notesSlide2.xml><?xml version="1.0" encoding="utf-8"?>
 <p:notes xmlns:p="http://schemas.openxmlformats.org/presentationml/2006/main">
   <p:cSld>
@@ -869,7 +941,7 @@
           <a:lstStyle xmlns:a="http://schemas.openxmlformats.org/drawingml/2006/main"/>
           <a:p xmlns:a="http://schemas.openxmlformats.org/drawingml/2006/main">
             <a:r>
-              <a:t>Source: workshop/00-start-here.md. Repository: https://github.com/Alias-z/agentic-researcher-psc</a:t>
+              <a:t>Source: workshop/00-start-here.md. Repository: https://github.com/Alias-z/agentic-researcher-psc. The bundled skill-installer accepts multiple repository paths and makes skills available on the next turn. If the first two skills are already installed, ask to install only skills/paper-reading. Skills can be requested by name: https://learn.chatgpt.com/docs/skills-and-plugins.</a:t>
             </a:r>
           </a:p>
         </p:txBody>
@@ -939,7 +1011,77 @@
           <a:lstStyle xmlns:a="http://schemas.openxmlformats.org/drawingml/2006/main"/>
           <a:p xmlns:a="http://schemas.openxmlformats.org/drawingml/2006/main">
             <a:r>
-              <a:t>Screenshot supplied by the instructor: Screenshot 2026-09-28 at 19.08.39.png. Plugin installation: https://learn.chatgpt.com/docs/plugins. Reading and citation capabilities were checked against the installed Zotero 0.1.2 skill and helper. The plugin reads indexed attachment text; it does not replace our publisher Connector/PDF save workflow. The original screenshot is preserved; the SVG adds red outlines and crops the recent chat list.</a:t>
+              <a:t>Screenshot supplied by the instructor: Screenshot 2026-09-28 at 19.08.39.png. Plugin installation: https://learn.chatgpt.com/docs/plugins. Reading and citation capabilities were checked against the installed Zotero 0.1.2 skill and helper. The plugin provides general library searches and citation exports. paper-reading includes its own local API helper. The original screenshot is preserved; the SVG adds red outlines and crops the recent chat list.</a:t>
+            </a:r>
+          </a:p>
+        </p:txBody>
+      </p:sp>
+      <p:sp>
+        <p:nvSpPr>
+          <p:cNvPr id="4" name="Slide Number Placeholder 3"/>
+          <p:cNvSpPr>
+            <a:spLocks xmlns:a="http://schemas.openxmlformats.org/drawingml/2006/main" noGrp="1"/>
+          </p:cNvSpPr>
+          <p:nvPr>
+            <p:ph type="sldNum" idx="5"/>
+          </p:nvPr>
+        </p:nvSpPr>
+        <p:spPr/>
+        <p:txBody>
+          <a:bodyPr xmlns:a="http://schemas.openxmlformats.org/drawingml/2006/main"/>
+          <a:lstStyle xmlns:a="http://schemas.openxmlformats.org/drawingml/2006/main"/>
+          <a:p xmlns:a="http://schemas.openxmlformats.org/drawingml/2006/main"/>
+        </p:txBody>
+      </p:sp>
+    </p:spTree>
+  </p:cSld>
+  <p:clrMapOvr>
+    <a:masterClrMapping xmlns:a="http://schemas.openxmlformats.org/drawingml/2006/main"/>
+  </p:clrMapOvr>
+</p:notes>
+</file>
+
+<file path=ppt/notesSlides/notesSlide9.xml><?xml version="1.0" encoding="utf-8"?>
+<p:notes xmlns:p="http://schemas.openxmlformats.org/presentationml/2006/main">
+  <p:cSld>
+    <p:spTree>
+      <p:nvGrpSpPr>
+        <p:cNvPr id="1" name=""/>
+        <p:cNvGrpSpPr/>
+        <p:nvPr/>
+      </p:nvGrpSpPr>
+      <p:grpSpPr>
+        <a:xfrm xmlns:a="http://schemas.openxmlformats.org/drawingml/2006/main"/>
+      </p:grpSpPr>
+      <p:sp>
+        <p:nvSpPr>
+          <p:cNvPr id="2" name="Slide Image Placeholder 1"/>
+          <p:cNvSpPr>
+            <a:spLocks xmlns:a="http://schemas.openxmlformats.org/drawingml/2006/main" noGrp="1"/>
+          </p:cNvSpPr>
+          <p:nvPr>
+            <p:ph type="sldImg" idx="0"/>
+          </p:nvPr>
+        </p:nvSpPr>
+        <p:spPr/>
+      </p:sp>
+      <p:sp>
+        <p:nvSpPr>
+          <p:cNvPr id="3" name="Notes Placeholder 2"/>
+          <p:cNvSpPr>
+            <a:spLocks xmlns:a="http://schemas.openxmlformats.org/drawingml/2006/main" noGrp="1"/>
+          </p:cNvSpPr>
+          <p:nvPr>
+            <p:ph type="body" idx="1"/>
+          </p:nvPr>
+        </p:nvSpPr>
+        <p:spPr/>
+        <p:txBody>
+          <a:bodyPr xmlns:a="http://schemas.openxmlformats.org/drawingml/2006/main"/>
+          <a:lstStyle xmlns:a="http://schemas.openxmlformats.org/drawingml/2006/main"/>
+          <a:p xmlns:a="http://schemas.openxmlformats.org/drawingml/2006/main">
+            <a:r>
+              <a:t>Sources: skills/paper-reading/SKILL.md and workshop/00-start-here.md. One Markdown source file per paper; a generated HTML child note sits beside the PDF under that paper in Zotero. The HTML copy links to the Markdown source. The file remains in the chosen writing/notes folder, or task deliverables. Zotero searches generated note text by keyword. The Markdown file itself is not uploaded by its link. Refresh the Zotero copy after manual edits; there is no background synchronization. Local API writes require Zotero 10+ and application authorization: https://www.zotero.org/support/dev/web_api/v3/local_api.</a:t>
             </a:r>
           </a:p>
         </p:txBody>
@@ -986,7 +1128,7 @@
           <p:cNvPr id="4" name="Accent rule">
             <a:extLst xmlns:a="http://schemas.openxmlformats.org/drawingml/2006/main">
               <a:ext uri="{FF2B5EF4-FFF2-40B4-BE49-F238E27FC236}">
-                <a16:creationId xmlns:a16="http://schemas.microsoft.com/office/drawing/2014/main" id="{B82C36B7-AF5C-4A9B-9C3A-6DEEFD765C32}"/>
+                <a16:creationId xmlns:a16="http://schemas.microsoft.com/office/drawing/2014/main" id="{52E1CF1A-7902-47F2-BE90-C5356459E2BC}"/>
               </a:ext>
             </a:extLst>
           </p:cNvPr>
@@ -1017,7 +1159,7 @@
           <p:cNvPr id="2" name="Title">
             <a:extLst xmlns:a="http://schemas.openxmlformats.org/drawingml/2006/main">
               <a:ext uri="{FF2B5EF4-FFF2-40B4-BE49-F238E27FC236}">
-                <a16:creationId xmlns:a16="http://schemas.microsoft.com/office/drawing/2014/main" id="{2B7D8A81-8970-43C4-A0A9-85F335AB6370}"/>
+                <a16:creationId xmlns:a16="http://schemas.microsoft.com/office/drawing/2014/main" id="{9C3F1BA7-F7A2-4E83-8977-5E6AD2A25A6E}"/>
               </a:ext>
             </a:extLst>
           </p:cNvPr>
@@ -1164,7 +1306,7 @@
           <p:cNvPr id="3" name="Subtitle">
             <a:extLst xmlns:a="http://schemas.openxmlformats.org/drawingml/2006/main">
               <a:ext uri="{FF2B5EF4-FFF2-40B4-BE49-F238E27FC236}">
-                <a16:creationId xmlns:a16="http://schemas.microsoft.com/office/drawing/2014/main" id="{03FC80FC-D146-4EF2-A33B-547AF8148035}"/>
+                <a16:creationId xmlns:a16="http://schemas.microsoft.com/office/drawing/2014/main" id="{02B5433C-61FD-4E4D-BE45-282CDB96AC31}"/>
               </a:ext>
             </a:extLst>
           </p:cNvPr>
@@ -1328,7 +1470,7 @@
           <p:cNvPr id="3" name="Accent rule">
             <a:extLst xmlns:a="http://schemas.openxmlformats.org/drawingml/2006/main">
               <a:ext uri="{FF2B5EF4-FFF2-40B4-BE49-F238E27FC236}">
-                <a16:creationId xmlns:a16="http://schemas.microsoft.com/office/drawing/2014/main" id="{168B1544-AA7C-4EA0-A9D9-978C8EC910C1}"/>
+                <a16:creationId xmlns:a16="http://schemas.microsoft.com/office/drawing/2014/main" id="{67391AE0-1683-4168-AAA6-7AB636629039}"/>
               </a:ext>
             </a:extLst>
           </p:cNvPr>
@@ -1359,7 +1501,7 @@
           <p:cNvPr id="2" name="Section title">
             <a:extLst xmlns:a="http://schemas.openxmlformats.org/drawingml/2006/main">
               <a:ext uri="{FF2B5EF4-FFF2-40B4-BE49-F238E27FC236}">
-                <a16:creationId xmlns:a16="http://schemas.microsoft.com/office/drawing/2014/main" id="{321E2848-676D-4DF0-88F1-2446A341735D}"/>
+                <a16:creationId xmlns:a16="http://schemas.microsoft.com/office/drawing/2014/main" id="{D880530F-5229-4E7F-BD56-8A78F3BEF39B}"/>
               </a:ext>
             </a:extLst>
           </p:cNvPr>
@@ -1523,7 +1665,7 @@
           <p:cNvPr id="4" name="Accent rule">
             <a:extLst xmlns:a="http://schemas.openxmlformats.org/drawingml/2006/main">
               <a:ext uri="{FF2B5EF4-FFF2-40B4-BE49-F238E27FC236}">
-                <a16:creationId xmlns:a16="http://schemas.microsoft.com/office/drawing/2014/main" id="{F23C18A9-19A0-4D7F-8DC5-A520FE3172B0}"/>
+                <a16:creationId xmlns:a16="http://schemas.microsoft.com/office/drawing/2014/main" id="{310B5149-5C7B-4B2A-8CE2-955373BA2347}"/>
               </a:ext>
             </a:extLst>
           </p:cNvPr>
@@ -1554,7 +1696,7 @@
           <p:cNvPr id="2" name="Title">
             <a:extLst xmlns:a="http://schemas.openxmlformats.org/drawingml/2006/main">
               <a:ext uri="{FF2B5EF4-FFF2-40B4-BE49-F238E27FC236}">
-                <a16:creationId xmlns:a16="http://schemas.microsoft.com/office/drawing/2014/main" id="{AF0DFA36-855B-49FD-9900-2279CB258097}"/>
+                <a16:creationId xmlns:a16="http://schemas.microsoft.com/office/drawing/2014/main" id="{446D283B-6D33-4CA4-B68D-47B2BD93B757}"/>
               </a:ext>
             </a:extLst>
           </p:cNvPr>
@@ -1701,7 +1843,7 @@
           <p:cNvPr id="3" name="Body">
             <a:extLst xmlns:a="http://schemas.openxmlformats.org/drawingml/2006/main">
               <a:ext uri="{FF2B5EF4-FFF2-40B4-BE49-F238E27FC236}">
-                <a16:creationId xmlns:a16="http://schemas.microsoft.com/office/drawing/2014/main" id="{FC987463-31CA-48D1-9615-E71CC5AFC63F}"/>
+                <a16:creationId xmlns:a16="http://schemas.microsoft.com/office/drawing/2014/main" id="{06FC522C-F861-4634-BCCE-FEE56F86CB7A}"/>
               </a:ext>
             </a:extLst>
           </p:cNvPr>
@@ -1865,7 +2007,7 @@
           <p:cNvPr id="5" name="Accent rule">
             <a:extLst xmlns:a="http://schemas.openxmlformats.org/drawingml/2006/main">
               <a:ext uri="{FF2B5EF4-FFF2-40B4-BE49-F238E27FC236}">
-                <a16:creationId xmlns:a16="http://schemas.microsoft.com/office/drawing/2014/main" id="{1A1887C7-6AB2-4DBC-B422-00412D0E95C0}"/>
+                <a16:creationId xmlns:a16="http://schemas.microsoft.com/office/drawing/2014/main" id="{4969F048-4BD2-4F99-92EB-787F87D6CB49}"/>
               </a:ext>
             </a:extLst>
           </p:cNvPr>
@@ -1896,7 +2038,7 @@
           <p:cNvPr id="2" name="Title">
             <a:extLst xmlns:a="http://schemas.openxmlformats.org/drawingml/2006/main">
               <a:ext uri="{FF2B5EF4-FFF2-40B4-BE49-F238E27FC236}">
-                <a16:creationId xmlns:a16="http://schemas.microsoft.com/office/drawing/2014/main" id="{7C2F7817-2D04-48CE-B005-AB8D637C1C10}"/>
+                <a16:creationId xmlns:a16="http://schemas.microsoft.com/office/drawing/2014/main" id="{F4F94A7E-4C73-4229-B227-7316C968C833}"/>
               </a:ext>
             </a:extLst>
           </p:cNvPr>
@@ -2043,7 +2185,7 @@
           <p:cNvPr id="3" name="Left column">
             <a:extLst xmlns:a="http://schemas.openxmlformats.org/drawingml/2006/main">
               <a:ext uri="{FF2B5EF4-FFF2-40B4-BE49-F238E27FC236}">
-                <a16:creationId xmlns:a16="http://schemas.microsoft.com/office/drawing/2014/main" id="{40AF1AA6-A3B2-4735-B76C-27B4154C248D}"/>
+                <a16:creationId xmlns:a16="http://schemas.microsoft.com/office/drawing/2014/main" id="{4C98D008-0BDF-4D76-BF2E-33CB88E0DD52}"/>
               </a:ext>
             </a:extLst>
           </p:cNvPr>
@@ -2190,7 +2332,7 @@
           <p:cNvPr id="4" name="Right column">
             <a:extLst xmlns:a="http://schemas.openxmlformats.org/drawingml/2006/main">
               <a:ext uri="{FF2B5EF4-FFF2-40B4-BE49-F238E27FC236}">
-                <a16:creationId xmlns:a16="http://schemas.microsoft.com/office/drawing/2014/main" id="{6F0F9D44-7415-48D4-87AA-14132E5ADD9F}"/>
+                <a16:creationId xmlns:a16="http://schemas.microsoft.com/office/drawing/2014/main" id="{BA2F8E8D-A435-43F5-9782-9B8227DAC187}"/>
               </a:ext>
             </a:extLst>
           </p:cNvPr>
@@ -2354,7 +2496,7 @@
           <p:cNvPr id="4" name="Accent rule">
             <a:extLst xmlns:a="http://schemas.openxmlformats.org/drawingml/2006/main">
               <a:ext uri="{FF2B5EF4-FFF2-40B4-BE49-F238E27FC236}">
-                <a16:creationId xmlns:a16="http://schemas.microsoft.com/office/drawing/2014/main" id="{08651FAA-1B59-4F92-A742-91D1238B1A3D}"/>
+                <a16:creationId xmlns:a16="http://schemas.microsoft.com/office/drawing/2014/main" id="{16C6638E-98F9-413E-9817-80D7C23101AA}"/>
               </a:ext>
             </a:extLst>
           </p:cNvPr>
@@ -2385,7 +2527,7 @@
           <p:cNvPr id="2" name="Title">
             <a:extLst xmlns:a="http://schemas.openxmlformats.org/drawingml/2006/main">
               <a:ext uri="{FF2B5EF4-FFF2-40B4-BE49-F238E27FC236}">
-                <a16:creationId xmlns:a16="http://schemas.microsoft.com/office/drawing/2014/main" id="{22188AAA-157D-4F55-9345-68738F20D5ED}"/>
+                <a16:creationId xmlns:a16="http://schemas.microsoft.com/office/drawing/2014/main" id="{D679147E-4D85-4565-99FB-2AA17C01D9C4}"/>
               </a:ext>
             </a:extLst>
           </p:cNvPr>
@@ -2532,7 +2674,7 @@
           <p:cNvPr id="3" name="Left column">
             <a:extLst xmlns:a="http://schemas.openxmlformats.org/drawingml/2006/main">
               <a:ext uri="{FF2B5EF4-FFF2-40B4-BE49-F238E27FC236}">
-                <a16:creationId xmlns:a16="http://schemas.microsoft.com/office/drawing/2014/main" id="{8E3B5FA3-ADDA-4CAD-98F1-331D5CEAC4A5}"/>
+                <a16:creationId xmlns:a16="http://schemas.microsoft.com/office/drawing/2014/main" id="{A18157B5-0A52-4F1D-985A-3943D13B25C5}"/>
               </a:ext>
             </a:extLst>
           </p:cNvPr>
@@ -2717,12 +2859,12 @@
   </p:cSld>
   <p:clrMap bg1="lt1" tx1="dk1" bg2="lt2" tx2="dk2" accent1="accent1" accent2="accent2" accent3="accent3" accent4="accent4" accent5="accent5" accent6="accent6" hlink="hlink" folHlink="folHlink"/>
   <p:sldLayoutIdLst>
-    <p:sldLayoutId xmlns:r="http://schemas.openxmlformats.org/officeDocument/2006/relationships" id="2147483649" r:id="Rae4e7b42a3144ce3"/>
-    <p:sldLayoutId xmlns:r="http://schemas.openxmlformats.org/officeDocument/2006/relationships" id="2147483650" r:id="R9d7c8b58021b4b3d"/>
-    <p:sldLayoutId xmlns:r="http://schemas.openxmlformats.org/officeDocument/2006/relationships" id="2147483651" r:id="Rb82fbcc02f744429"/>
-    <p:sldLayoutId xmlns:r="http://schemas.openxmlformats.org/officeDocument/2006/relationships" id="2147483652" r:id="Rd7324638c22a404b"/>
-    <p:sldLayoutId xmlns:r="http://schemas.openxmlformats.org/officeDocument/2006/relationships" id="2147483653" r:id="R2e7fbcecd1114b18"/>
-    <p:sldLayoutId xmlns:r="http://schemas.openxmlformats.org/officeDocument/2006/relationships" id="2147483654" r:id="R5b7967cc86784807"/>
+    <p:sldLayoutId xmlns:r="http://schemas.openxmlformats.org/officeDocument/2006/relationships" id="2147483649" r:id="Rd74f8eb281ac4a11"/>
+    <p:sldLayoutId xmlns:r="http://schemas.openxmlformats.org/officeDocument/2006/relationships" id="2147483650" r:id="Rafe7c86664e648eb"/>
+    <p:sldLayoutId xmlns:r="http://schemas.openxmlformats.org/officeDocument/2006/relationships" id="2147483651" r:id="Rfb34c045fee74f74"/>
+    <p:sldLayoutId xmlns:r="http://schemas.openxmlformats.org/officeDocument/2006/relationships" id="2147483652" r:id="R8cbb85a93c1e4932"/>
+    <p:sldLayoutId xmlns:r="http://schemas.openxmlformats.org/officeDocument/2006/relationships" id="2147483653" r:id="Rc1dd825e06f24f44"/>
+    <p:sldLayoutId xmlns:r="http://schemas.openxmlformats.org/officeDocument/2006/relationships" id="2147483654" r:id="Rf3a28c46637046b0"/>
   </p:sldLayoutIdLst>
   <p:txStyles>
     <p:titleStyle>
@@ -3273,7 +3415,7 @@
           <p:cNvPr id="13" name="">
             <a:extLst xmlns:a="http://schemas.openxmlformats.org/drawingml/2006/main">
               <a:ext uri="{FF2B5EF4-FFF2-40B4-BE49-F238E27FC236}">
-                <a16:creationId xmlns:a16="http://schemas.microsoft.com/office/drawing/2014/main" id="{854BAC86-D50F-4CA4-86FF-A35534DCDD37}"/>
+                <a16:creationId xmlns:a16="http://schemas.microsoft.com/office/drawing/2014/main" id="{12AE8F7F-F9E3-417F-92E3-9E5F82866824}"/>
               </a:ext>
             </a:extLst>
           </p:cNvPr>
@@ -3330,7 +3472,7 @@
           <p:cNvPr id="2" name="">
             <a:extLst xmlns:a="http://schemas.openxmlformats.org/drawingml/2006/main">
               <a:ext uri="{FF2B5EF4-FFF2-40B4-BE49-F238E27FC236}">
-                <a16:creationId xmlns:a16="http://schemas.microsoft.com/office/drawing/2014/main" id="{FCD5273E-DA74-4253-9895-5D3707BDEBB8}"/>
+                <a16:creationId xmlns:a16="http://schemas.microsoft.com/office/drawing/2014/main" id="{4A32B294-1AED-4C5F-A08B-116DEF3F3915}"/>
               </a:ext>
             </a:extLst>
           </p:cNvPr>
@@ -3387,7 +3529,7 @@
           <p:cNvPr id="3" name="">
             <a:extLst xmlns:a="http://schemas.openxmlformats.org/drawingml/2006/main">
               <a:ext uri="{FF2B5EF4-FFF2-40B4-BE49-F238E27FC236}">
-                <a16:creationId xmlns:a16="http://schemas.microsoft.com/office/drawing/2014/main" id="{A2A73BE1-8D65-4986-A58A-C3835DE9E516}"/>
+                <a16:creationId xmlns:a16="http://schemas.microsoft.com/office/drawing/2014/main" id="{A5BD7248-60BA-4154-804E-DE5723DDB485}"/>
               </a:ext>
             </a:extLst>
           </p:cNvPr>
@@ -3444,7 +3586,7 @@
           <p:cNvPr id="4" name="">
             <a:extLst xmlns:a="http://schemas.openxmlformats.org/drawingml/2006/main">
               <a:ext uri="{FF2B5EF4-FFF2-40B4-BE49-F238E27FC236}">
-                <a16:creationId xmlns:a16="http://schemas.microsoft.com/office/drawing/2014/main" id="{CDC8D267-6AF2-4712-8058-172AE094B826}"/>
+                <a16:creationId xmlns:a16="http://schemas.microsoft.com/office/drawing/2014/main" id="{B79602D6-9B18-48C3-B63C-25BCFCD19664}"/>
               </a:ext>
             </a:extLst>
           </p:cNvPr>
@@ -3501,7 +3643,7 @@
           <p:cNvPr id="5" name="">
             <a:extLst xmlns:a="http://schemas.openxmlformats.org/drawingml/2006/main">
               <a:ext uri="{FF2B5EF4-FFF2-40B4-BE49-F238E27FC236}">
-                <a16:creationId xmlns:a16="http://schemas.microsoft.com/office/drawing/2014/main" id="{046FF2F1-A88F-4266-B354-F7179D344B22}"/>
+                <a16:creationId xmlns:a16="http://schemas.microsoft.com/office/drawing/2014/main" id="{C248DB5A-556E-4CC9-B0FE-26F5EFDDA321}"/>
               </a:ext>
             </a:extLst>
           </p:cNvPr>
@@ -3547,7 +3689,7 @@
                 <a:latin typeface="Arial"/>
                 <a:ea typeface="Arial"/>
                 <a:cs typeface="Arial"/>
-                <a:hlinkClick xmlns:r="http://schemas.openxmlformats.org/officeDocument/2006/relationships" r:id="Rcb3b22bee98d4a68"/>
+                <a:hlinkClick xmlns:r="http://schemas.openxmlformats.org/officeDocument/2006/relationships" r:id="R3dcec3ce070c4de3"/>
               </a:rPr>
               <a:t>chatgpt.com/download</a:t>
             </a:r>
@@ -3559,7 +3701,7 @@
           <p:cNvPr id="6" name="">
             <a:extLst xmlns:a="http://schemas.openxmlformats.org/drawingml/2006/main">
               <a:ext uri="{FF2B5EF4-FFF2-40B4-BE49-F238E27FC236}">
-                <a16:creationId xmlns:a16="http://schemas.microsoft.com/office/drawing/2014/main" id="{2B7DBE92-9AA3-4493-9BF5-81359BBB7320}"/>
+                <a16:creationId xmlns:a16="http://schemas.microsoft.com/office/drawing/2014/main" id="{76898EE7-91DE-4E7A-A081-C47B10926862}"/>
               </a:ext>
             </a:extLst>
           </p:cNvPr>
@@ -3616,7 +3758,7 @@
           <p:cNvPr id="7" name="">
             <a:extLst xmlns:a="http://schemas.openxmlformats.org/drawingml/2006/main">
               <a:ext uri="{FF2B5EF4-FFF2-40B4-BE49-F238E27FC236}">
-                <a16:creationId xmlns:a16="http://schemas.microsoft.com/office/drawing/2014/main" id="{634F2B0B-614C-4737-90B9-430FD69EC7FF}"/>
+                <a16:creationId xmlns:a16="http://schemas.microsoft.com/office/drawing/2014/main" id="{E0B5F882-CC20-4559-8921-70161C9B4F8C}"/>
               </a:ext>
             </a:extLst>
           </p:cNvPr>
@@ -3673,7 +3815,7 @@
           <p:cNvPr id="8" name="">
             <a:extLst xmlns:a="http://schemas.openxmlformats.org/drawingml/2006/main">
               <a:ext uri="{FF2B5EF4-FFF2-40B4-BE49-F238E27FC236}">
-                <a16:creationId xmlns:a16="http://schemas.microsoft.com/office/drawing/2014/main" id="{E0AB1BF5-100E-417D-8370-F07C894FA245}"/>
+                <a16:creationId xmlns:a16="http://schemas.microsoft.com/office/drawing/2014/main" id="{D91E68B5-F725-477E-8687-95ABDFB0186A}"/>
               </a:ext>
             </a:extLst>
           </p:cNvPr>
@@ -3719,7 +3861,7 @@
                 <a:latin typeface="Arial"/>
                 <a:ea typeface="Arial"/>
                 <a:cs typeface="Arial"/>
-                <a:hlinkClick xmlns:r="http://schemas.openxmlformats.org/officeDocument/2006/relationships" r:id="R961b7b4b2e0b450d"/>
+                <a:hlinkClick xmlns:r="http://schemas.openxmlformats.org/officeDocument/2006/relationships" r:id="R5a0d37d1fec04f19"/>
               </a:rPr>
               <a:t>google.com/chrome</a:t>
             </a:r>
@@ -3731,7 +3873,7 @@
           <p:cNvPr id="9" name="">
             <a:extLst xmlns:a="http://schemas.openxmlformats.org/drawingml/2006/main">
               <a:ext uri="{FF2B5EF4-FFF2-40B4-BE49-F238E27FC236}">
-                <a16:creationId xmlns:a16="http://schemas.microsoft.com/office/drawing/2014/main" id="{9E268C47-59CC-4B12-8438-B158D9AC2901}"/>
+                <a16:creationId xmlns:a16="http://schemas.microsoft.com/office/drawing/2014/main" id="{DEC5DF4C-00D3-4770-8197-073E09E2D299}"/>
               </a:ext>
             </a:extLst>
           </p:cNvPr>
@@ -3788,7 +3930,7 @@
           <p:cNvPr id="10" name="">
             <a:extLst xmlns:a="http://schemas.openxmlformats.org/drawingml/2006/main">
               <a:ext uri="{FF2B5EF4-FFF2-40B4-BE49-F238E27FC236}">
-                <a16:creationId xmlns:a16="http://schemas.microsoft.com/office/drawing/2014/main" id="{4B79ED39-55E2-467B-A748-C3707C7C3DFC}"/>
+                <a16:creationId xmlns:a16="http://schemas.microsoft.com/office/drawing/2014/main" id="{5982F392-EABA-4C9F-87B2-59E47B2651C0}"/>
               </a:ext>
             </a:extLst>
           </p:cNvPr>
@@ -3845,7 +3987,7 @@
           <p:cNvPr id="11" name="">
             <a:extLst xmlns:a="http://schemas.openxmlformats.org/drawingml/2006/main">
               <a:ext uri="{FF2B5EF4-FFF2-40B4-BE49-F238E27FC236}">
-                <a16:creationId xmlns:a16="http://schemas.microsoft.com/office/drawing/2014/main" id="{4166D91E-A8D5-408F-9D50-1E1A534A4A57}"/>
+                <a16:creationId xmlns:a16="http://schemas.microsoft.com/office/drawing/2014/main" id="{7636BE94-2319-4805-BCA6-9E44593C821A}"/>
               </a:ext>
             </a:extLst>
           </p:cNvPr>
@@ -3891,7 +4033,7 @@
                 <a:latin typeface="Arial"/>
                 <a:ea typeface="Arial"/>
                 <a:cs typeface="Arial"/>
-                <a:hlinkClick xmlns:r="http://schemas.openxmlformats.org/officeDocument/2006/relationships" r:id="R6e15a089dc0c40b5"/>
+                <a:hlinkClick xmlns:r="http://schemas.openxmlformats.org/officeDocument/2006/relationships" r:id="R1c3d1a47a03c42bf"/>
               </a:rPr>
               <a:t>zotero.org/download</a:t>
             </a:r>
@@ -3903,7 +4045,7 @@
           <p:cNvPr id="12" name="">
             <a:extLst xmlns:a="http://schemas.openxmlformats.org/drawingml/2006/main">
               <a:ext uri="{FF2B5EF4-FFF2-40B4-BE49-F238E27FC236}">
-                <a16:creationId xmlns:a16="http://schemas.microsoft.com/office/drawing/2014/main" id="{A0165864-BF8A-4D3C-ABC9-A307DACB1EB8}"/>
+                <a16:creationId xmlns:a16="http://schemas.microsoft.com/office/drawing/2014/main" id="{B2B969AC-4A24-4B21-81A4-B8A810B953BF}"/>
               </a:ext>
             </a:extLst>
           </p:cNvPr>
@@ -3950,7 +4092,7 @@
                 <a:ea typeface="Arial"/>
                 <a:cs typeface="Arial"/>
               </a:rPr>
-              <a:t>Open Zotero desktop.</a:t>
+              <a:t>Open Zotero 10+ to save reading notes.</a:t>
             </a:r>
           </a:p>
         </p:txBody>
@@ -3958,7 +4100,619 @@
     </p:spTree>
     <p:extLst>
       <p:ext uri="{BB962C8B-B14F-4D97-AF65-F5344CB8AC3E}">
-        <p14:creationId xmlns:p14="http://schemas.microsoft.com/office/powerpoint/2010/main" val="938461103"/>
+        <p14:creationId xmlns:p14="http://schemas.microsoft.com/office/powerpoint/2010/main" val="441511905"/>
+      </p:ext>
+    </p:extLst>
+  </p:cSld>
+</p:sld>
+</file>
+
+<file path=ppt/slides/slide10.xml><?xml version="1.0" encoding="utf-8"?>
+<p:sld xmlns:p="http://schemas.openxmlformats.org/presentationml/2006/main">
+  <p:cSld>
+    <p:bg>
+      <p:bgPr>
+        <a:solidFill xmlns:a="http://schemas.openxmlformats.org/drawingml/2006/main">
+          <a:srgbClr val="FFFFFF"/>
+        </a:solidFill>
+      </p:bgPr>
+    </p:bg>
+    <p:spTree>
+      <p:nvGrpSpPr>
+        <p:cNvPr id="1" name=""/>
+        <p:cNvGrpSpPr/>
+        <p:nvPr/>
+      </p:nvGrpSpPr>
+      <p:grpSpPr>
+        <a:xfrm xmlns:a="http://schemas.openxmlformats.org/drawingml/2006/main"/>
+      </p:grpSpPr>
+      <p:sp>
+        <p:nvSpPr>
+          <p:cNvPr id="10" name="">
+            <a:extLst xmlns:a="http://schemas.openxmlformats.org/drawingml/2006/main">
+              <a:ext uri="{FF2B5EF4-FFF2-40B4-BE49-F238E27FC236}">
+                <a16:creationId xmlns:a16="http://schemas.microsoft.com/office/drawing/2014/main" id="{8F5C1722-AD5D-458C-A13E-BE7DAC5111ED}"/>
+              </a:ext>
+            </a:extLst>
+          </p:cNvPr>
+          <p:cNvSpPr>
+            <a:spLocks xmlns:a="http://schemas.openxmlformats.org/drawingml/2006/main" noGrp="1"/>
+          </p:cNvSpPr>
+          <p:nvPr/>
+        </p:nvSpPr>
+        <p:spPr>
+          <a:xfrm xmlns:a="http://schemas.openxmlformats.org/drawingml/2006/main">
+            <a:off x="609600" y="361950"/>
+            <a:ext cx="10972800" cy="571500"/>
+          </a:xfrm>
+          <a:prstGeom xmlns:a="http://schemas.openxmlformats.org/drawingml/2006/main" prst="rect">
+            <a:avLst/>
+          </a:prstGeom>
+          <a:noFill xmlns:a="http://schemas.openxmlformats.org/drawingml/2006/main"/>
+          <a:ln xmlns:a="http://schemas.openxmlformats.org/drawingml/2006/main" w="0">
+            <a:noFill/>
+          </a:ln>
+        </p:spPr>
+        <p:txBody>
+          <a:bodyPr xmlns:a="http://schemas.openxmlformats.org/drawingml/2006/main" wrap="none" lIns="0" tIns="0" rIns="0" bIns="0" anchor="t">
+            <a:noAutofit/>
+          </a:bodyPr>
+          <a:lstStyle xmlns:a="http://schemas.openxmlformats.org/drawingml/2006/main"/>
+          <a:p xmlns:a="http://schemas.openxmlformats.org/drawingml/2006/main">
+            <a:pPr algn="l">
+              <a:defRPr sz="3300" b="1">
+                <a:solidFill>
+                  <a:srgbClr val="147477"/>
+                </a:solidFill>
+                <a:latin typeface="Arial"/>
+                <a:ea typeface="Arial"/>
+                <a:cs typeface="Arial"/>
+              </a:defRPr>
+            </a:pPr>
+            <a:r>
+              <a:rPr sz="3300" b="1">
+                <a:solidFill>
+                  <a:srgbClr val="147477"/>
+                </a:solidFill>
+                <a:latin typeface="Arial"/>
+                <a:ea typeface="Arial"/>
+                <a:cs typeface="Arial"/>
+              </a:rPr>
+              <a:t>Try reading, review, and discussion</a:t>
+            </a:r>
+          </a:p>
+        </p:txBody>
+      </p:sp>
+      <p:sp>
+        <p:nvSpPr>
+          <p:cNvPr id="2" name="">
+            <a:extLst xmlns:a="http://schemas.openxmlformats.org/drawingml/2006/main">
+              <a:ext uri="{FF2B5EF4-FFF2-40B4-BE49-F238E27FC236}">
+                <a16:creationId xmlns:a16="http://schemas.microsoft.com/office/drawing/2014/main" id="{39E0DB62-6703-4A2C-8919-2BE610CDD3F8}"/>
+              </a:ext>
+            </a:extLst>
+          </p:cNvPr>
+          <p:cNvSpPr>
+            <a:spLocks xmlns:a="http://schemas.openxmlformats.org/drawingml/2006/main" noGrp="1"/>
+          </p:cNvSpPr>
+          <p:nvPr/>
+        </p:nvSpPr>
+        <p:spPr>
+          <a:xfrm xmlns:a="http://schemas.openxmlformats.org/drawingml/2006/main">
+            <a:off x="11125200" y="6448425"/>
+            <a:ext cx="457200" cy="228600"/>
+          </a:xfrm>
+          <a:prstGeom xmlns:a="http://schemas.openxmlformats.org/drawingml/2006/main" prst="rect">
+            <a:avLst/>
+          </a:prstGeom>
+          <a:noFill xmlns:a="http://schemas.openxmlformats.org/drawingml/2006/main"/>
+          <a:ln xmlns:a="http://schemas.openxmlformats.org/drawingml/2006/main" w="0">
+            <a:noFill/>
+          </a:ln>
+        </p:spPr>
+        <p:txBody>
+          <a:bodyPr xmlns:a="http://schemas.openxmlformats.org/drawingml/2006/main" wrap="none" lIns="0" tIns="0" rIns="0" bIns="0" anchor="t">
+            <a:noAutofit/>
+          </a:bodyPr>
+          <a:lstStyle xmlns:a="http://schemas.openxmlformats.org/drawingml/2006/main"/>
+          <a:p xmlns:a="http://schemas.openxmlformats.org/drawingml/2006/main">
+            <a:pPr algn="r">
+              <a:defRPr sz="1275" b="0">
+                <a:solidFill>
+                  <a:srgbClr val="536166"/>
+                </a:solidFill>
+                <a:latin typeface="Arial"/>
+                <a:ea typeface="Arial"/>
+                <a:cs typeface="Arial"/>
+              </a:defRPr>
+            </a:pPr>
+            <a:r>
+              <a:rPr sz="1275" b="0">
+                <a:solidFill>
+                  <a:srgbClr val="536166"/>
+                </a:solidFill>
+                <a:latin typeface="Arial"/>
+                <a:ea typeface="Arial"/>
+                <a:cs typeface="Arial"/>
+              </a:rPr>
+              <a:t>10</a:t>
+            </a:r>
+          </a:p>
+        </p:txBody>
+      </p:sp>
+      <p:sp>
+        <p:nvSpPr>
+          <p:cNvPr id="3" name="">
+            <a:extLst xmlns:a="http://schemas.openxmlformats.org/drawingml/2006/main">
+              <a:ext uri="{FF2B5EF4-FFF2-40B4-BE49-F238E27FC236}">
+                <a16:creationId xmlns:a16="http://schemas.microsoft.com/office/drawing/2014/main" id="{4FDC9B06-298F-4D43-BCF7-B3E7A20B27EF}"/>
+              </a:ext>
+            </a:extLst>
+          </p:cNvPr>
+          <p:cNvSpPr>
+            <a:spLocks xmlns:a="http://schemas.openxmlformats.org/drawingml/2006/main" noGrp="1"/>
+          </p:cNvSpPr>
+          <p:nvPr/>
+        </p:nvSpPr>
+        <p:spPr>
+          <a:xfrm xmlns:a="http://schemas.openxmlformats.org/drawingml/2006/main">
+            <a:off x="609600" y="1676400"/>
+            <a:ext cx="2381250" cy="428625"/>
+          </a:xfrm>
+          <a:prstGeom xmlns:a="http://schemas.openxmlformats.org/drawingml/2006/main" prst="rect">
+            <a:avLst/>
+          </a:prstGeom>
+          <a:noFill xmlns:a="http://schemas.openxmlformats.org/drawingml/2006/main"/>
+          <a:ln xmlns:a="http://schemas.openxmlformats.org/drawingml/2006/main" w="0">
+            <a:noFill/>
+          </a:ln>
+        </p:spPr>
+        <p:txBody>
+          <a:bodyPr xmlns:a="http://schemas.openxmlformats.org/drawingml/2006/main" wrap="none" lIns="0" tIns="0" rIns="0" bIns="0" anchor="t">
+            <a:noAutofit/>
+          </a:bodyPr>
+          <a:lstStyle xmlns:a="http://schemas.openxmlformats.org/drawingml/2006/main"/>
+          <a:p xmlns:a="http://schemas.openxmlformats.org/drawingml/2006/main">
+            <a:pPr algn="l">
+              <a:defRPr sz="2250" b="1">
+                <a:solidFill>
+                  <a:srgbClr val="172C31"/>
+                </a:solidFill>
+                <a:latin typeface="Arial"/>
+                <a:ea typeface="Arial"/>
+                <a:cs typeface="Arial"/>
+              </a:defRPr>
+            </a:pPr>
+            <a:r>
+              <a:rPr sz="2250" b="1">
+                <a:solidFill>
+                  <a:srgbClr val="172C31"/>
+                </a:solidFill>
+                <a:latin typeface="Arial"/>
+                <a:ea typeface="Arial"/>
+                <a:cs typeface="Arial"/>
+              </a:rPr>
+              <a:t>Read</a:t>
+            </a:r>
+          </a:p>
+        </p:txBody>
+      </p:sp>
+      <p:sp>
+        <p:nvSpPr>
+          <p:cNvPr id="4" name="">
+            <a:extLst xmlns:a="http://schemas.openxmlformats.org/drawingml/2006/main">
+              <a:ext uri="{FF2B5EF4-FFF2-40B4-BE49-F238E27FC236}">
+                <a16:creationId xmlns:a16="http://schemas.microsoft.com/office/drawing/2014/main" id="{26D3F013-062C-418B-A8F5-0169D88F84F3}"/>
+              </a:ext>
+            </a:extLst>
+          </p:cNvPr>
+          <p:cNvSpPr>
+            <a:spLocks xmlns:a="http://schemas.openxmlformats.org/drawingml/2006/main" noGrp="1"/>
+          </p:cNvSpPr>
+          <p:nvPr/>
+        </p:nvSpPr>
+        <p:spPr>
+          <a:xfrm xmlns:a="http://schemas.openxmlformats.org/drawingml/2006/main">
+            <a:off x="2857500" y="1676400"/>
+            <a:ext cx="8724900" cy="895350"/>
+          </a:xfrm>
+          <a:prstGeom xmlns:a="http://schemas.openxmlformats.org/drawingml/2006/main" prst="rect">
+            <a:avLst/>
+          </a:prstGeom>
+          <a:noFill xmlns:a="http://schemas.openxmlformats.org/drawingml/2006/main"/>
+          <a:ln xmlns:a="http://schemas.openxmlformats.org/drawingml/2006/main" w="0">
+            <a:noFill/>
+          </a:ln>
+        </p:spPr>
+        <p:txBody>
+          <a:bodyPr xmlns:a="http://schemas.openxmlformats.org/drawingml/2006/main" wrap="none" lIns="0" tIns="0" rIns="0" bIns="0" anchor="t">
+            <a:noAutofit/>
+          </a:bodyPr>
+          <a:lstStyle xmlns:a="http://schemas.openxmlformats.org/drawingml/2006/main"/>
+          <a:p xmlns:a="http://schemas.openxmlformats.org/drawingml/2006/main">
+            <a:pPr algn="l">
+              <a:defRPr sz="1950" b="0">
+                <a:solidFill>
+                  <a:srgbClr val="172C31"/>
+                </a:solidFill>
+                <a:latin typeface="Arial"/>
+                <a:ea typeface="Arial"/>
+                <a:cs typeface="Arial"/>
+              </a:defRPr>
+            </a:pPr>
+            <a:r>
+              <a:rPr sz="1950" b="0">
+                <a:solidFill>
+                  <a:srgbClr val="172C31"/>
+                </a:solidFill>
+                <a:latin typeface="Arial"/>
+                <a:ea typeface="Arial"/>
+                <a:cs typeface="Arial"/>
+              </a:rPr>
+              <a:t>“Use paper-reading to read [paper] in my test collection.</a:t>
+            </a:r>
+          </a:p>
+          <a:p xmlns:a="http://schemas.openxmlformats.org/drawingml/2006/main">
+            <a:pPr algn="l">
+              <a:defRPr sz="1950" b="0">
+                <a:solidFill>
+                  <a:srgbClr val="172C31"/>
+                </a:solidFill>
+                <a:latin typeface="Arial"/>
+                <a:ea typeface="Arial"/>
+                <a:cs typeface="Arial"/>
+              </a:defRPr>
+            </a:pPr>
+            <a:r>
+              <a:rPr sz="1950" b="0">
+                <a:solidFill>
+                  <a:srgbClr val="172C31"/>
+                </a:solidFill>
+                <a:latin typeface="Arial"/>
+                <a:ea typeface="Arial"/>
+                <a:cs typeface="Arial"/>
+              </a:rPr>
+              <a:t>Save its Markdown note and Zotero copy, then show me.”</a:t>
+            </a:r>
+          </a:p>
+        </p:txBody>
+      </p:sp>
+      <p:sp>
+        <p:nvSpPr>
+          <p:cNvPr id="5" name="">
+            <a:extLst xmlns:a="http://schemas.openxmlformats.org/drawingml/2006/main">
+              <a:ext uri="{FF2B5EF4-FFF2-40B4-BE49-F238E27FC236}">
+                <a16:creationId xmlns:a16="http://schemas.microsoft.com/office/drawing/2014/main" id="{8F2F762E-298C-490B-84C8-45AE0866981E}"/>
+              </a:ext>
+            </a:extLst>
+          </p:cNvPr>
+          <p:cNvSpPr>
+            <a:spLocks xmlns:a="http://schemas.openxmlformats.org/drawingml/2006/main" noGrp="1"/>
+          </p:cNvSpPr>
+          <p:nvPr/>
+        </p:nvSpPr>
+        <p:spPr>
+          <a:xfrm xmlns:a="http://schemas.openxmlformats.org/drawingml/2006/main">
+            <a:off x="609600" y="3057525"/>
+            <a:ext cx="2381250" cy="428625"/>
+          </a:xfrm>
+          <a:prstGeom xmlns:a="http://schemas.openxmlformats.org/drawingml/2006/main" prst="rect">
+            <a:avLst/>
+          </a:prstGeom>
+          <a:noFill xmlns:a="http://schemas.openxmlformats.org/drawingml/2006/main"/>
+          <a:ln xmlns:a="http://schemas.openxmlformats.org/drawingml/2006/main" w="0">
+            <a:noFill/>
+          </a:ln>
+        </p:spPr>
+        <p:txBody>
+          <a:bodyPr xmlns:a="http://schemas.openxmlformats.org/drawingml/2006/main" wrap="none" lIns="0" tIns="0" rIns="0" bIns="0" anchor="t">
+            <a:noAutofit/>
+          </a:bodyPr>
+          <a:lstStyle xmlns:a="http://schemas.openxmlformats.org/drawingml/2006/main"/>
+          <a:p xmlns:a="http://schemas.openxmlformats.org/drawingml/2006/main">
+            <a:pPr algn="l">
+              <a:defRPr sz="2250" b="1">
+                <a:solidFill>
+                  <a:srgbClr val="172C31"/>
+                </a:solidFill>
+                <a:latin typeface="Arial"/>
+                <a:ea typeface="Arial"/>
+                <a:cs typeface="Arial"/>
+              </a:defRPr>
+            </a:pPr>
+            <a:r>
+              <a:rPr sz="2250" b="1">
+                <a:solidFill>
+                  <a:srgbClr val="172C31"/>
+                </a:solidFill>
+                <a:latin typeface="Arial"/>
+                <a:ea typeface="Arial"/>
+                <a:cs typeface="Arial"/>
+              </a:rPr>
+              <a:t>Review</a:t>
+            </a:r>
+          </a:p>
+        </p:txBody>
+      </p:sp>
+      <p:sp>
+        <p:nvSpPr>
+          <p:cNvPr id="6" name="">
+            <a:extLst xmlns:a="http://schemas.openxmlformats.org/drawingml/2006/main">
+              <a:ext uri="{FF2B5EF4-FFF2-40B4-BE49-F238E27FC236}">
+                <a16:creationId xmlns:a16="http://schemas.microsoft.com/office/drawing/2014/main" id="{CD5F68F9-B2A8-4792-99E2-ECC9A38567D6}"/>
+              </a:ext>
+            </a:extLst>
+          </p:cNvPr>
+          <p:cNvSpPr>
+            <a:spLocks xmlns:a="http://schemas.openxmlformats.org/drawingml/2006/main" noGrp="1"/>
+          </p:cNvSpPr>
+          <p:nvPr/>
+        </p:nvSpPr>
+        <p:spPr>
+          <a:xfrm xmlns:a="http://schemas.openxmlformats.org/drawingml/2006/main">
+            <a:off x="2857500" y="3057525"/>
+            <a:ext cx="8724900" cy="895350"/>
+          </a:xfrm>
+          <a:prstGeom xmlns:a="http://schemas.openxmlformats.org/drawingml/2006/main" prst="rect">
+            <a:avLst/>
+          </a:prstGeom>
+          <a:noFill xmlns:a="http://schemas.openxmlformats.org/drawingml/2006/main"/>
+          <a:ln xmlns:a="http://schemas.openxmlformats.org/drawingml/2006/main" w="0">
+            <a:noFill/>
+          </a:ln>
+        </p:spPr>
+        <p:txBody>
+          <a:bodyPr xmlns:a="http://schemas.openxmlformats.org/drawingml/2006/main" wrap="none" lIns="0" tIns="0" rIns="0" bIns="0" anchor="t">
+            <a:noAutofit/>
+          </a:bodyPr>
+          <a:lstStyle xmlns:a="http://schemas.openxmlformats.org/drawingml/2006/main"/>
+          <a:p xmlns:a="http://schemas.openxmlformats.org/drawingml/2006/main">
+            <a:pPr algn="l">
+              <a:defRPr sz="1950" b="0">
+                <a:solidFill>
+                  <a:srgbClr val="172C31"/>
+                </a:solidFill>
+                <a:latin typeface="Arial"/>
+                <a:ea typeface="Arial"/>
+                <a:cs typeface="Arial"/>
+              </a:defRPr>
+            </a:pPr>
+            <a:r>
+              <a:rPr sz="1950" b="0">
+                <a:solidFill>
+                  <a:srgbClr val="172C31"/>
+                </a:solidFill>
+                <a:latin typeface="Arial"/>
+                <a:ea typeface="Arial"/>
+                <a:cs typeface="Arial"/>
+              </a:rPr>
+              <a:t>After checking the note against the paper:</a:t>
+            </a:r>
+          </a:p>
+          <a:p xmlns:a="http://schemas.openxmlformats.org/drawingml/2006/main">
+            <a:pPr algn="l">
+              <a:defRPr sz="1950" b="0">
+                <a:solidFill>
+                  <a:srgbClr val="172C31"/>
+                </a:solidFill>
+                <a:latin typeface="Arial"/>
+                <a:ea typeface="Arial"/>
+                <a:cs typeface="Arial"/>
+              </a:defRPr>
+            </a:pPr>
+            <a:r>
+              <a:rPr sz="1950" b="0">
+                <a:solidFill>
+                  <a:srgbClr val="172C31"/>
+                </a:solidFill>
+                <a:latin typeface="Arial"/>
+                <a:ea typeface="Arial"/>
+                <a:cs typeface="Arial"/>
+              </a:rPr>
+              <a:t>“I approve the current note for [paper]. Mark it human-reviewed.”</a:t>
+            </a:r>
+          </a:p>
+        </p:txBody>
+      </p:sp>
+      <p:sp>
+        <p:nvSpPr>
+          <p:cNvPr id="7" name="">
+            <a:extLst xmlns:a="http://schemas.openxmlformats.org/drawingml/2006/main">
+              <a:ext uri="{FF2B5EF4-FFF2-40B4-BE49-F238E27FC236}">
+                <a16:creationId xmlns:a16="http://schemas.microsoft.com/office/drawing/2014/main" id="{067965C6-5706-4DAE-9A1F-DF8F0F87CAF3}"/>
+              </a:ext>
+            </a:extLst>
+          </p:cNvPr>
+          <p:cNvSpPr>
+            <a:spLocks xmlns:a="http://schemas.openxmlformats.org/drawingml/2006/main" noGrp="1"/>
+          </p:cNvSpPr>
+          <p:nvPr/>
+        </p:nvSpPr>
+        <p:spPr>
+          <a:xfrm xmlns:a="http://schemas.openxmlformats.org/drawingml/2006/main">
+            <a:off x="609600" y="4438650"/>
+            <a:ext cx="2381250" cy="428625"/>
+          </a:xfrm>
+          <a:prstGeom xmlns:a="http://schemas.openxmlformats.org/drawingml/2006/main" prst="rect">
+            <a:avLst/>
+          </a:prstGeom>
+          <a:noFill xmlns:a="http://schemas.openxmlformats.org/drawingml/2006/main"/>
+          <a:ln xmlns:a="http://schemas.openxmlformats.org/drawingml/2006/main" w="0">
+            <a:noFill/>
+          </a:ln>
+        </p:spPr>
+        <p:txBody>
+          <a:bodyPr xmlns:a="http://schemas.openxmlformats.org/drawingml/2006/main" wrap="none" lIns="0" tIns="0" rIns="0" bIns="0" anchor="t">
+            <a:noAutofit/>
+          </a:bodyPr>
+          <a:lstStyle xmlns:a="http://schemas.openxmlformats.org/drawingml/2006/main"/>
+          <a:p xmlns:a="http://schemas.openxmlformats.org/drawingml/2006/main">
+            <a:pPr algn="l">
+              <a:defRPr sz="2250" b="1">
+                <a:solidFill>
+                  <a:srgbClr val="172C31"/>
+                </a:solidFill>
+                <a:latin typeface="Arial"/>
+                <a:ea typeface="Arial"/>
+                <a:cs typeface="Arial"/>
+              </a:defRPr>
+            </a:pPr>
+            <a:r>
+              <a:rPr sz="2250" b="1">
+                <a:solidFill>
+                  <a:srgbClr val="172C31"/>
+                </a:solidFill>
+                <a:latin typeface="Arial"/>
+                <a:ea typeface="Arial"/>
+                <a:cs typeface="Arial"/>
+              </a:rPr>
+              <a:t>Discuss</a:t>
+            </a:r>
+          </a:p>
+        </p:txBody>
+      </p:sp>
+      <p:sp>
+        <p:nvSpPr>
+          <p:cNvPr id="8" name="">
+            <a:extLst xmlns:a="http://schemas.openxmlformats.org/drawingml/2006/main">
+              <a:ext uri="{FF2B5EF4-FFF2-40B4-BE49-F238E27FC236}">
+                <a16:creationId xmlns:a16="http://schemas.microsoft.com/office/drawing/2014/main" id="{7748356D-35CA-4469-9494-1DE8C9AC4CC6}"/>
+              </a:ext>
+            </a:extLst>
+          </p:cNvPr>
+          <p:cNvSpPr>
+            <a:spLocks xmlns:a="http://schemas.openxmlformats.org/drawingml/2006/main" noGrp="1"/>
+          </p:cNvSpPr>
+          <p:nvPr/>
+        </p:nvSpPr>
+        <p:spPr>
+          <a:xfrm xmlns:a="http://schemas.openxmlformats.org/drawingml/2006/main">
+            <a:off x="2857500" y="4438650"/>
+            <a:ext cx="8724900" cy="895350"/>
+          </a:xfrm>
+          <a:prstGeom xmlns:a="http://schemas.openxmlformats.org/drawingml/2006/main" prst="rect">
+            <a:avLst/>
+          </a:prstGeom>
+          <a:noFill xmlns:a="http://schemas.openxmlformats.org/drawingml/2006/main"/>
+          <a:ln xmlns:a="http://schemas.openxmlformats.org/drawingml/2006/main" w="0">
+            <a:noFill/>
+          </a:ln>
+        </p:spPr>
+        <p:txBody>
+          <a:bodyPr xmlns:a="http://schemas.openxmlformats.org/drawingml/2006/main" wrap="none" lIns="0" tIns="0" rIns="0" bIns="0" anchor="t">
+            <a:noAutofit/>
+          </a:bodyPr>
+          <a:lstStyle xmlns:a="http://schemas.openxmlformats.org/drawingml/2006/main"/>
+          <a:p xmlns:a="http://schemas.openxmlformats.org/drawingml/2006/main">
+            <a:pPr algn="l">
+              <a:defRPr sz="1950" b="0">
+                <a:solidFill>
+                  <a:srgbClr val="172C31"/>
+                </a:solidFill>
+                <a:latin typeface="Arial"/>
+                <a:ea typeface="Arial"/>
+                <a:cs typeface="Arial"/>
+              </a:defRPr>
+            </a:pPr>
+            <a:r>
+              <a:rPr sz="1950" b="0">
+                <a:solidFill>
+                  <a:srgbClr val="172C31"/>
+                </a:solidFill>
+                <a:latin typeface="Arial"/>
+                <a:ea typeface="Arial"/>
+                <a:cs typeface="Arial"/>
+              </a:rPr>
+              <a:t>“Search my test collection’s notes for [topic]. Discuss [question],</a:t>
+            </a:r>
+          </a:p>
+          <a:p xmlns:a="http://schemas.openxmlformats.org/drawingml/2006/main">
+            <a:pPr algn="l">
+              <a:defRPr sz="1950" b="0">
+                <a:solidFill>
+                  <a:srgbClr val="172C31"/>
+                </a:solidFill>
+                <a:latin typeface="Arial"/>
+                <a:ea typeface="Arial"/>
+                <a:cs typeface="Arial"/>
+              </a:defRPr>
+            </a:pPr>
+            <a:r>
+              <a:rPr sz="1950" b="0">
+                <a:solidFill>
+                  <a:srgbClr val="172C31"/>
+                </a:solidFill>
+                <a:latin typeface="Arial"/>
+                <a:ea typeface="Arial"/>
+                <a:cs typeface="Arial"/>
+              </a:rPr>
+              <a:t>cite the evidence, and state each note’s human-review status.”</a:t>
+            </a:r>
+          </a:p>
+        </p:txBody>
+      </p:sp>
+      <p:sp>
+        <p:nvSpPr>
+          <p:cNvPr id="9" name="">
+            <a:extLst xmlns:a="http://schemas.openxmlformats.org/drawingml/2006/main">
+              <a:ext uri="{FF2B5EF4-FFF2-40B4-BE49-F238E27FC236}">
+                <a16:creationId xmlns:a16="http://schemas.microsoft.com/office/drawing/2014/main" id="{2D690567-B219-423D-A5DD-411C283FED7F}"/>
+              </a:ext>
+            </a:extLst>
+          </p:cNvPr>
+          <p:cNvSpPr>
+            <a:spLocks xmlns:a="http://schemas.openxmlformats.org/drawingml/2006/main" noGrp="1"/>
+          </p:cNvSpPr>
+          <p:nvPr/>
+        </p:nvSpPr>
+        <p:spPr>
+          <a:xfrm xmlns:a="http://schemas.openxmlformats.org/drawingml/2006/main">
+            <a:off x="609600" y="5981700"/>
+            <a:ext cx="10972800" cy="342900"/>
+          </a:xfrm>
+          <a:prstGeom xmlns:a="http://schemas.openxmlformats.org/drawingml/2006/main" prst="rect">
+            <a:avLst/>
+          </a:prstGeom>
+          <a:noFill xmlns:a="http://schemas.openxmlformats.org/drawingml/2006/main"/>
+          <a:ln xmlns:a="http://schemas.openxmlformats.org/drawingml/2006/main" w="0">
+            <a:noFill/>
+          </a:ln>
+        </p:spPr>
+        <p:txBody>
+          <a:bodyPr xmlns:a="http://schemas.openxmlformats.org/drawingml/2006/main" wrap="none" lIns="0" tIns="0" rIns="0" bIns="0" anchor="t">
+            <a:noAutofit/>
+          </a:bodyPr>
+          <a:lstStyle xmlns:a="http://schemas.openxmlformats.org/drawingml/2006/main"/>
+          <a:p xmlns:a="http://schemas.openxmlformats.org/drawingml/2006/main">
+            <a:pPr algn="l">
+              <a:defRPr sz="1875" b="0">
+                <a:solidFill>
+                  <a:srgbClr val="147477"/>
+                </a:solidFill>
+                <a:latin typeface="Arial"/>
+                <a:ea typeface="Arial"/>
+                <a:cs typeface="Arial"/>
+              </a:defRPr>
+            </a:pPr>
+            <a:r>
+              <a:rPr sz="1875" b="0">
+                <a:solidFill>
+                  <a:srgbClr val="147477"/>
+                </a:solidFill>
+                <a:latin typeface="Arial"/>
+                <a:ea typeface="Arial"/>
+                <a:cs typeface="Arial"/>
+                <a:hlinkClick xmlns:r="http://schemas.openxmlformats.org/officeDocument/2006/relationships" r:id="R616fdd40a1a44905"/>
+              </a:rPr>
+              <a:t>Full copyable prompts are in the workshop exercise guide.</a:t>
+            </a:r>
+          </a:p>
+        </p:txBody>
+      </p:sp>
+    </p:spTree>
+    <p:extLst>
+      <p:ext uri="{BB962C8B-B14F-4D97-AF65-F5344CB8AC3E}">
+        <p14:creationId xmlns:p14="http://schemas.microsoft.com/office/powerpoint/2010/main" val="2006205569"/>
       </p:ext>
     </p:extLst>
   </p:cSld>
@@ -3989,7 +4743,7 @@
           <p:cNvPr id="9" name="">
             <a:extLst xmlns:a="http://schemas.openxmlformats.org/drawingml/2006/main">
               <a:ext uri="{FF2B5EF4-FFF2-40B4-BE49-F238E27FC236}">
-                <a16:creationId xmlns:a16="http://schemas.microsoft.com/office/drawing/2014/main" id="{84C04EAA-88DE-432B-A050-1DD5AC1B81E5}"/>
+                <a16:creationId xmlns:a16="http://schemas.microsoft.com/office/drawing/2014/main" id="{DE550415-F8E9-4155-8AA2-913EA23B6112}"/>
               </a:ext>
             </a:extLst>
           </p:cNvPr>
@@ -4069,7 +4823,7 @@
           <p:cNvPr id="2" name="">
             <a:extLst xmlns:a="http://schemas.openxmlformats.org/drawingml/2006/main">
               <a:ext uri="{FF2B5EF4-FFF2-40B4-BE49-F238E27FC236}">
-                <a16:creationId xmlns:a16="http://schemas.microsoft.com/office/drawing/2014/main" id="{C965E284-534D-4B05-A65E-9DCCC39A2884}"/>
+                <a16:creationId xmlns:a16="http://schemas.microsoft.com/office/drawing/2014/main" id="{11E430CD-F8C2-463F-942B-67227A785929}"/>
               </a:ext>
             </a:extLst>
           </p:cNvPr>
@@ -4126,7 +4880,7 @@
           <p:cNvPr id="3" name="">
             <a:extLst xmlns:a="http://schemas.openxmlformats.org/drawingml/2006/main">
               <a:ext uri="{FF2B5EF4-FFF2-40B4-BE49-F238E27FC236}">
-                <a16:creationId xmlns:a16="http://schemas.microsoft.com/office/drawing/2014/main" id="{B57B0948-BB2E-429B-A299-B67EF4AB654E}"/>
+                <a16:creationId xmlns:a16="http://schemas.microsoft.com/office/drawing/2014/main" id="{50E30DD9-2BBF-41FD-8BE2-2EE1C381AB0C}"/>
               </a:ext>
             </a:extLst>
           </p:cNvPr>
@@ -4206,7 +4960,7 @@
           <p:cNvPr id="4" name="">
             <a:extLst xmlns:a="http://schemas.openxmlformats.org/drawingml/2006/main">
               <a:ext uri="{FF2B5EF4-FFF2-40B4-BE49-F238E27FC236}">
-                <a16:creationId xmlns:a16="http://schemas.microsoft.com/office/drawing/2014/main" id="{193181D8-05A4-4B16-B641-9E56C5032232}"/>
+                <a16:creationId xmlns:a16="http://schemas.microsoft.com/office/drawing/2014/main" id="{3F61303F-2624-4119-8C80-1A3FBF3A4FCA}"/>
               </a:ext>
             </a:extLst>
           </p:cNvPr>
@@ -4263,7 +5017,7 @@
           <p:cNvPr id="5" name="">
             <a:extLst xmlns:a="http://schemas.openxmlformats.org/drawingml/2006/main">
               <a:ext uri="{FF2B5EF4-FFF2-40B4-BE49-F238E27FC236}">
-                <a16:creationId xmlns:a16="http://schemas.microsoft.com/office/drawing/2014/main" id="{912CC068-1B39-46CE-885B-2A239CB19992}"/>
+                <a16:creationId xmlns:a16="http://schemas.microsoft.com/office/drawing/2014/main" id="{0EA29AF9-2114-4F8C-9C81-8F2F1E00AC1A}"/>
               </a:ext>
             </a:extLst>
           </p:cNvPr>
@@ -4343,7 +5097,7 @@
           <p:cNvPr id="6" name="">
             <a:extLst xmlns:a="http://schemas.openxmlformats.org/drawingml/2006/main">
               <a:ext uri="{FF2B5EF4-FFF2-40B4-BE49-F238E27FC236}">
-                <a16:creationId xmlns:a16="http://schemas.microsoft.com/office/drawing/2014/main" id="{25B867AA-BD81-4712-9871-62DFD6A5CD3C}"/>
+                <a16:creationId xmlns:a16="http://schemas.microsoft.com/office/drawing/2014/main" id="{218A7CDA-74BD-41A6-A45A-0989E43E901E}"/>
               </a:ext>
             </a:extLst>
           </p:cNvPr>
@@ -4427,10 +5181,10 @@
           <p:nvPr/>
         </p:nvPicPr>
         <p:blipFill>
-          <a:blip xmlns:r="http://schemas.openxmlformats.org/officeDocument/2006/relationships" xmlns:a="http://schemas.openxmlformats.org/drawingml/2006/main" r:embed="R8eb2626d575348c3">
+          <a:blip xmlns:r="http://schemas.openxmlformats.org/officeDocument/2006/relationships" xmlns:a="http://schemas.openxmlformats.org/drawingml/2006/main" r:embed="R74ff459d5dd046e8">
             <a:extLst>
               <a:ext uri="{96DAC541-7B7A-43D3-8B79-37D633B846F1}">
-                <asvg:svgBlip xmlns:asvg="http://schemas.microsoft.com/office/drawing/2016/SVG/main" r:embed="R9a3162ee57314f5e"/>
+                <asvg:svgBlip xmlns:asvg="http://schemas.microsoft.com/office/drawing/2016/SVG/main" r:embed="R356b0674da794d71"/>
               </a:ext>
             </a:extLst>
           </a:blip>
@@ -4455,7 +5209,7 @@
           <p:nvPr/>
         </p:nvPicPr>
         <p:blipFill>
-          <a:blip xmlns:r="http://schemas.openxmlformats.org/officeDocument/2006/relationships" xmlns:a="http://schemas.openxmlformats.org/drawingml/2006/main" r:embed="R38c2f7f61b7e4292"/>
+          <a:blip xmlns:r="http://schemas.openxmlformats.org/officeDocument/2006/relationships" xmlns:a="http://schemas.openxmlformats.org/drawingml/2006/main" r:embed="R1b6ccbf8131444fa"/>
           <a:srcRect xmlns:a="http://schemas.openxmlformats.org/drawingml/2006/main" l="0" t="6081" r="0" b="28604"/>
           <a:stretch xmlns:a="http://schemas.openxmlformats.org/drawingml/2006/main"/>
         </p:blipFill>
@@ -4472,7 +5226,7 @@
     </p:spTree>
     <p:extLst>
       <p:ext uri="{BB962C8B-B14F-4D97-AF65-F5344CB8AC3E}">
-        <p14:creationId xmlns:p14="http://schemas.microsoft.com/office/powerpoint/2010/main" val="1778222932"/>
+        <p14:creationId xmlns:p14="http://schemas.microsoft.com/office/powerpoint/2010/main" val="919537865"/>
       </p:ext>
     </p:extLst>
   </p:cSld>
@@ -4503,7 +5257,7 @@
           <p:cNvPr id="5" name="">
             <a:extLst xmlns:a="http://schemas.openxmlformats.org/drawingml/2006/main">
               <a:ext uri="{FF2B5EF4-FFF2-40B4-BE49-F238E27FC236}">
-                <a16:creationId xmlns:a16="http://schemas.microsoft.com/office/drawing/2014/main" id="{05BED945-9C34-4B20-AF46-87406FABA4B1}"/>
+                <a16:creationId xmlns:a16="http://schemas.microsoft.com/office/drawing/2014/main" id="{E6B5A08D-9D79-402D-8A75-C296E3F861B0}"/>
               </a:ext>
             </a:extLst>
           </p:cNvPr>
@@ -4560,7 +5314,7 @@
           <p:cNvPr id="2" name="">
             <a:extLst xmlns:a="http://schemas.openxmlformats.org/drawingml/2006/main">
               <a:ext uri="{FF2B5EF4-FFF2-40B4-BE49-F238E27FC236}">
-                <a16:creationId xmlns:a16="http://schemas.microsoft.com/office/drawing/2014/main" id="{4979EBCE-0ADA-47F5-B6C6-2C08EFCA86C9}"/>
+                <a16:creationId xmlns:a16="http://schemas.microsoft.com/office/drawing/2014/main" id="{1E066FEC-6BBC-4E69-8385-F1BFD6E17681}"/>
               </a:ext>
             </a:extLst>
           </p:cNvPr>
@@ -4617,7 +5371,7 @@
           <p:cNvPr id="3" name="">
             <a:extLst xmlns:a="http://schemas.openxmlformats.org/drawingml/2006/main">
               <a:ext uri="{FF2B5EF4-FFF2-40B4-BE49-F238E27FC236}">
-                <a16:creationId xmlns:a16="http://schemas.microsoft.com/office/drawing/2014/main" id="{FFF29971-CE25-4B64-A104-C46EED6697E0}"/>
+                <a16:creationId xmlns:a16="http://schemas.microsoft.com/office/drawing/2014/main" id="{5757DE95-4899-494D-8FB3-E4468D786E7A}"/>
               </a:ext>
             </a:extLst>
           </p:cNvPr>
@@ -4678,7 +5432,7 @@
           <p:nvPr/>
         </p:nvPicPr>
         <p:blipFill>
-          <a:blip xmlns:r="http://schemas.openxmlformats.org/officeDocument/2006/relationships" xmlns:a="http://schemas.openxmlformats.org/drawingml/2006/main" r:embed="R5223b735eafc46e7"/>
+          <a:blip xmlns:r="http://schemas.openxmlformats.org/officeDocument/2006/relationships" xmlns:a="http://schemas.openxmlformats.org/drawingml/2006/main" r:embed="Rada1a95e727b43c1"/>
           <a:stretch xmlns:a="http://schemas.openxmlformats.org/drawingml/2006/main"/>
         </p:blipFill>
         <p:spPr>
@@ -4694,7 +5448,7 @@
     </p:spTree>
     <p:extLst>
       <p:ext uri="{BB962C8B-B14F-4D97-AF65-F5344CB8AC3E}">
-        <p14:creationId xmlns:p14="http://schemas.microsoft.com/office/powerpoint/2010/main" val="1328665889"/>
+        <p14:creationId xmlns:p14="http://schemas.microsoft.com/office/powerpoint/2010/main" val="1285746623"/>
       </p:ext>
     </p:extLst>
   </p:cSld>
@@ -4725,7 +5479,7 @@
           <p:cNvPr id="5" name="">
             <a:extLst xmlns:a="http://schemas.openxmlformats.org/drawingml/2006/main">
               <a:ext uri="{FF2B5EF4-FFF2-40B4-BE49-F238E27FC236}">
-                <a16:creationId xmlns:a16="http://schemas.microsoft.com/office/drawing/2014/main" id="{6556DDF9-2CB3-4BAE-BC8C-81BA5485DFB7}"/>
+                <a16:creationId xmlns:a16="http://schemas.microsoft.com/office/drawing/2014/main" id="{902ED072-67B8-4ACE-A3A3-DAAFDDF5419F}"/>
               </a:ext>
             </a:extLst>
           </p:cNvPr>
@@ -4782,7 +5536,7 @@
           <p:cNvPr id="2" name="">
             <a:extLst xmlns:a="http://schemas.openxmlformats.org/drawingml/2006/main">
               <a:ext uri="{FF2B5EF4-FFF2-40B4-BE49-F238E27FC236}">
-                <a16:creationId xmlns:a16="http://schemas.microsoft.com/office/drawing/2014/main" id="{89779615-EB02-4FAD-9698-B8FDA0F52640}"/>
+                <a16:creationId xmlns:a16="http://schemas.microsoft.com/office/drawing/2014/main" id="{743B7963-27E0-49A0-84D7-AA005A49C481}"/>
               </a:ext>
             </a:extLst>
           </p:cNvPr>
@@ -4839,7 +5593,7 @@
           <p:cNvPr id="3" name="">
             <a:extLst xmlns:a="http://schemas.openxmlformats.org/drawingml/2006/main">
               <a:ext uri="{FF2B5EF4-FFF2-40B4-BE49-F238E27FC236}">
-                <a16:creationId xmlns:a16="http://schemas.microsoft.com/office/drawing/2014/main" id="{6ABAC7D9-32D1-425B-B0FD-E735E35A0B4D}"/>
+                <a16:creationId xmlns:a16="http://schemas.microsoft.com/office/drawing/2014/main" id="{7E91E90C-A1B4-493B-8968-812D745A2B8D}"/>
               </a:ext>
             </a:extLst>
           </p:cNvPr>
@@ -4900,7 +5654,7 @@
           <p:nvPr/>
         </p:nvPicPr>
         <p:blipFill>
-          <a:blip xmlns:r="http://schemas.openxmlformats.org/officeDocument/2006/relationships" xmlns:a="http://schemas.openxmlformats.org/drawingml/2006/main" r:embed="R91c0bba1dc944622"/>
+          <a:blip xmlns:r="http://schemas.openxmlformats.org/officeDocument/2006/relationships" xmlns:a="http://schemas.openxmlformats.org/drawingml/2006/main" r:embed="Rc699e8c335af4e8f"/>
           <a:stretch xmlns:a="http://schemas.openxmlformats.org/drawingml/2006/main"/>
         </p:blipFill>
         <p:spPr>
@@ -4916,7 +5670,7 @@
     </p:spTree>
     <p:extLst>
       <p:ext uri="{BB962C8B-B14F-4D97-AF65-F5344CB8AC3E}">
-        <p14:creationId xmlns:p14="http://schemas.microsoft.com/office/powerpoint/2010/main" val="1935320746"/>
+        <p14:creationId xmlns:p14="http://schemas.microsoft.com/office/powerpoint/2010/main" val="91932158"/>
       </p:ext>
     </p:extLst>
   </p:cSld>
@@ -4947,7 +5701,7 @@
           <p:cNvPr id="5" name="">
             <a:extLst xmlns:a="http://schemas.openxmlformats.org/drawingml/2006/main">
               <a:ext uri="{FF2B5EF4-FFF2-40B4-BE49-F238E27FC236}">
-                <a16:creationId xmlns:a16="http://schemas.microsoft.com/office/drawing/2014/main" id="{202BCDDD-091A-4185-86F5-1364FAA98755}"/>
+                <a16:creationId xmlns:a16="http://schemas.microsoft.com/office/drawing/2014/main" id="{07817F2E-85C6-4C31-AA4A-89490FF23363}"/>
               </a:ext>
             </a:extLst>
           </p:cNvPr>
@@ -5004,7 +5758,7 @@
           <p:cNvPr id="2" name="">
             <a:extLst xmlns:a="http://schemas.openxmlformats.org/drawingml/2006/main">
               <a:ext uri="{FF2B5EF4-FFF2-40B4-BE49-F238E27FC236}">
-                <a16:creationId xmlns:a16="http://schemas.microsoft.com/office/drawing/2014/main" id="{173618C2-8B01-4C42-AF50-34CA2CC311D3}"/>
+                <a16:creationId xmlns:a16="http://schemas.microsoft.com/office/drawing/2014/main" id="{70544B9D-FE62-4556-8E5C-DD7750817793}"/>
               </a:ext>
             </a:extLst>
           </p:cNvPr>
@@ -5061,7 +5815,7 @@
           <p:cNvPr id="3" name="">
             <a:extLst xmlns:a="http://schemas.openxmlformats.org/drawingml/2006/main">
               <a:ext uri="{FF2B5EF4-FFF2-40B4-BE49-F238E27FC236}">
-                <a16:creationId xmlns:a16="http://schemas.microsoft.com/office/drawing/2014/main" id="{ED097DC3-C13C-454C-8C64-EA8E86DC683C}"/>
+                <a16:creationId xmlns:a16="http://schemas.microsoft.com/office/drawing/2014/main" id="{0FBCDFBA-721A-42F1-8BF4-D84176009DE6}"/>
               </a:ext>
             </a:extLst>
           </p:cNvPr>
@@ -5122,7 +5876,7 @@
           <p:nvPr/>
         </p:nvPicPr>
         <p:blipFill>
-          <a:blip xmlns:r="http://schemas.openxmlformats.org/officeDocument/2006/relationships" xmlns:a="http://schemas.openxmlformats.org/drawingml/2006/main" r:embed="Rf57f637aaec94605"/>
+          <a:blip xmlns:r="http://schemas.openxmlformats.org/officeDocument/2006/relationships" xmlns:a="http://schemas.openxmlformats.org/drawingml/2006/main" r:embed="R478e3cdb2cc5457d"/>
           <a:stretch xmlns:a="http://schemas.openxmlformats.org/drawingml/2006/main"/>
         </p:blipFill>
         <p:spPr>
@@ -5138,7 +5892,7 @@
     </p:spTree>
     <p:extLst>
       <p:ext uri="{BB962C8B-B14F-4D97-AF65-F5344CB8AC3E}">
-        <p14:creationId xmlns:p14="http://schemas.microsoft.com/office/powerpoint/2010/main" val="917130261"/>
+        <p14:creationId xmlns:p14="http://schemas.microsoft.com/office/powerpoint/2010/main" val="570819543"/>
       </p:ext>
     </p:extLst>
   </p:cSld>
@@ -5169,7 +5923,7 @@
           <p:cNvPr id="6" name="">
             <a:extLst xmlns:a="http://schemas.openxmlformats.org/drawingml/2006/main">
               <a:ext uri="{FF2B5EF4-FFF2-40B4-BE49-F238E27FC236}">
-                <a16:creationId xmlns:a16="http://schemas.microsoft.com/office/drawing/2014/main" id="{1ACAB929-8FBC-4124-B5DB-557EF3B64141}"/>
+                <a16:creationId xmlns:a16="http://schemas.microsoft.com/office/drawing/2014/main" id="{D90F58E7-8973-4318-93BE-959815A4A2F2}"/>
               </a:ext>
             </a:extLst>
           </p:cNvPr>
@@ -5226,7 +5980,7 @@
           <p:cNvPr id="2" name="">
             <a:extLst xmlns:a="http://schemas.openxmlformats.org/drawingml/2006/main">
               <a:ext uri="{FF2B5EF4-FFF2-40B4-BE49-F238E27FC236}">
-                <a16:creationId xmlns:a16="http://schemas.microsoft.com/office/drawing/2014/main" id="{DC1FF6B6-7032-44CC-8906-8238FA7D55F1}"/>
+                <a16:creationId xmlns:a16="http://schemas.microsoft.com/office/drawing/2014/main" id="{8F07D973-972A-4F49-AFEA-7548A7DF5FAE}"/>
               </a:ext>
             </a:extLst>
           </p:cNvPr>
@@ -5283,7 +6037,7 @@
           <p:cNvPr id="3" name="">
             <a:extLst xmlns:a="http://schemas.openxmlformats.org/drawingml/2006/main">
               <a:ext uri="{FF2B5EF4-FFF2-40B4-BE49-F238E27FC236}">
-                <a16:creationId xmlns:a16="http://schemas.microsoft.com/office/drawing/2014/main" id="{7971DF77-AC87-4F69-920D-2AF95A4FE5B6}"/>
+                <a16:creationId xmlns:a16="http://schemas.microsoft.com/office/drawing/2014/main" id="{D11593CC-04C2-4314-A42A-1E8CBCB497F4}"/>
               </a:ext>
             </a:extLst>
           </p:cNvPr>
@@ -5344,10 +6098,10 @@
           <p:nvPr/>
         </p:nvPicPr>
         <p:blipFill>
-          <a:blip xmlns:r="http://schemas.openxmlformats.org/officeDocument/2006/relationships" xmlns:a="http://schemas.openxmlformats.org/drawingml/2006/main" r:embed="R99d92f1f63194144">
+          <a:blip xmlns:r="http://schemas.openxmlformats.org/officeDocument/2006/relationships" xmlns:a="http://schemas.openxmlformats.org/drawingml/2006/main" r:embed="R8fe53525ebeb4c74">
             <a:extLst>
               <a:ext uri="{96DAC541-7B7A-43D3-8B79-37D633B846F1}">
-                <asvg:svgBlip xmlns:asvg="http://schemas.microsoft.com/office/drawing/2016/SVG/main" r:embed="R8c557e7085164916"/>
+                <asvg:svgBlip xmlns:asvg="http://schemas.microsoft.com/office/drawing/2016/SVG/main" r:embed="Rf9e3da08498a4c0d"/>
               </a:ext>
             </a:extLst>
           </a:blip>
@@ -5368,7 +6122,7 @@
           <p:cNvPr id="5" name="">
             <a:extLst xmlns:a="http://schemas.openxmlformats.org/drawingml/2006/main">
               <a:ext uri="{FF2B5EF4-FFF2-40B4-BE49-F238E27FC236}">
-                <a16:creationId xmlns:a16="http://schemas.microsoft.com/office/drawing/2014/main" id="{49972772-17B7-4491-B947-78D32E1BD5C9}"/>
+                <a16:creationId xmlns:a16="http://schemas.microsoft.com/office/drawing/2014/main" id="{28F4F93D-C459-4B56-9E03-4F127ED2ED84}"/>
               </a:ext>
             </a:extLst>
           </p:cNvPr>
@@ -5415,7 +6169,7 @@
                 <a:ea typeface="Arial"/>
                 <a:cs typeface="Arial"/>
               </a:rPr>
-              <a:t>Keep Zotero desktop open so Codex can check your library and read saved text.</a:t>
+              <a:t>Keep Zotero open. Allow “Paper Reading” to save notes when Zotero asks.</a:t>
             </a:r>
           </a:p>
         </p:txBody>
@@ -5423,7 +6177,7 @@
     </p:spTree>
     <p:extLst>
       <p:ext uri="{BB962C8B-B14F-4D97-AF65-F5344CB8AC3E}">
-        <p14:creationId xmlns:p14="http://schemas.microsoft.com/office/powerpoint/2010/main" val="1125414157"/>
+        <p14:creationId xmlns:p14="http://schemas.microsoft.com/office/powerpoint/2010/main" val="1342996718"/>
       </p:ext>
     </p:extLst>
   </p:cSld>
@@ -5451,10 +6205,10 @@
       </p:grpSpPr>
       <p:sp>
         <p:nvSpPr>
-          <p:cNvPr id="10" name="">
+          <p:cNvPr id="11" name="">
             <a:extLst xmlns:a="http://schemas.openxmlformats.org/drawingml/2006/main">
               <a:ext uri="{FF2B5EF4-FFF2-40B4-BE49-F238E27FC236}">
-                <a16:creationId xmlns:a16="http://schemas.microsoft.com/office/drawing/2014/main" id="{C991F367-3184-4418-9F75-11C633A9902C}"/>
+                <a16:creationId xmlns:a16="http://schemas.microsoft.com/office/drawing/2014/main" id="{210B3642-88EF-4614-8265-C033BC2ACE51}"/>
               </a:ext>
             </a:extLst>
           </p:cNvPr>
@@ -5511,7 +6265,7 @@
           <p:cNvPr id="2" name="">
             <a:extLst xmlns:a="http://schemas.openxmlformats.org/drawingml/2006/main">
               <a:ext uri="{FF2B5EF4-FFF2-40B4-BE49-F238E27FC236}">
-                <a16:creationId xmlns:a16="http://schemas.microsoft.com/office/drawing/2014/main" id="{678A159B-3CA1-47F9-9C4A-43213354E795}"/>
+                <a16:creationId xmlns:a16="http://schemas.microsoft.com/office/drawing/2014/main" id="{DC6D6513-C10A-4C79-981E-4B23FE3E6E47}"/>
               </a:ext>
             </a:extLst>
           </p:cNvPr>
@@ -5568,7 +6322,7 @@
           <p:cNvPr id="3" name="">
             <a:extLst xmlns:a="http://schemas.openxmlformats.org/drawingml/2006/main">
               <a:ext uri="{FF2B5EF4-FFF2-40B4-BE49-F238E27FC236}">
-                <a16:creationId xmlns:a16="http://schemas.microsoft.com/office/drawing/2014/main" id="{147ACC5C-4D93-4448-B1DE-A9C37EC6C140}"/>
+                <a16:creationId xmlns:a16="http://schemas.microsoft.com/office/drawing/2014/main" id="{36B9D62B-01C8-420B-B374-F39208857110}"/>
               </a:ext>
             </a:extLst>
           </p:cNvPr>
@@ -5615,7 +6369,7 @@
                 <a:ea typeface="Arial"/>
                 <a:cs typeface="Arial"/>
               </a:rPr>
-              <a:t>In Codex, type @ and select skill-installer. Then paste:</a:t>
+              <a:t>In Codex, paste this request:</a:t>
             </a:r>
           </a:p>
         </p:txBody>
@@ -5625,7 +6379,7 @@
           <p:cNvPr id="4" name="">
             <a:extLst xmlns:a="http://schemas.openxmlformats.org/drawingml/2006/main">
               <a:ext uri="{FF2B5EF4-FFF2-40B4-BE49-F238E27FC236}">
-                <a16:creationId xmlns:a16="http://schemas.microsoft.com/office/drawing/2014/main" id="{2D665317-4307-4CCF-9F8A-D4527E677C57}"/>
+                <a16:creationId xmlns:a16="http://schemas.microsoft.com/office/drawing/2014/main" id="{15B9B087-0988-4BE2-A615-D33FE5092918}"/>
               </a:ext>
             </a:extLst>
           </p:cNvPr>
@@ -5636,8 +6390,8 @@
         </p:nvSpPr>
         <p:spPr>
           <a:xfrm xmlns:a="http://schemas.openxmlformats.org/drawingml/2006/main">
-            <a:off x="609600" y="1952625"/>
-            <a:ext cx="10972800" cy="2895600"/>
+            <a:off x="609600" y="1809750"/>
+            <a:ext cx="10972800" cy="3238500"/>
           </a:xfrm>
           <a:prstGeom xmlns:a="http://schemas.openxmlformats.org/drawingml/2006/main" prst="rect">
             <a:avLst/>
@@ -5655,7 +6409,7 @@
           <p:cNvPr id="5" name="">
             <a:extLst xmlns:a="http://schemas.openxmlformats.org/drawingml/2006/main">
               <a:ext uri="{FF2B5EF4-FFF2-40B4-BE49-F238E27FC236}">
-                <a16:creationId xmlns:a16="http://schemas.microsoft.com/office/drawing/2014/main" id="{F2B9AB8A-7110-4AD0-939A-0A3A78AFD92A}"/>
+                <a16:creationId xmlns:a16="http://schemas.microsoft.com/office/drawing/2014/main" id="{8AB3C2A0-2895-47D2-A59F-EB35C64100A9}"/>
               </a:ext>
             </a:extLst>
           </p:cNvPr>
@@ -5666,7 +6420,7 @@
         </p:nvSpPr>
         <p:spPr>
           <a:xfrm xmlns:a="http://schemas.openxmlformats.org/drawingml/2006/main">
-            <a:off x="876300" y="2257425"/>
+            <a:off x="876300" y="2095500"/>
             <a:ext cx="10439400" cy="361950"/>
           </a:xfrm>
           <a:prstGeom xmlns:a="http://schemas.openxmlformats.org/drawingml/2006/main" prst="rect">
@@ -5702,7 +6456,7 @@
                 <a:ea typeface="Courier New"/>
                 <a:cs typeface="Courier New"/>
               </a:rPr>
-              <a:t>Install skills/paper-search and skills/zotero-save from:</a:t>
+              <a:t>Use skill-installer to install skills/paper-search,</a:t>
             </a:r>
           </a:p>
         </p:txBody>
@@ -5712,7 +6466,7 @@
           <p:cNvPr id="6" name="">
             <a:extLst xmlns:a="http://schemas.openxmlformats.org/drawingml/2006/main">
               <a:ext uri="{FF2B5EF4-FFF2-40B4-BE49-F238E27FC236}">
-                <a16:creationId xmlns:a16="http://schemas.microsoft.com/office/drawing/2014/main" id="{89DB719E-BB46-4BE5-96B3-0BAE68C179A7}"/>
+                <a16:creationId xmlns:a16="http://schemas.microsoft.com/office/drawing/2014/main" id="{5D0CF59A-D7CF-49A2-86CE-C6417905B350}"/>
               </a:ext>
             </a:extLst>
           </p:cNvPr>
@@ -5723,7 +6477,7 @@
         </p:nvSpPr>
         <p:spPr>
           <a:xfrm xmlns:a="http://schemas.openxmlformats.org/drawingml/2006/main">
-            <a:off x="876300" y="2876550"/>
+            <a:off x="876300" y="2476500"/>
             <a:ext cx="10439400" cy="361950"/>
           </a:xfrm>
           <a:prstGeom xmlns:a="http://schemas.openxmlformats.org/drawingml/2006/main" prst="rect">
@@ -5758,9 +6512,8 @@
                 <a:latin typeface="Courier New"/>
                 <a:ea typeface="Courier New"/>
                 <a:cs typeface="Courier New"/>
-                <a:hlinkClick xmlns:r="http://schemas.openxmlformats.org/officeDocument/2006/relationships" r:id="Re49cd519556a4d94"/>
               </a:rPr>
-              <a:t>https://github.com/Alias-z/agentic-researcher-psc</a:t>
+              <a:t>skills/zotero-save, and skills/paper-reading from:</a:t>
             </a:r>
           </a:p>
         </p:txBody>
@@ -5770,7 +6523,7 @@
           <p:cNvPr id="7" name="">
             <a:extLst xmlns:a="http://schemas.openxmlformats.org/drawingml/2006/main">
               <a:ext uri="{FF2B5EF4-FFF2-40B4-BE49-F238E27FC236}">
-                <a16:creationId xmlns:a16="http://schemas.microsoft.com/office/drawing/2014/main" id="{1749A9F3-F6F3-4F4A-BFAA-68696978A309}"/>
+                <a16:creationId xmlns:a16="http://schemas.microsoft.com/office/drawing/2014/main" id="{C5CA9B2E-7692-4A5E-B7AF-DF75DCC908CE}"/>
               </a:ext>
             </a:extLst>
           </p:cNvPr>
@@ -5781,7 +6534,7 @@
         </p:nvSpPr>
         <p:spPr>
           <a:xfrm xmlns:a="http://schemas.openxmlformats.org/drawingml/2006/main">
-            <a:off x="876300" y="3629025"/>
+            <a:off x="876300" y="3086100"/>
             <a:ext cx="10439400" cy="361950"/>
           </a:xfrm>
           <a:prstGeom xmlns:a="http://schemas.openxmlformats.org/drawingml/2006/main" prst="rect">
@@ -5816,8 +6569,9 @@
                 <a:latin typeface="Courier New"/>
                 <a:ea typeface="Courier New"/>
                 <a:cs typeface="Courier New"/>
+                <a:hlinkClick xmlns:r="http://schemas.openxmlformats.org/officeDocument/2006/relationships" r:id="R63352c1fee884419"/>
               </a:rPr>
-              <a:t>If python3 is unavailable, use the Python executable from</a:t>
+              <a:t>https://github.com/Alias-z/agentic-researcher-psc</a:t>
             </a:r>
           </a:p>
         </p:txBody>
@@ -5827,7 +6581,7 @@
           <p:cNvPr id="8" name="">
             <a:extLst xmlns:a="http://schemas.openxmlformats.org/drawingml/2006/main">
               <a:ext uri="{FF2B5EF4-FFF2-40B4-BE49-F238E27FC236}">
-                <a16:creationId xmlns:a16="http://schemas.microsoft.com/office/drawing/2014/main" id="{2D0ABF89-CB51-40F0-B399-28FB9640E947}"/>
+                <a16:creationId xmlns:a16="http://schemas.microsoft.com/office/drawing/2014/main" id="{B00A7D61-BDD9-4F56-B2AA-D997401615AA}"/>
               </a:ext>
             </a:extLst>
           </p:cNvPr>
@@ -5838,7 +6592,7 @@
         </p:nvSpPr>
         <p:spPr>
           <a:xfrm xmlns:a="http://schemas.openxmlformats.org/drawingml/2006/main">
-            <a:off x="876300" y="4029075"/>
+            <a:off x="876300" y="3819525"/>
             <a:ext cx="10439400" cy="361950"/>
           </a:xfrm>
           <a:prstGeom xmlns:a="http://schemas.openxmlformats.org/drawingml/2006/main" prst="rect">
@@ -5874,7 +6628,7 @@
                 <a:ea typeface="Courier New"/>
                 <a:cs typeface="Courier New"/>
               </a:rPr>
-              <a:t>load_workspace_dependencies for the installer.</a:t>
+              <a:t>If python3 is unavailable, use the Python executable from</a:t>
             </a:r>
           </a:p>
         </p:txBody>
@@ -5884,7 +6638,7 @@
           <p:cNvPr id="9" name="">
             <a:extLst xmlns:a="http://schemas.openxmlformats.org/drawingml/2006/main">
               <a:ext uri="{FF2B5EF4-FFF2-40B4-BE49-F238E27FC236}">
-                <a16:creationId xmlns:a16="http://schemas.microsoft.com/office/drawing/2014/main" id="{5A178D26-AA45-463C-B2E5-A34B9350E7F1}"/>
+                <a16:creationId xmlns:a16="http://schemas.microsoft.com/office/drawing/2014/main" id="{5D64FECA-8F8B-434A-AB31-2BEFDBB40BD5}"/>
               </a:ext>
             </a:extLst>
           </p:cNvPr>
@@ -5895,8 +6649,8 @@
         </p:nvSpPr>
         <p:spPr>
           <a:xfrm xmlns:a="http://schemas.openxmlformats.org/drawingml/2006/main">
-            <a:off x="609600" y="5334000"/>
-            <a:ext cx="10972800" cy="361950"/>
+            <a:off x="876300" y="4219575"/>
+            <a:ext cx="10439400" cy="361950"/>
           </a:xfrm>
           <a:prstGeom xmlns:a="http://schemas.openxmlformats.org/drawingml/2006/main" prst="rect">
             <a:avLst/>
@@ -5913,16 +6667,73 @@
           <a:lstStyle xmlns:a="http://schemas.openxmlformats.org/drawingml/2006/main"/>
           <a:p xmlns:a="http://schemas.openxmlformats.org/drawingml/2006/main">
             <a:pPr algn="l">
-              <a:defRPr sz="1875" b="0">
-                <a:solidFill>
-                  <a:srgbClr val="536166"/>
-                </a:solidFill>
-                <a:latin typeface="Arial"/>
-                <a:ea typeface="Arial"/>
-                <a:cs typeface="Arial"/>
+              <a:defRPr sz="1950" b="0">
+                <a:solidFill>
+                  <a:srgbClr val="172C31"/>
+                </a:solidFill>
+                <a:latin typeface="Courier New"/>
+                <a:ea typeface="Courier New"/>
+                <a:cs typeface="Courier New"/>
               </a:defRPr>
             </a:pPr>
             <a:r>
+              <a:rPr sz="1950" b="0">
+                <a:solidFill>
+                  <a:srgbClr val="172C31"/>
+                </a:solidFill>
+                <a:latin typeface="Courier New"/>
+                <a:ea typeface="Courier New"/>
+                <a:cs typeface="Courier New"/>
+              </a:rPr>
+              <a:t>load_workspace_dependencies for the installer.</a:t>
+            </a:r>
+          </a:p>
+        </p:txBody>
+      </p:sp>
+      <p:sp>
+        <p:nvSpPr>
+          <p:cNvPr id="10" name="">
+            <a:extLst xmlns:a="http://schemas.openxmlformats.org/drawingml/2006/main">
+              <a:ext uri="{FF2B5EF4-FFF2-40B4-BE49-F238E27FC236}">
+                <a16:creationId xmlns:a16="http://schemas.microsoft.com/office/drawing/2014/main" id="{AC96E7CF-997C-4122-9BAA-FE389E83FE8A}"/>
+              </a:ext>
+            </a:extLst>
+          </p:cNvPr>
+          <p:cNvSpPr>
+            <a:spLocks xmlns:a="http://schemas.openxmlformats.org/drawingml/2006/main" noGrp="1"/>
+          </p:cNvSpPr>
+          <p:nvPr/>
+        </p:nvSpPr>
+        <p:spPr>
+          <a:xfrm xmlns:a="http://schemas.openxmlformats.org/drawingml/2006/main">
+            <a:off x="609600" y="5334000"/>
+            <a:ext cx="10972800" cy="361950"/>
+          </a:xfrm>
+          <a:prstGeom xmlns:a="http://schemas.openxmlformats.org/drawingml/2006/main" prst="rect">
+            <a:avLst/>
+          </a:prstGeom>
+          <a:noFill xmlns:a="http://schemas.openxmlformats.org/drawingml/2006/main"/>
+          <a:ln xmlns:a="http://schemas.openxmlformats.org/drawingml/2006/main" w="0">
+            <a:noFill/>
+          </a:ln>
+        </p:spPr>
+        <p:txBody>
+          <a:bodyPr xmlns:a="http://schemas.openxmlformats.org/drawingml/2006/main" wrap="none" lIns="0" tIns="0" rIns="0" bIns="0" anchor="t">
+            <a:noAutofit/>
+          </a:bodyPr>
+          <a:lstStyle xmlns:a="http://schemas.openxmlformats.org/drawingml/2006/main"/>
+          <a:p xmlns:a="http://schemas.openxmlformats.org/drawingml/2006/main">
+            <a:pPr algn="l">
+              <a:defRPr sz="1875" b="0">
+                <a:solidFill>
+                  <a:srgbClr val="536166"/>
+                </a:solidFill>
+                <a:latin typeface="Arial"/>
+                <a:ea typeface="Arial"/>
+                <a:cs typeface="Arial"/>
+              </a:defRPr>
+            </a:pPr>
+            <a:r>
               <a:rPr sz="1875" b="0">
                 <a:solidFill>
                   <a:srgbClr val="536166"/>
@@ -5931,7 +6742,7 @@
                 <a:ea typeface="Arial"/>
                 <a:cs typeface="Arial"/>
               </a:rPr>
-              <a:t>To use a skill later, type @ and select paper-search or zotero-save.</a:t>
+              <a:t>Then ask to use a skill by name, for example: “Use paper-reading to read…”</a:t>
             </a:r>
           </a:p>
         </p:txBody>
@@ -5939,7 +6750,7 @@
     </p:spTree>
     <p:extLst>
       <p:ext uri="{BB962C8B-B14F-4D97-AF65-F5344CB8AC3E}">
-        <p14:creationId xmlns:p14="http://schemas.microsoft.com/office/powerpoint/2010/main" val="1187832934"/>
+        <p14:creationId xmlns:p14="http://schemas.microsoft.com/office/powerpoint/2010/main" val="1377925183"/>
       </p:ext>
     </p:extLst>
   </p:cSld>
@@ -5970,7 +6781,7 @@
           <p:cNvPr id="7" name="">
             <a:extLst xmlns:a="http://schemas.openxmlformats.org/drawingml/2006/main">
               <a:ext uri="{FF2B5EF4-FFF2-40B4-BE49-F238E27FC236}">
-                <a16:creationId xmlns:a16="http://schemas.microsoft.com/office/drawing/2014/main" id="{21C08B76-601B-474F-807F-A0BE41557D26}"/>
+                <a16:creationId xmlns:a16="http://schemas.microsoft.com/office/drawing/2014/main" id="{11D4FEE5-C55E-478A-B61C-A102ED445BA7}"/>
               </a:ext>
             </a:extLst>
           </p:cNvPr>
@@ -6017,7 +6828,7 @@
                 <a:ea typeface="Arial"/>
                 <a:cs typeface="Arial"/>
               </a:rPr>
-              <a:t>Zotero plugin</a:t>
+              <a:t>Zotero plugin (optional)</a:t>
             </a:r>
           </a:p>
         </p:txBody>
@@ -6027,7 +6838,7 @@
           <p:cNvPr id="2" name="">
             <a:extLst xmlns:a="http://schemas.openxmlformats.org/drawingml/2006/main">
               <a:ext uri="{FF2B5EF4-FFF2-40B4-BE49-F238E27FC236}">
-                <a16:creationId xmlns:a16="http://schemas.microsoft.com/office/drawing/2014/main" id="{F1710C09-0B9A-4851-B90A-0D66000FA7B0}"/>
+                <a16:creationId xmlns:a16="http://schemas.microsoft.com/office/drawing/2014/main" id="{8A26E6BD-E8BC-4FF0-AACA-24104AE12E04}"/>
               </a:ext>
             </a:extLst>
           </p:cNvPr>
@@ -6084,7 +6895,7 @@
           <p:cNvPr id="3" name="">
             <a:extLst xmlns:a="http://schemas.openxmlformats.org/drawingml/2006/main">
               <a:ext uri="{FF2B5EF4-FFF2-40B4-BE49-F238E27FC236}">
-                <a16:creationId xmlns:a16="http://schemas.microsoft.com/office/drawing/2014/main" id="{DC7E4424-F79A-4E88-94BF-A25EBB074248}"/>
+                <a16:creationId xmlns:a16="http://schemas.microsoft.com/office/drawing/2014/main" id="{1B094F1B-B193-4938-9631-9C7893D14C08}"/>
               </a:ext>
             </a:extLst>
           </p:cNvPr>
@@ -6131,7 +6942,7 @@
                 <a:ea typeface="Arial"/>
                 <a:cs typeface="Arial"/>
               </a:rPr>
-              <a:t>In Codex Plugins, search "zotero" and install Zotero for use in later chats.</a:t>
+              <a:t>For citation exports, open Plugins, search "zotero", and install Zotero.</a:t>
             </a:r>
           </a:p>
         </p:txBody>
@@ -6145,10 +6956,10 @@
           <p:nvPr/>
         </p:nvPicPr>
         <p:blipFill>
-          <a:blip xmlns:r="http://schemas.openxmlformats.org/officeDocument/2006/relationships" xmlns:a="http://schemas.openxmlformats.org/drawingml/2006/main" r:embed="Rea6416b8b9fe4ac9">
+          <a:blip xmlns:r="http://schemas.openxmlformats.org/officeDocument/2006/relationships" xmlns:a="http://schemas.openxmlformats.org/drawingml/2006/main" r:embed="Rc26e4c4355bc4e60">
             <a:extLst>
               <a:ext uri="{96DAC541-7B7A-43D3-8B79-37D633B846F1}">
-                <asvg:svgBlip xmlns:asvg="http://schemas.microsoft.com/office/drawing/2016/SVG/main" r:embed="R179d0d545753495e"/>
+                <asvg:svgBlip xmlns:asvg="http://schemas.microsoft.com/office/drawing/2016/SVG/main" r:embed="Rb2c0a5eeb4c84690"/>
               </a:ext>
             </a:extLst>
           </a:blip>
@@ -6169,7 +6980,7 @@
           <p:cNvPr id="5" name="">
             <a:extLst xmlns:a="http://schemas.openxmlformats.org/drawingml/2006/main">
               <a:ext uri="{FF2B5EF4-FFF2-40B4-BE49-F238E27FC236}">
-                <a16:creationId xmlns:a16="http://schemas.microsoft.com/office/drawing/2014/main" id="{8AA3BC82-9D62-414C-A473-CA98FCCCC9B6}"/>
+                <a16:creationId xmlns:a16="http://schemas.microsoft.com/office/drawing/2014/main" id="{8B63352E-A654-4C41-877E-C2E573F7313E}"/>
               </a:ext>
             </a:extLst>
           </p:cNvPr>
@@ -6216,7 +7027,7 @@
                 <a:ea typeface="Arial"/>
                 <a:cs typeface="Arial"/>
               </a:rPr>
-              <a:t>paper-search finds papers; zotero-save saves selected papers and available PDFs.</a:t>
+              <a:t>Use the plugin for general library searches and BibTeX/citation exports.</a:t>
             </a:r>
           </a:p>
         </p:txBody>
@@ -6226,7 +7037,7 @@
           <p:cNvPr id="6" name="">
             <a:extLst xmlns:a="http://schemas.openxmlformats.org/drawingml/2006/main">
               <a:ext uri="{FF2B5EF4-FFF2-40B4-BE49-F238E27FC236}">
-                <a16:creationId xmlns:a16="http://schemas.microsoft.com/office/drawing/2014/main" id="{1C6D4B31-A9DB-4749-91A3-433CA4E0CA6C}"/>
+                <a16:creationId xmlns:a16="http://schemas.microsoft.com/office/drawing/2014/main" id="{68B54087-D9D0-4B69-92E0-DA0FDD63B966}"/>
               </a:ext>
             </a:extLst>
           </p:cNvPr>
@@ -6273,7 +7084,7 @@
                 <a:ea typeface="Arial"/>
                 <a:cs typeface="Arial"/>
               </a:rPr>
-              <a:t>The Zotero plugin reads their indexed text and helps with citations.</a:t>
+              <a:t>paper-reading can read papers and save notes without this plugin.</a:t>
             </a:r>
           </a:p>
         </p:txBody>
@@ -6281,7 +7092,618 @@
     </p:spTree>
     <p:extLst>
       <p:ext uri="{BB962C8B-B14F-4D97-AF65-F5344CB8AC3E}">
-        <p14:creationId xmlns:p14="http://schemas.microsoft.com/office/powerpoint/2010/main" val="703869016"/>
+        <p14:creationId xmlns:p14="http://schemas.microsoft.com/office/powerpoint/2010/main" val="1155263117"/>
+      </p:ext>
+    </p:extLst>
+  </p:cSld>
+</p:sld>
+</file>
+
+<file path=ppt/slides/slide9.xml><?xml version="1.0" encoding="utf-8"?>
+<p:sld xmlns:p="http://schemas.openxmlformats.org/presentationml/2006/main">
+  <p:cSld>
+    <p:bg>
+      <p:bgPr>
+        <a:solidFill xmlns:a="http://schemas.openxmlformats.org/drawingml/2006/main">
+          <a:srgbClr val="FFFFFF"/>
+        </a:solidFill>
+      </p:bgPr>
+    </p:bg>
+    <p:spTree>
+      <p:nvGrpSpPr>
+        <p:cNvPr id="1" name=""/>
+        <p:cNvGrpSpPr/>
+        <p:nvPr/>
+      </p:nvGrpSpPr>
+      <p:grpSpPr>
+        <a:xfrm xmlns:a="http://schemas.openxmlformats.org/drawingml/2006/main"/>
+      </p:grpSpPr>
+      <p:sp>
+        <p:nvSpPr>
+          <p:cNvPr id="10" name="">
+            <a:extLst xmlns:a="http://schemas.openxmlformats.org/drawingml/2006/main">
+              <a:ext uri="{FF2B5EF4-FFF2-40B4-BE49-F238E27FC236}">
+                <a16:creationId xmlns:a16="http://schemas.microsoft.com/office/drawing/2014/main" id="{85698B1A-3C91-48BA-99FF-068ACE56CEC1}"/>
+              </a:ext>
+            </a:extLst>
+          </p:cNvPr>
+          <p:cNvSpPr>
+            <a:spLocks xmlns:a="http://schemas.openxmlformats.org/drawingml/2006/main" noGrp="1"/>
+          </p:cNvSpPr>
+          <p:nvPr/>
+        </p:nvSpPr>
+        <p:spPr>
+          <a:xfrm xmlns:a="http://schemas.openxmlformats.org/drawingml/2006/main">
+            <a:off x="609600" y="361950"/>
+            <a:ext cx="10972800" cy="571500"/>
+          </a:xfrm>
+          <a:prstGeom xmlns:a="http://schemas.openxmlformats.org/drawingml/2006/main" prst="rect">
+            <a:avLst/>
+          </a:prstGeom>
+          <a:noFill xmlns:a="http://schemas.openxmlformats.org/drawingml/2006/main"/>
+          <a:ln xmlns:a="http://schemas.openxmlformats.org/drawingml/2006/main" w="0">
+            <a:noFill/>
+          </a:ln>
+        </p:spPr>
+        <p:txBody>
+          <a:bodyPr xmlns:a="http://schemas.openxmlformats.org/drawingml/2006/main" wrap="none" lIns="0" tIns="0" rIns="0" bIns="0" anchor="t">
+            <a:noAutofit/>
+          </a:bodyPr>
+          <a:lstStyle xmlns:a="http://schemas.openxmlformats.org/drawingml/2006/main"/>
+          <a:p xmlns:a="http://schemas.openxmlformats.org/drawingml/2006/main">
+            <a:pPr algn="l">
+              <a:defRPr sz="3300" b="1">
+                <a:solidFill>
+                  <a:srgbClr val="147477"/>
+                </a:solidFill>
+                <a:latin typeface="Arial"/>
+                <a:ea typeface="Arial"/>
+                <a:cs typeface="Arial"/>
+              </a:defRPr>
+            </a:pPr>
+            <a:r>
+              <a:rPr sz="3300" b="1">
+                <a:solidFill>
+                  <a:srgbClr val="147477"/>
+                </a:solidFill>
+                <a:latin typeface="Arial"/>
+                <a:ea typeface="Arial"/>
+                <a:cs typeface="Arial"/>
+              </a:rPr>
+              <a:t>Reading always leaves notes</a:t>
+            </a:r>
+          </a:p>
+        </p:txBody>
+      </p:sp>
+      <p:sp>
+        <p:nvSpPr>
+          <p:cNvPr id="2" name="">
+            <a:extLst xmlns:a="http://schemas.openxmlformats.org/drawingml/2006/main">
+              <a:ext uri="{FF2B5EF4-FFF2-40B4-BE49-F238E27FC236}">
+                <a16:creationId xmlns:a16="http://schemas.microsoft.com/office/drawing/2014/main" id="{0F4D0BF1-C68A-40A2-AAD9-6FF05F00952A}"/>
+              </a:ext>
+            </a:extLst>
+          </p:cNvPr>
+          <p:cNvSpPr>
+            <a:spLocks xmlns:a="http://schemas.openxmlformats.org/drawingml/2006/main" noGrp="1"/>
+          </p:cNvSpPr>
+          <p:nvPr/>
+        </p:nvSpPr>
+        <p:spPr>
+          <a:xfrm xmlns:a="http://schemas.openxmlformats.org/drawingml/2006/main">
+            <a:off x="11125200" y="6448425"/>
+            <a:ext cx="457200" cy="228600"/>
+          </a:xfrm>
+          <a:prstGeom xmlns:a="http://schemas.openxmlformats.org/drawingml/2006/main" prst="rect">
+            <a:avLst/>
+          </a:prstGeom>
+          <a:noFill xmlns:a="http://schemas.openxmlformats.org/drawingml/2006/main"/>
+          <a:ln xmlns:a="http://schemas.openxmlformats.org/drawingml/2006/main" w="0">
+            <a:noFill/>
+          </a:ln>
+        </p:spPr>
+        <p:txBody>
+          <a:bodyPr xmlns:a="http://schemas.openxmlformats.org/drawingml/2006/main" wrap="none" lIns="0" tIns="0" rIns="0" bIns="0" anchor="t">
+            <a:noAutofit/>
+          </a:bodyPr>
+          <a:lstStyle xmlns:a="http://schemas.openxmlformats.org/drawingml/2006/main"/>
+          <a:p xmlns:a="http://schemas.openxmlformats.org/drawingml/2006/main">
+            <a:pPr algn="r">
+              <a:defRPr sz="1275" b="0">
+                <a:solidFill>
+                  <a:srgbClr val="536166"/>
+                </a:solidFill>
+                <a:latin typeface="Arial"/>
+                <a:ea typeface="Arial"/>
+                <a:cs typeface="Arial"/>
+              </a:defRPr>
+            </a:pPr>
+            <a:r>
+              <a:rPr sz="1275" b="0">
+                <a:solidFill>
+                  <a:srgbClr val="536166"/>
+                </a:solidFill>
+                <a:latin typeface="Arial"/>
+                <a:ea typeface="Arial"/>
+                <a:cs typeface="Arial"/>
+              </a:rPr>
+              <a:t>9</a:t>
+            </a:r>
+          </a:p>
+        </p:txBody>
+      </p:sp>
+      <p:sp>
+        <p:nvSpPr>
+          <p:cNvPr id="3" name="">
+            <a:extLst xmlns:a="http://schemas.openxmlformats.org/drawingml/2006/main">
+              <a:ext uri="{FF2B5EF4-FFF2-40B4-BE49-F238E27FC236}">
+                <a16:creationId xmlns:a16="http://schemas.microsoft.com/office/drawing/2014/main" id="{FCBE39AC-1FDC-4B3E-A379-058DCEE6BC24}"/>
+              </a:ext>
+            </a:extLst>
+          </p:cNvPr>
+          <p:cNvSpPr>
+            <a:spLocks xmlns:a="http://schemas.openxmlformats.org/drawingml/2006/main" noGrp="1"/>
+          </p:cNvSpPr>
+          <p:nvPr/>
+        </p:nvSpPr>
+        <p:spPr>
+          <a:xfrm xmlns:a="http://schemas.openxmlformats.org/drawingml/2006/main">
+            <a:off x="609600" y="1676400"/>
+            <a:ext cx="2857500" cy="428625"/>
+          </a:xfrm>
+          <a:prstGeom xmlns:a="http://schemas.openxmlformats.org/drawingml/2006/main" prst="rect">
+            <a:avLst/>
+          </a:prstGeom>
+          <a:noFill xmlns:a="http://schemas.openxmlformats.org/drawingml/2006/main"/>
+          <a:ln xmlns:a="http://schemas.openxmlformats.org/drawingml/2006/main" w="0">
+            <a:noFill/>
+          </a:ln>
+        </p:spPr>
+        <p:txBody>
+          <a:bodyPr xmlns:a="http://schemas.openxmlformats.org/drawingml/2006/main" wrap="none" lIns="0" tIns="0" rIns="0" bIns="0" anchor="t">
+            <a:noAutofit/>
+          </a:bodyPr>
+          <a:lstStyle xmlns:a="http://schemas.openxmlformats.org/drawingml/2006/main"/>
+          <a:p xmlns:a="http://schemas.openxmlformats.org/drawingml/2006/main">
+            <a:pPr algn="l">
+              <a:defRPr sz="2250" b="1">
+                <a:solidFill>
+                  <a:srgbClr val="172C31"/>
+                </a:solidFill>
+                <a:latin typeface="Arial"/>
+                <a:ea typeface="Arial"/>
+                <a:cs typeface="Arial"/>
+              </a:defRPr>
+            </a:pPr>
+            <a:r>
+              <a:rPr sz="2250" b="1">
+                <a:solidFill>
+                  <a:srgbClr val="172C31"/>
+                </a:solidFill>
+                <a:latin typeface="Arial"/>
+                <a:ea typeface="Arial"/>
+                <a:cs typeface="Arial"/>
+              </a:rPr>
+              <a:t>Markdown file</a:t>
+            </a:r>
+          </a:p>
+        </p:txBody>
+      </p:sp>
+      <p:sp>
+        <p:nvSpPr>
+          <p:cNvPr id="4" name="">
+            <a:extLst xmlns:a="http://schemas.openxmlformats.org/drawingml/2006/main">
+              <a:ext uri="{FF2B5EF4-FFF2-40B4-BE49-F238E27FC236}">
+                <a16:creationId xmlns:a16="http://schemas.microsoft.com/office/drawing/2014/main" id="{29C6CC18-809F-44E9-B01D-5DC6E4D818C7}"/>
+              </a:ext>
+            </a:extLst>
+          </p:cNvPr>
+          <p:cNvSpPr>
+            <a:spLocks xmlns:a="http://schemas.openxmlformats.org/drawingml/2006/main" noGrp="1"/>
+          </p:cNvSpPr>
+          <p:nvPr/>
+        </p:nvSpPr>
+        <p:spPr>
+          <a:xfrm xmlns:a="http://schemas.openxmlformats.org/drawingml/2006/main">
+            <a:off x="3667125" y="1676400"/>
+            <a:ext cx="7905750" cy="895350"/>
+          </a:xfrm>
+          <a:prstGeom xmlns:a="http://schemas.openxmlformats.org/drawingml/2006/main" prst="rect">
+            <a:avLst/>
+          </a:prstGeom>
+          <a:noFill xmlns:a="http://schemas.openxmlformats.org/drawingml/2006/main"/>
+          <a:ln xmlns:a="http://schemas.openxmlformats.org/drawingml/2006/main" w="0">
+            <a:noFill/>
+          </a:ln>
+        </p:spPr>
+        <p:txBody>
+          <a:bodyPr xmlns:a="http://schemas.openxmlformats.org/drawingml/2006/main" wrap="none" lIns="0" tIns="0" rIns="0" bIns="0" anchor="t">
+            <a:noAutofit/>
+          </a:bodyPr>
+          <a:lstStyle xmlns:a="http://schemas.openxmlformats.org/drawingml/2006/main"/>
+          <a:p xmlns:a="http://schemas.openxmlformats.org/drawingml/2006/main">
+            <a:pPr algn="l">
+              <a:defRPr sz="1950" b="0">
+                <a:solidFill>
+                  <a:srgbClr val="172C31"/>
+                </a:solidFill>
+                <a:latin typeface="Arial"/>
+                <a:ea typeface="Arial"/>
+                <a:cs typeface="Arial"/>
+              </a:defRPr>
+            </a:pPr>
+            <a:r>
+              <a:rPr sz="1950" b="0">
+                <a:solidFill>
+                  <a:srgbClr val="172C31"/>
+                </a:solidFill>
+                <a:latin typeface="Arial"/>
+                <a:ea typeface="Arial"/>
+                <a:cs typeface="Arial"/>
+              </a:rPr>
+              <a:t>One editable .md file per paper in your notes folder.</a:t>
+            </a:r>
+          </a:p>
+          <a:p xmlns:a="http://schemas.openxmlformats.org/drawingml/2006/main">
+            <a:pPr algn="l">
+              <a:defRPr sz="1950" b="0">
+                <a:solidFill>
+                  <a:srgbClr val="172C31"/>
+                </a:solidFill>
+                <a:latin typeface="Arial"/>
+                <a:ea typeface="Arial"/>
+                <a:cs typeface="Arial"/>
+              </a:defRPr>
+            </a:pPr>
+            <a:r>
+              <a:rPr sz="1950" b="0">
+                <a:solidFill>
+                  <a:srgbClr val="172C31"/>
+                </a:solidFill>
+                <a:latin typeface="Arial"/>
+                <a:ea typeface="Arial"/>
+                <a:cs typeface="Arial"/>
+              </a:rPr>
+              <a:t>Keep findings, evidence references, and LaTeX source together.</a:t>
+            </a:r>
+          </a:p>
+        </p:txBody>
+      </p:sp>
+      <p:sp>
+        <p:nvSpPr>
+          <p:cNvPr id="5" name="">
+            <a:extLst xmlns:a="http://schemas.openxmlformats.org/drawingml/2006/main">
+              <a:ext uri="{FF2B5EF4-FFF2-40B4-BE49-F238E27FC236}">
+                <a16:creationId xmlns:a16="http://schemas.microsoft.com/office/drawing/2014/main" id="{923BD76F-A994-481D-8F66-21FFB094C96F}"/>
+              </a:ext>
+            </a:extLst>
+          </p:cNvPr>
+          <p:cNvSpPr>
+            <a:spLocks xmlns:a="http://schemas.openxmlformats.org/drawingml/2006/main" noGrp="1"/>
+          </p:cNvSpPr>
+          <p:nvPr/>
+        </p:nvSpPr>
+        <p:spPr>
+          <a:xfrm xmlns:a="http://schemas.openxmlformats.org/drawingml/2006/main">
+            <a:off x="609600" y="3057525"/>
+            <a:ext cx="2857500" cy="428625"/>
+          </a:xfrm>
+          <a:prstGeom xmlns:a="http://schemas.openxmlformats.org/drawingml/2006/main" prst="rect">
+            <a:avLst/>
+          </a:prstGeom>
+          <a:noFill xmlns:a="http://schemas.openxmlformats.org/drawingml/2006/main"/>
+          <a:ln xmlns:a="http://schemas.openxmlformats.org/drawingml/2006/main" w="0">
+            <a:noFill/>
+          </a:ln>
+        </p:spPr>
+        <p:txBody>
+          <a:bodyPr xmlns:a="http://schemas.openxmlformats.org/drawingml/2006/main" wrap="none" lIns="0" tIns="0" rIns="0" bIns="0" anchor="t">
+            <a:noAutofit/>
+          </a:bodyPr>
+          <a:lstStyle xmlns:a="http://schemas.openxmlformats.org/drawingml/2006/main"/>
+          <a:p xmlns:a="http://schemas.openxmlformats.org/drawingml/2006/main">
+            <a:pPr algn="l">
+              <a:defRPr sz="2250" b="1">
+                <a:solidFill>
+                  <a:srgbClr val="172C31"/>
+                </a:solidFill>
+                <a:latin typeface="Arial"/>
+                <a:ea typeface="Arial"/>
+                <a:cs typeface="Arial"/>
+              </a:defRPr>
+            </a:pPr>
+            <a:r>
+              <a:rPr sz="2250" b="1">
+                <a:solidFill>
+                  <a:srgbClr val="172C31"/>
+                </a:solidFill>
+                <a:latin typeface="Arial"/>
+                <a:ea typeface="Arial"/>
+                <a:cs typeface="Arial"/>
+              </a:rPr>
+              <a:t>Zotero copy</a:t>
+            </a:r>
+          </a:p>
+        </p:txBody>
+      </p:sp>
+      <p:sp>
+        <p:nvSpPr>
+          <p:cNvPr id="6" name="">
+            <a:extLst xmlns:a="http://schemas.openxmlformats.org/drawingml/2006/main">
+              <a:ext uri="{FF2B5EF4-FFF2-40B4-BE49-F238E27FC236}">
+                <a16:creationId xmlns:a16="http://schemas.microsoft.com/office/drawing/2014/main" id="{8F8825CC-E61A-404B-9938-5E2EC6F05D34}"/>
+              </a:ext>
+            </a:extLst>
+          </p:cNvPr>
+          <p:cNvSpPr>
+            <a:spLocks xmlns:a="http://schemas.openxmlformats.org/drawingml/2006/main" noGrp="1"/>
+          </p:cNvSpPr>
+          <p:nvPr/>
+        </p:nvSpPr>
+        <p:spPr>
+          <a:xfrm xmlns:a="http://schemas.openxmlformats.org/drawingml/2006/main">
+            <a:off x="3667125" y="3057525"/>
+            <a:ext cx="7905750" cy="895350"/>
+          </a:xfrm>
+          <a:prstGeom xmlns:a="http://schemas.openxmlformats.org/drawingml/2006/main" prst="rect">
+            <a:avLst/>
+          </a:prstGeom>
+          <a:noFill xmlns:a="http://schemas.openxmlformats.org/drawingml/2006/main"/>
+          <a:ln xmlns:a="http://schemas.openxmlformats.org/drawingml/2006/main" w="0">
+            <a:noFill/>
+          </a:ln>
+        </p:spPr>
+        <p:txBody>
+          <a:bodyPr xmlns:a="http://schemas.openxmlformats.org/drawingml/2006/main" wrap="none" lIns="0" tIns="0" rIns="0" bIns="0" anchor="t">
+            <a:noAutofit/>
+          </a:bodyPr>
+          <a:lstStyle xmlns:a="http://schemas.openxmlformats.org/drawingml/2006/main"/>
+          <a:p xmlns:a="http://schemas.openxmlformats.org/drawingml/2006/main">
+            <a:pPr algn="l">
+              <a:defRPr sz="1950" b="0">
+                <a:solidFill>
+                  <a:srgbClr val="172C31"/>
+                </a:solidFill>
+                <a:latin typeface="Arial"/>
+                <a:ea typeface="Arial"/>
+                <a:cs typeface="Arial"/>
+              </a:defRPr>
+            </a:pPr>
+            <a:r>
+              <a:rPr sz="1950" b="0">
+                <a:solidFill>
+                  <a:srgbClr val="172C31"/>
+                </a:solidFill>
+                <a:latin typeface="Arial"/>
+                <a:ea typeface="Arial"/>
+                <a:cs typeface="Arial"/>
+              </a:rPr>
+              <a:t>A searchable note beside the PDF under the same paper.</a:t>
+            </a:r>
+          </a:p>
+          <a:p xmlns:a="http://schemas.openxmlformats.org/drawingml/2006/main">
+            <a:pPr algn="l">
+              <a:defRPr sz="1950" b="0">
+                <a:solidFill>
+                  <a:srgbClr val="172C31"/>
+                </a:solidFill>
+                <a:latin typeface="Arial"/>
+                <a:ea typeface="Arial"/>
+                <a:cs typeface="Arial"/>
+              </a:defRPr>
+            </a:pPr>
+            <a:r>
+              <a:rPr sz="1950" b="0">
+                <a:solidFill>
+                  <a:srgbClr val="172C31"/>
+                </a:solidFill>
+                <a:latin typeface="Arial"/>
+                <a:ea typeface="Arial"/>
+                <a:cs typeface="Arial"/>
+              </a:rPr>
+              <a:t>Its Markdown source link opens your editable file.</a:t>
+            </a:r>
+          </a:p>
+        </p:txBody>
+      </p:sp>
+      <p:sp>
+        <p:nvSpPr>
+          <p:cNvPr id="7" name="">
+            <a:extLst xmlns:a="http://schemas.openxmlformats.org/drawingml/2006/main">
+              <a:ext uri="{FF2B5EF4-FFF2-40B4-BE49-F238E27FC236}">
+                <a16:creationId xmlns:a16="http://schemas.microsoft.com/office/drawing/2014/main" id="{B78FD28F-9956-4019-B28A-37EC62EC7CF3}"/>
+              </a:ext>
+            </a:extLst>
+          </p:cNvPr>
+          <p:cNvSpPr>
+            <a:spLocks xmlns:a="http://schemas.openxmlformats.org/drawingml/2006/main" noGrp="1"/>
+          </p:cNvSpPr>
+          <p:nvPr/>
+        </p:nvSpPr>
+        <p:spPr>
+          <a:xfrm xmlns:a="http://schemas.openxmlformats.org/drawingml/2006/main">
+            <a:off x="609600" y="4438650"/>
+            <a:ext cx="2857500" cy="428625"/>
+          </a:xfrm>
+          <a:prstGeom xmlns:a="http://schemas.openxmlformats.org/drawingml/2006/main" prst="rect">
+            <a:avLst/>
+          </a:prstGeom>
+          <a:noFill xmlns:a="http://schemas.openxmlformats.org/drawingml/2006/main"/>
+          <a:ln xmlns:a="http://schemas.openxmlformats.org/drawingml/2006/main" w="0">
+            <a:noFill/>
+          </a:ln>
+        </p:spPr>
+        <p:txBody>
+          <a:bodyPr xmlns:a="http://schemas.openxmlformats.org/drawingml/2006/main" wrap="none" lIns="0" tIns="0" rIns="0" bIns="0" anchor="t">
+            <a:noAutofit/>
+          </a:bodyPr>
+          <a:lstStyle xmlns:a="http://schemas.openxmlformats.org/drawingml/2006/main"/>
+          <a:p xmlns:a="http://schemas.openxmlformats.org/drawingml/2006/main">
+            <a:pPr algn="l">
+              <a:defRPr sz="2250" b="1">
+                <a:solidFill>
+                  <a:srgbClr val="172C31"/>
+                </a:solidFill>
+                <a:latin typeface="Arial"/>
+                <a:ea typeface="Arial"/>
+                <a:cs typeface="Arial"/>
+              </a:defRPr>
+            </a:pPr>
+            <a:r>
+              <a:rPr sz="2250" b="1">
+                <a:solidFill>
+                  <a:srgbClr val="172C31"/>
+                </a:solidFill>
+                <a:latin typeface="Arial"/>
+                <a:ea typeface="Arial"/>
+                <a:cs typeface="Arial"/>
+              </a:rPr>
+              <a:t>Human review</a:t>
+            </a:r>
+          </a:p>
+        </p:txBody>
+      </p:sp>
+      <p:sp>
+        <p:nvSpPr>
+          <p:cNvPr id="8" name="">
+            <a:extLst xmlns:a="http://schemas.openxmlformats.org/drawingml/2006/main">
+              <a:ext uri="{FF2B5EF4-FFF2-40B4-BE49-F238E27FC236}">
+                <a16:creationId xmlns:a16="http://schemas.microsoft.com/office/drawing/2014/main" id="{12DB47B8-9BC7-4830-A4E0-4FE064302C11}"/>
+              </a:ext>
+            </a:extLst>
+          </p:cNvPr>
+          <p:cNvSpPr>
+            <a:spLocks xmlns:a="http://schemas.openxmlformats.org/drawingml/2006/main" noGrp="1"/>
+          </p:cNvSpPr>
+          <p:nvPr/>
+        </p:nvSpPr>
+        <p:spPr>
+          <a:xfrm xmlns:a="http://schemas.openxmlformats.org/drawingml/2006/main">
+            <a:off x="3667125" y="4438650"/>
+            <a:ext cx="7905750" cy="895350"/>
+          </a:xfrm>
+          <a:prstGeom xmlns:a="http://schemas.openxmlformats.org/drawingml/2006/main" prst="rect">
+            <a:avLst/>
+          </a:prstGeom>
+          <a:noFill xmlns:a="http://schemas.openxmlformats.org/drawingml/2006/main"/>
+          <a:ln xmlns:a="http://schemas.openxmlformats.org/drawingml/2006/main" w="0">
+            <a:noFill/>
+          </a:ln>
+        </p:spPr>
+        <p:txBody>
+          <a:bodyPr xmlns:a="http://schemas.openxmlformats.org/drawingml/2006/main" wrap="none" lIns="0" tIns="0" rIns="0" bIns="0" anchor="t">
+            <a:noAutofit/>
+          </a:bodyPr>
+          <a:lstStyle xmlns:a="http://schemas.openxmlformats.org/drawingml/2006/main"/>
+          <a:p xmlns:a="http://schemas.openxmlformats.org/drawingml/2006/main">
+            <a:pPr algn="l">
+              <a:defRPr sz="1950" b="0">
+                <a:solidFill>
+                  <a:srgbClr val="172C31"/>
+                </a:solidFill>
+                <a:latin typeface="Arial"/>
+                <a:ea typeface="Arial"/>
+                <a:cs typeface="Arial"/>
+              </a:defRPr>
+            </a:pPr>
+            <a:r>
+              <a:rPr sz="1950" b="0">
+                <a:solidFill>
+                  <a:srgbClr val="172C31"/>
+                </a:solidFill>
+                <a:latin typeface="Arial"/>
+                <a:ea typeface="Arial"/>
+                <a:cs typeface="Arial"/>
+              </a:rPr>
+              <a:t>Saved immediately as human_reviewed: false / reading:draft.</a:t>
+            </a:r>
+          </a:p>
+          <a:p xmlns:a="http://schemas.openxmlformats.org/drawingml/2006/main">
+            <a:pPr algn="l">
+              <a:defRPr sz="1950" b="0">
+                <a:solidFill>
+                  <a:srgbClr val="172C31"/>
+                </a:solidFill>
+                <a:latin typeface="Arial"/>
+                <a:ea typeface="Arial"/>
+                <a:cs typeface="Arial"/>
+              </a:defRPr>
+            </a:pPr>
+            <a:r>
+              <a:rPr sz="1950" b="0">
+                <a:solidFill>
+                  <a:srgbClr val="172C31"/>
+                </a:solidFill>
+                <a:latin typeface="Arial"/>
+                <a:ea typeface="Arial"/>
+                <a:cs typeface="Arial"/>
+              </a:rPr>
+              <a:t>Your explicit content approval changes it to reviewed.</a:t>
+            </a:r>
+          </a:p>
+        </p:txBody>
+      </p:sp>
+      <p:sp>
+        <p:nvSpPr>
+          <p:cNvPr id="9" name="">
+            <a:extLst xmlns:a="http://schemas.openxmlformats.org/drawingml/2006/main">
+              <a:ext uri="{FF2B5EF4-FFF2-40B4-BE49-F238E27FC236}">
+                <a16:creationId xmlns:a16="http://schemas.microsoft.com/office/drawing/2014/main" id="{C69C8017-36B3-4950-8E55-24A21053192B}"/>
+              </a:ext>
+            </a:extLst>
+          </p:cNvPr>
+          <p:cNvSpPr>
+            <a:spLocks xmlns:a="http://schemas.openxmlformats.org/drawingml/2006/main" noGrp="1"/>
+          </p:cNvSpPr>
+          <p:nvPr/>
+        </p:nvSpPr>
+        <p:spPr>
+          <a:xfrm xmlns:a="http://schemas.openxmlformats.org/drawingml/2006/main">
+            <a:off x="609600" y="5981700"/>
+            <a:ext cx="10972800" cy="342900"/>
+          </a:xfrm>
+          <a:prstGeom xmlns:a="http://schemas.openxmlformats.org/drawingml/2006/main" prst="rect">
+            <a:avLst/>
+          </a:prstGeom>
+          <a:noFill xmlns:a="http://schemas.openxmlformats.org/drawingml/2006/main"/>
+          <a:ln xmlns:a="http://schemas.openxmlformats.org/drawingml/2006/main" w="0">
+            <a:noFill/>
+          </a:ln>
+        </p:spPr>
+        <p:txBody>
+          <a:bodyPr xmlns:a="http://schemas.openxmlformats.org/drawingml/2006/main" wrap="none" lIns="0" tIns="0" rIns="0" bIns="0" anchor="t">
+            <a:noAutofit/>
+          </a:bodyPr>
+          <a:lstStyle xmlns:a="http://schemas.openxmlformats.org/drawingml/2006/main"/>
+          <a:p xmlns:a="http://schemas.openxmlformats.org/drawingml/2006/main">
+            <a:pPr algn="l">
+              <a:defRPr sz="1800" b="0">
+                <a:solidFill>
+                  <a:srgbClr val="536166"/>
+                </a:solidFill>
+                <a:latin typeface="Arial"/>
+                <a:ea typeface="Arial"/>
+                <a:cs typeface="Arial"/>
+              </a:defRPr>
+            </a:pPr>
+            <a:r>
+              <a:rPr sz="1800" b="0">
+                <a:solidFill>
+                  <a:srgbClr val="536166"/>
+                </a:solidFill>
+                <a:latin typeface="Arial"/>
+                <a:ea typeface="Arial"/>
+                <a:cs typeface="Arial"/>
+              </a:rPr>
+              <a:t>An agent revision returns the note to draft. Zotero’s Allow button grants write access.</a:t>
+            </a:r>
+          </a:p>
+        </p:txBody>
+      </p:sp>
+    </p:spTree>
+    <p:extLst>
+      <p:ext uri="{BB962C8B-B14F-4D97-AF65-F5344CB8AC3E}">
+        <p14:creationId xmlns:p14="http://schemas.microsoft.com/office/powerpoint/2010/main" val="1917377992"/>
       </p:ext>
     </p:extLst>
   </p:cSld>

</xml_diff>